<commit_message>
Refresh deck charts and add product slide
Regenerate data/charts and add a 'The Product' slide with a device hero
image; deck is now 12 slides. Pairs with the upgraded interactive 3D model.

Co-Authored-By: Claude Opus 4.8 <noreply@anthropic.com>
Claude-Session: https://claude.ai/code/session_01CxrUMy4UZKTNYh6kiz9919
</commit_message>
<xml_diff>
--- a/science-fair/night-signal/Night_Signal_Presentation.pptx
+++ b/science-fair/night-signal/Night_Signal_Presentation.pptx
@@ -16,9 +16,10 @@
     <p:sldId id="264" r:id="rId10"/>
     <p:sldId id="265" r:id="rId11"/>
     <p:sldId id="266" r:id="rId12"/>
+    <p:sldId id="267" r:id="rId13"/>
   </p:sldIdLst>
   <p:notesMasterIdLst>
-    <p:notesMasterId r:id="rId13"/>
+    <p:notesMasterId r:id="rId14"/>
   </p:notesMasterIdLst>
   <p:sldSz cx="12191695" cy="6858000"/>
   <p:notesSz cx="6858000" cy="12191695"/>
@@ -712,6 +713,94 @@
             <a:fld id="{F7021451-1387-4CA6-816F-3879F97B5CBC}" type="slidenum">
               <a:rPr lang="en-US"/>
               <a:t>11</a:t>
+            </a:fld>
+            <a:endParaRPr lang="en-US"/>
+          </a:p>
+        </p:txBody>
+      </p:sp>
+    </p:spTree>
+    <p:extLst>
+      <p:ext uri="{BB962C8B-B14F-4D97-AF65-F5344CB8AC3E}">
+        <p14:creationId xmlns:p14="http://schemas.microsoft.com/office/powerpoint/2010/main" val="1024086991"/>
+      </p:ext>
+    </p:extLst>
+  </p:cSld>
+  <p:clrMapOvr>
+    <a:masterClrMapping/>
+  </p:clrMapOvr>
+</p:notes>
+</file>
+
+<file path=ppt/notesSlides/notesSlide12.xml><?xml version="1.0" encoding="utf-8"?>
+<p:notes xmlns:a="http://schemas.openxmlformats.org/drawingml/2006/main" xmlns:r="http://schemas.openxmlformats.org/officeDocument/2006/relationships" xmlns:p="http://schemas.openxmlformats.org/presentationml/2006/main">
+  <p:cSld>
+    <p:spTree>
+      <p:nvGrpSpPr>
+        <p:cNvPr id="1" name=""/>
+        <p:cNvGrpSpPr/>
+        <p:nvPr/>
+      </p:nvGrpSpPr>
+      <p:grpSpPr>
+        <a:xfrm>
+          <a:off x="0" y="0"/>
+          <a:ext cx="0" cy="0"/>
+          <a:chOff x="0" y="0"/>
+          <a:chExt cx="0" cy="0"/>
+        </a:xfrm>
+      </p:grpSpPr>
+      <p:sp>
+        <p:nvSpPr>
+          <p:cNvPr id="2" name="Slide Image Placeholder 1"/>
+          <p:cNvSpPr>
+            <a:spLocks noGrp="1" noRot="1" noChangeAspect="1"/>
+          </p:cNvSpPr>
+          <p:nvPr>
+            <p:ph type="sldImg"/>
+          </p:nvPr>
+        </p:nvSpPr>
+        <p:spPr/>
+      </p:sp>
+      <p:sp>
+        <p:nvSpPr>
+          <p:cNvPr id="3" name="Notes Placeholder 2"/>
+          <p:cNvSpPr>
+            <a:spLocks noGrp="1"/>
+          </p:cNvSpPr>
+          <p:nvPr>
+            <p:ph type="body" idx="1"/>
+          </p:nvPr>
+        </p:nvSpPr>
+        <p:spPr/>
+        <p:txBody>
+          <a:bodyPr/>
+          <a:lstStyle/>
+          <a:p>
+            <a:r>
+              <a:rPr lang="en-US" dirty="0"/>
+              <a:t/>
+            </a:r>
+            <a:endParaRPr lang="en-US" dirty="0"/>
+          </a:p>
+        </p:txBody>
+      </p:sp>
+      <p:sp>
+        <p:nvSpPr>
+          <p:cNvPr id="4" name="Slide Number Placeholder 3"/>
+          <p:cNvSpPr>
+            <a:spLocks noGrp="1"/>
+          </p:cNvSpPr>
+          <p:nvPr>
+            <p:ph type="sldNum" sz="quarter" idx="10"/>
+          </p:nvPr>
+        </p:nvSpPr>
+        <p:spPr/>
+        <p:txBody>
+          <a:bodyPr/>
+          <a:lstStyle/>
+          <a:p>
+            <a:fld id="{F7021451-1387-4CA6-816F-3879F97B5CBC}" type="slidenum">
+              <a:rPr lang="en-US"/>
+              <a:t>12</a:t>
             </a:fld>
             <a:endParaRPr lang="en-US"/>
           </a:p>
@@ -1991,6 +2080,492 @@
     <p:bg>
       <p:bgPr>
         <a:solidFill>
+          <a:srgbClr val="0E1830"/>
+        </a:solidFill>
+      </p:bgPr>
+    </p:bg>
+    <p:spTree>
+      <p:nvGrpSpPr>
+        <p:cNvPr id="1" name=""/>
+        <p:cNvGrpSpPr/>
+        <p:nvPr/>
+      </p:nvGrpSpPr>
+      <p:grpSpPr>
+        <a:xfrm>
+          <a:off x="0" y="0"/>
+          <a:ext cx="0" cy="0"/>
+          <a:chOff x="0" y="0"/>
+          <a:chExt cx="0" cy="0"/>
+        </a:xfrm>
+      </p:grpSpPr>
+      <p:sp>
+        <p:nvSpPr>
+          <p:cNvPr id="2" name="Text 0"/>
+          <p:cNvSpPr txBox="1"/>
+          <p:nvPr/>
+        </p:nvSpPr>
+        <p:spPr>
+          <a:xfrm>
+            <a:off x="640080" y="457200"/>
+            <a:ext cx="10881360" cy="274320"/>
+          </a:xfrm>
+          <a:prstGeom prst="rect">
+            <a:avLst/>
+          </a:prstGeom>
+          <a:noFill/>
+          <a:ln/>
+        </p:spPr>
+        <p:txBody>
+          <a:bodyPr wrap="square" lIns="0" tIns="0" rIns="0" bIns="0" rtlCol="0" anchor="ctr"/>
+          <a:lstStyle/>
+          <a:p>
+            <a:pPr indent="0" marL="0">
+              <a:buNone/>
+            </a:pPr>
+            <a:r>
+              <a:rPr lang="en-US" sz="1200" b="1" spc="300" kern="0" dirty="0">
+                <a:solidFill>
+                  <a:srgbClr val="3FB8CC"/>
+                </a:solidFill>
+                <a:latin typeface="Calibri" pitchFamily="34" charset="0"/>
+                <a:ea typeface="Calibri" pitchFamily="34" charset="-122"/>
+                <a:cs typeface="Calibri" pitchFamily="34" charset="-120"/>
+              </a:rPr>
+              <a:t>CONCLUSION</a:t>
+            </a:r>
+            <a:endParaRPr lang="en-US" sz="1200" dirty="0"/>
+          </a:p>
+        </p:txBody>
+      </p:sp>
+      <p:sp>
+        <p:nvSpPr>
+          <p:cNvPr id="3" name="Text 1"/>
+          <p:cNvSpPr txBox="1"/>
+          <p:nvPr/>
+        </p:nvSpPr>
+        <p:spPr>
+          <a:xfrm>
+            <a:off x="640080" y="822960"/>
+            <a:ext cx="10881360" cy="914400"/>
+          </a:xfrm>
+          <a:prstGeom prst="rect">
+            <a:avLst/>
+          </a:prstGeom>
+          <a:noFill/>
+          <a:ln/>
+        </p:spPr>
+        <p:txBody>
+          <a:bodyPr wrap="square" lIns="0" tIns="0" rIns="0" bIns="0" rtlCol="0" anchor="ctr"/>
+          <a:lstStyle/>
+          <a:p>
+            <a:pPr indent="0" marL="0">
+              <a:lnSpc>
+                <a:spcPts val="3400"/>
+              </a:lnSpc>
+              <a:buNone/>
+            </a:pPr>
+            <a:r>
+              <a:rPr lang="en-US" sz="3000" b="1" dirty="0">
+                <a:solidFill>
+                  <a:srgbClr val="FFFFFF"/>
+                </a:solidFill>
+                <a:latin typeface="Calibri" pitchFamily="34" charset="0"/>
+                <a:ea typeface="Calibri" pitchFamily="34" charset="-122"/>
+                <a:cs typeface="Calibri" pitchFamily="34" charset="-120"/>
+              </a:rPr>
+              <a:t>Back to the hypothesis</a:t>
+            </a:r>
+            <a:endParaRPr lang="en-US" sz="3000" dirty="0"/>
+          </a:p>
+        </p:txBody>
+      </p:sp>
+      <p:sp>
+        <p:nvSpPr>
+          <p:cNvPr id="4" name="Shape 2"/>
+          <p:cNvSpPr/>
+          <p:nvPr/>
+        </p:nvSpPr>
+        <p:spPr>
+          <a:xfrm>
+            <a:off x="640080" y="1828800"/>
+            <a:ext cx="10881360" cy="1280160"/>
+          </a:xfrm>
+          <a:prstGeom prst="roundRect">
+            <a:avLst>
+              <a:gd name="adj" fmla="val 7143"/>
+            </a:avLst>
+          </a:prstGeom>
+          <a:solidFill>
+            <a:srgbClr val="18233F"/>
+          </a:solidFill>
+          <a:ln w="12700">
+            <a:solidFill>
+              <a:srgbClr val="1F8A9C"/>
+            </a:solidFill>
+            <a:prstDash val="solid"/>
+          </a:ln>
+        </p:spPr>
+      </p:sp>
+      <p:sp>
+        <p:nvSpPr>
+          <p:cNvPr id="5" name="Text 3"/>
+          <p:cNvSpPr txBox="1"/>
+          <p:nvPr/>
+        </p:nvSpPr>
+        <p:spPr>
+          <a:xfrm>
+            <a:off x="914400" y="2011680"/>
+            <a:ext cx="10332720" cy="1005840"/>
+          </a:xfrm>
+          <a:prstGeom prst="rect">
+            <a:avLst/>
+          </a:prstGeom>
+          <a:noFill/>
+          <a:ln/>
+        </p:spPr>
+        <p:txBody>
+          <a:bodyPr wrap="square" lIns="0" tIns="0" rIns="0" bIns="0" rtlCol="0" anchor="ctr"/>
+          <a:lstStyle/>
+          <a:p>
+            <a:pPr indent="0" marL="0">
+              <a:lnSpc>
+                <a:spcPts val="2300"/>
+              </a:lnSpc>
+              <a:buNone/>
+            </a:pPr>
+            <a:r>
+              <a:rPr lang="en-US" sz="1600" b="1" dirty="0">
+                <a:solidFill>
+                  <a:srgbClr val="3FB8CC"/>
+                </a:solidFill>
+                <a:latin typeface="Calibri" pitchFamily="34" charset="0"/>
+                <a:ea typeface="Calibri" pitchFamily="34" charset="-122"/>
+                <a:cs typeface="Calibri" pitchFamily="34" charset="-120"/>
+              </a:rPr>
+              <a:t>Hypothesis supported. </a:t>
+            </a:r>
+            <a:pPr indent="0" marL="0">
+              <a:lnSpc>
+                <a:spcPts val="2300"/>
+              </a:lnSpc>
+              <a:buNone/>
+            </a:pPr>
+            <a:r>
+              <a:rPr lang="en-US" sz="1600" dirty="0">
+                <a:solidFill>
+                  <a:srgbClr val="FFFFFF"/>
+                </a:solidFill>
+                <a:latin typeface="Calibri" pitchFamily="34" charset="0"/>
+                <a:ea typeface="Calibri" pitchFamily="34" charset="-122"/>
+                <a:cs typeface="Calibri" pitchFamily="34" charset="-120"/>
+              </a:rPr>
+              <a:t>A $35 wearable detected apnea’s oxygen drops, agreed closely with a medical oximeter, estimated an AHI severity, and revealed that back-sleeping caused more events.</a:t>
+            </a:r>
+            <a:endParaRPr lang="en-US" sz="1600" dirty="0"/>
+          </a:p>
+        </p:txBody>
+      </p:sp>
+      <p:sp>
+        <p:nvSpPr>
+          <p:cNvPr id="6" name="Text 4"/>
+          <p:cNvSpPr txBox="1"/>
+          <p:nvPr/>
+        </p:nvSpPr>
+        <p:spPr>
+          <a:xfrm>
+            <a:off x="640080" y="3474720"/>
+            <a:ext cx="10058400" cy="365760"/>
+          </a:xfrm>
+          <a:prstGeom prst="rect">
+            <a:avLst/>
+          </a:prstGeom>
+          <a:noFill/>
+          <a:ln/>
+        </p:spPr>
+        <p:txBody>
+          <a:bodyPr wrap="square" lIns="0" tIns="0" rIns="0" bIns="0" rtlCol="0" anchor="ctr"/>
+          <a:lstStyle/>
+          <a:p>
+            <a:pPr indent="0" marL="0">
+              <a:buNone/>
+            </a:pPr>
+            <a:r>
+              <a:rPr lang="en-US" sz="1600" b="1" dirty="0">
+                <a:solidFill>
+                  <a:srgbClr val="E4568A"/>
+                </a:solidFill>
+                <a:latin typeface="Calibri" pitchFamily="34" charset="0"/>
+                <a:ea typeface="Calibri" pitchFamily="34" charset="-122"/>
+                <a:cs typeface="Calibri" pitchFamily="34" charset="-120"/>
+              </a:rPr>
+              <a:t>Further considerations &amp; improvements</a:t>
+            </a:r>
+            <a:endParaRPr lang="en-US" sz="1600" dirty="0"/>
+          </a:p>
+        </p:txBody>
+      </p:sp>
+      <p:sp>
+        <p:nvSpPr>
+          <p:cNvPr id="7" name="Shape 5"/>
+          <p:cNvSpPr/>
+          <p:nvPr/>
+        </p:nvSpPr>
+        <p:spPr>
+          <a:xfrm>
+            <a:off x="640080" y="3995928"/>
+            <a:ext cx="128016" cy="128016"/>
+          </a:xfrm>
+          <a:prstGeom prst="ellipse">
+            <a:avLst/>
+          </a:prstGeom>
+          <a:solidFill>
+            <a:srgbClr val="1F8A9C"/>
+          </a:solidFill>
+          <a:ln/>
+        </p:spPr>
+      </p:sp>
+      <p:sp>
+        <p:nvSpPr>
+          <p:cNvPr id="8" name="Text 6"/>
+          <p:cNvSpPr txBox="1"/>
+          <p:nvPr/>
+        </p:nvSpPr>
+        <p:spPr>
+          <a:xfrm>
+            <a:off x="932688" y="3904488"/>
+            <a:ext cx="10314432" cy="731520"/>
+          </a:xfrm>
+          <a:prstGeom prst="rect">
+            <a:avLst/>
+          </a:prstGeom>
+          <a:noFill/>
+          <a:ln/>
+        </p:spPr>
+        <p:txBody>
+          <a:bodyPr wrap="square" lIns="0" tIns="0" rIns="0" bIns="0" rtlCol="0" anchor="ctr"/>
+          <a:lstStyle/>
+          <a:p>
+            <a:pPr indent="0" marL="0">
+              <a:lnSpc>
+                <a:spcPts val="1900"/>
+              </a:lnSpc>
+              <a:buNone/>
+            </a:pPr>
+            <a:r>
+              <a:rPr lang="en-US" sz="1400" dirty="0">
+                <a:solidFill>
+                  <a:srgbClr val="9FB0CF"/>
+                </a:solidFill>
+                <a:latin typeface="Calibri" pitchFamily="34" charset="0"/>
+                <a:ea typeface="Calibri" pitchFamily="34" charset="-122"/>
+                <a:cs typeface="Calibri" pitchFamily="34" charset="-120"/>
+              </a:rPr>
+              <a:t>Test more people, for more full nights, to strengthen the data.</a:t>
+            </a:r>
+            <a:endParaRPr lang="en-US" sz="1400" dirty="0"/>
+          </a:p>
+        </p:txBody>
+      </p:sp>
+      <p:sp>
+        <p:nvSpPr>
+          <p:cNvPr id="9" name="Shape 7"/>
+          <p:cNvSpPr/>
+          <p:nvPr/>
+        </p:nvSpPr>
+        <p:spPr>
+          <a:xfrm>
+            <a:off x="640080" y="4864608"/>
+            <a:ext cx="128016" cy="128016"/>
+          </a:xfrm>
+          <a:prstGeom prst="ellipse">
+            <a:avLst/>
+          </a:prstGeom>
+          <a:solidFill>
+            <a:srgbClr val="1F8A9C"/>
+          </a:solidFill>
+          <a:ln/>
+        </p:spPr>
+      </p:sp>
+      <p:sp>
+        <p:nvSpPr>
+          <p:cNvPr id="10" name="Text 8"/>
+          <p:cNvSpPr txBox="1"/>
+          <p:nvPr/>
+        </p:nvSpPr>
+        <p:spPr>
+          <a:xfrm>
+            <a:off x="932688" y="4773168"/>
+            <a:ext cx="10314432" cy="731520"/>
+          </a:xfrm>
+          <a:prstGeom prst="rect">
+            <a:avLst/>
+          </a:prstGeom>
+          <a:noFill/>
+          <a:ln/>
+        </p:spPr>
+        <p:txBody>
+          <a:bodyPr wrap="square" lIns="0" tIns="0" rIns="0" bIns="0" rtlCol="0" anchor="ctr"/>
+          <a:lstStyle/>
+          <a:p>
+            <a:pPr indent="0" marL="0">
+              <a:lnSpc>
+                <a:spcPts val="1900"/>
+              </a:lnSpc>
+              <a:buNone/>
+            </a:pPr>
+            <a:r>
+              <a:rPr lang="en-US" sz="1400" dirty="0">
+                <a:solidFill>
+                  <a:srgbClr val="9FB0CF"/>
+                </a:solidFill>
+                <a:latin typeface="Calibri" pitchFamily="34" charset="0"/>
+                <a:ea typeface="Calibri" pitchFamily="34" charset="-122"/>
+                <a:cs typeface="Calibri" pitchFamily="34" charset="-120"/>
+              </a:rPr>
+              <a:t>Switch to Bluetooth Low Energy for a live phone app.</a:t>
+            </a:r>
+            <a:endParaRPr lang="en-US" sz="1400" dirty="0"/>
+          </a:p>
+        </p:txBody>
+      </p:sp>
+      <p:sp>
+        <p:nvSpPr>
+          <p:cNvPr id="11" name="Shape 9"/>
+          <p:cNvSpPr/>
+          <p:nvPr/>
+        </p:nvSpPr>
+        <p:spPr>
+          <a:xfrm>
+            <a:off x="640080" y="5431536"/>
+            <a:ext cx="128016" cy="128016"/>
+          </a:xfrm>
+          <a:prstGeom prst="ellipse">
+            <a:avLst/>
+          </a:prstGeom>
+          <a:solidFill>
+            <a:srgbClr val="1F8A9C"/>
+          </a:solidFill>
+          <a:ln/>
+        </p:spPr>
+      </p:sp>
+      <p:sp>
+        <p:nvSpPr>
+          <p:cNvPr id="12" name="Text 10"/>
+          <p:cNvSpPr txBox="1"/>
+          <p:nvPr/>
+        </p:nvSpPr>
+        <p:spPr>
+          <a:xfrm>
+            <a:off x="932688" y="5340096"/>
+            <a:ext cx="10314432" cy="731520"/>
+          </a:xfrm>
+          <a:prstGeom prst="rect">
+            <a:avLst/>
+          </a:prstGeom>
+          <a:noFill/>
+          <a:ln/>
+        </p:spPr>
+        <p:txBody>
+          <a:bodyPr wrap="square" lIns="0" tIns="0" rIns="0" bIns="0" rtlCol="0" anchor="ctr"/>
+          <a:lstStyle/>
+          <a:p>
+            <a:pPr indent="0" marL="0">
+              <a:lnSpc>
+                <a:spcPts val="1900"/>
+              </a:lnSpc>
+              <a:buNone/>
+            </a:pPr>
+            <a:r>
+              <a:rPr lang="en-US" sz="1400" dirty="0">
+                <a:solidFill>
+                  <a:srgbClr val="9FB0CF"/>
+                </a:solidFill>
+                <a:latin typeface="Calibri" pitchFamily="34" charset="0"/>
+                <a:ea typeface="Calibri" pitchFamily="34" charset="-122"/>
+                <a:cs typeface="Calibri" pitchFamily="34" charset="-120"/>
+              </a:rPr>
+              <a:t>Shrink the device into a comfortable finger-ring form.</a:t>
+            </a:r>
+            <a:endParaRPr lang="en-US" sz="1400" dirty="0"/>
+          </a:p>
+        </p:txBody>
+      </p:sp>
+      <p:sp>
+        <p:nvSpPr>
+          <p:cNvPr id="13" name="Shape 11"/>
+          <p:cNvSpPr/>
+          <p:nvPr/>
+        </p:nvSpPr>
+        <p:spPr>
+          <a:xfrm>
+            <a:off x="640080" y="5998464"/>
+            <a:ext cx="128016" cy="128016"/>
+          </a:xfrm>
+          <a:prstGeom prst="ellipse">
+            <a:avLst/>
+          </a:prstGeom>
+          <a:solidFill>
+            <a:srgbClr val="1F8A9C"/>
+          </a:solidFill>
+          <a:ln/>
+        </p:spPr>
+      </p:sp>
+      <p:sp>
+        <p:nvSpPr>
+          <p:cNvPr id="14" name="Text 12"/>
+          <p:cNvSpPr txBox="1"/>
+          <p:nvPr/>
+        </p:nvSpPr>
+        <p:spPr>
+          <a:xfrm>
+            <a:off x="932688" y="5907024"/>
+            <a:ext cx="10314432" cy="731520"/>
+          </a:xfrm>
+          <a:prstGeom prst="rect">
+            <a:avLst/>
+          </a:prstGeom>
+          <a:noFill/>
+          <a:ln/>
+        </p:spPr>
+        <p:txBody>
+          <a:bodyPr wrap="square" lIns="0" tIns="0" rIns="0" bIns="0" rtlCol="0" anchor="ctr"/>
+          <a:lstStyle/>
+          <a:p>
+            <a:pPr indent="0" marL="0">
+              <a:lnSpc>
+                <a:spcPts val="1900"/>
+              </a:lnSpc>
+              <a:buNone/>
+            </a:pPr>
+            <a:r>
+              <a:rPr lang="en-US" sz="1400" dirty="0">
+                <a:solidFill>
+                  <a:srgbClr val="9FB0CF"/>
+                </a:solidFill>
+                <a:latin typeface="Calibri" pitchFamily="34" charset="0"/>
+                <a:ea typeface="Calibri" pitchFamily="34" charset="-122"/>
+                <a:cs typeface="Calibri" pitchFamily="34" charset="-120"/>
+              </a:rPr>
+              <a:t>Compare results directly against a real clinical sleep study.</a:t>
+            </a:r>
+            <a:endParaRPr lang="en-US" sz="1400" dirty="0"/>
+          </a:p>
+        </p:txBody>
+      </p:sp>
+    </p:spTree>
+  </p:cSld>
+  <p:clrMapOvr>
+    <a:masterClrMapping/>
+  </p:clrMapOvr>
+</p:sld>
+</file>
+
+<file path=ppt/slides/slide11.xml><?xml version="1.0" encoding="utf-8"?>
+<p:sld xmlns:a="http://schemas.openxmlformats.org/drawingml/2006/main" xmlns:r="http://schemas.openxmlformats.org/officeDocument/2006/relationships" xmlns:p="http://schemas.openxmlformats.org/presentationml/2006/main">
+  <p:cSld name="Slide 11">
+    <p:bg>
+      <p:bgPr>
+        <a:solidFill>
           <a:srgbClr val="FFFFFF"/>
         </a:solidFill>
       </p:bgPr>
@@ -2092,7 +2667,7 @@
       </p:sp>
       <p:graphicFrame>
         <p:nvGraphicFramePr>
-          <p:cNvPr id="11" name="Table 0"/>
+          <p:cNvPr id="12" name="Table 0"/>
           <p:cNvGraphicFramePr>
             <a:graphicFrameLocks noGrp="1"/>
           </p:cNvGraphicFramePr>
@@ -3601,9 +4176,9 @@
 </p:sld>
 </file>
 
-<file path=ppt/slides/slide11.xml><?xml version="1.0" encoding="utf-8"?>
+<file path=ppt/slides/slide12.xml><?xml version="1.0" encoding="utf-8"?>
 <p:sld xmlns:a="http://schemas.openxmlformats.org/drawingml/2006/main" xmlns:r="http://schemas.openxmlformats.org/officeDocument/2006/relationships" xmlns:p="http://schemas.openxmlformats.org/presentationml/2006/main">
-  <p:cSld name="Slide 11">
+  <p:cSld name="Slide 12">
     <p:bg>
       <p:bgPr>
         <a:solidFill>
@@ -5721,6 +6296,477 @@
     <p:bg>
       <p:bgPr>
         <a:solidFill>
+          <a:srgbClr val="0E1830"/>
+        </a:solidFill>
+      </p:bgPr>
+    </p:bg>
+    <p:spTree>
+      <p:nvGrpSpPr>
+        <p:cNvPr id="1" name=""/>
+        <p:cNvGrpSpPr/>
+        <p:nvPr/>
+      </p:nvGrpSpPr>
+      <p:grpSpPr>
+        <a:xfrm>
+          <a:off x="0" y="0"/>
+          <a:ext cx="0" cy="0"/>
+          <a:chOff x="0" y="0"/>
+          <a:chExt cx="0" cy="0"/>
+        </a:xfrm>
+      </p:grpSpPr>
+      <p:sp>
+        <p:nvSpPr>
+          <p:cNvPr id="2" name="Text 0"/>
+          <p:cNvSpPr txBox="1"/>
+          <p:nvPr/>
+        </p:nvSpPr>
+        <p:spPr>
+          <a:xfrm>
+            <a:off x="640080" y="457200"/>
+            <a:ext cx="10881360" cy="274320"/>
+          </a:xfrm>
+          <a:prstGeom prst="rect">
+            <a:avLst/>
+          </a:prstGeom>
+          <a:noFill/>
+          <a:ln/>
+        </p:spPr>
+        <p:txBody>
+          <a:bodyPr wrap="square" lIns="0" tIns="0" rIns="0" bIns="0" rtlCol="0" anchor="ctr"/>
+          <a:lstStyle/>
+          <a:p>
+            <a:pPr indent="0" marL="0">
+              <a:buNone/>
+            </a:pPr>
+            <a:r>
+              <a:rPr lang="en-US" sz="1200" b="1" spc="300" kern="0" dirty="0">
+                <a:solidFill>
+                  <a:srgbClr val="3FB8CC"/>
+                </a:solidFill>
+                <a:latin typeface="Calibri" pitchFamily="34" charset="0"/>
+                <a:ea typeface="Calibri" pitchFamily="34" charset="-122"/>
+                <a:cs typeface="Calibri" pitchFamily="34" charset="-120"/>
+              </a:rPr>
+              <a:t>THE PRODUCT</a:t>
+            </a:r>
+            <a:endParaRPr lang="en-US" sz="1200" dirty="0"/>
+          </a:p>
+        </p:txBody>
+      </p:sp>
+      <p:sp>
+        <p:nvSpPr>
+          <p:cNvPr id="3" name="Text 1"/>
+          <p:cNvSpPr txBox="1"/>
+          <p:nvPr/>
+        </p:nvSpPr>
+        <p:spPr>
+          <a:xfrm>
+            <a:off x="640080" y="822960"/>
+            <a:ext cx="10881360" cy="914400"/>
+          </a:xfrm>
+          <a:prstGeom prst="rect">
+            <a:avLst/>
+          </a:prstGeom>
+          <a:noFill/>
+          <a:ln/>
+        </p:spPr>
+        <p:txBody>
+          <a:bodyPr wrap="square" lIns="0" tIns="0" rIns="0" bIns="0" rtlCol="0" anchor="ctr"/>
+          <a:lstStyle/>
+          <a:p>
+            <a:pPr indent="0" marL="0">
+              <a:lnSpc>
+                <a:spcPts val="3400"/>
+              </a:lnSpc>
+              <a:buNone/>
+            </a:pPr>
+            <a:r>
+              <a:rPr lang="en-US" sz="3000" b="1" dirty="0">
+                <a:solidFill>
+                  <a:srgbClr val="FFFFFF"/>
+                </a:solidFill>
+                <a:latin typeface="Calibri" pitchFamily="34" charset="0"/>
+                <a:ea typeface="Calibri" pitchFamily="34" charset="-122"/>
+                <a:cs typeface="Calibri" pitchFamily="34" charset="-120"/>
+              </a:rPr>
+              <a:t>What it looks like</a:t>
+            </a:r>
+            <a:endParaRPr lang="en-US" sz="3000" dirty="0"/>
+          </a:p>
+        </p:txBody>
+      </p:sp>
+      <p:pic>
+        <p:nvPicPr>
+          <p:cNvPr id="4" name="Image 0" descr="/tmp/product_hero.png">    </p:cNvPr>
+          <p:cNvPicPr>
+            <a:picLocks noChangeAspect="1"/>
+          </p:cNvPicPr>
+          <p:nvPr/>
+        </p:nvPicPr>
+        <p:blipFill>
+          <a:blip r:embed="rId1"/>
+          <a:stretch>
+            <a:fillRect/>
+          </a:stretch>
+        </p:blipFill>
+        <p:spPr>
+          <a:xfrm>
+            <a:off x="5760720" y="1554480"/>
+            <a:ext cx="5760720" cy="3960495"/>
+          </a:xfrm>
+          <a:prstGeom prst="rect">
+            <a:avLst/>
+          </a:prstGeom>
+        </p:spPr>
+      </p:pic>
+      <p:sp>
+        <p:nvSpPr>
+          <p:cNvPr id="5" name="Shape 2"/>
+          <p:cNvSpPr/>
+          <p:nvPr/>
+        </p:nvSpPr>
+        <p:spPr>
+          <a:xfrm>
+            <a:off x="640080" y="2075688"/>
+            <a:ext cx="128016" cy="128016"/>
+          </a:xfrm>
+          <a:prstGeom prst="ellipse">
+            <a:avLst/>
+          </a:prstGeom>
+          <a:solidFill>
+            <a:srgbClr val="1F8A9C"/>
+          </a:solidFill>
+          <a:ln/>
+        </p:spPr>
+      </p:sp>
+      <p:sp>
+        <p:nvSpPr>
+          <p:cNvPr id="6" name="Text 3"/>
+          <p:cNvSpPr txBox="1"/>
+          <p:nvPr/>
+        </p:nvSpPr>
+        <p:spPr>
+          <a:xfrm>
+            <a:off x="932688" y="1984248"/>
+            <a:ext cx="4553712" cy="731520"/>
+          </a:xfrm>
+          <a:prstGeom prst="rect">
+            <a:avLst/>
+          </a:prstGeom>
+          <a:noFill/>
+          <a:ln/>
+        </p:spPr>
+        <p:txBody>
+          <a:bodyPr wrap="square" lIns="0" tIns="0" rIns="0" bIns="0" rtlCol="0" anchor="ctr"/>
+          <a:lstStyle/>
+          <a:p>
+            <a:pPr indent="0" marL="0">
+              <a:lnSpc>
+                <a:spcPts val="1950"/>
+              </a:lnSpc>
+              <a:buNone/>
+            </a:pPr>
+            <a:r>
+              <a:rPr lang="en-US" sz="1450" dirty="0">
+                <a:solidFill>
+                  <a:srgbClr val="9FB0CF"/>
+                </a:solidFill>
+                <a:latin typeface="Calibri" pitchFamily="34" charset="0"/>
+                <a:ea typeface="Calibri" pitchFamily="34" charset="-122"/>
+                <a:cs typeface="Calibri" pitchFamily="34" charset="-120"/>
+              </a:rPr>
+              <a:t>Machined body with a glass screen showing your sleep report.</a:t>
+            </a:r>
+            <a:endParaRPr lang="en-US" sz="1450" dirty="0"/>
+          </a:p>
+        </p:txBody>
+      </p:sp>
+      <p:sp>
+        <p:nvSpPr>
+          <p:cNvPr id="7" name="Shape 4"/>
+          <p:cNvSpPr/>
+          <p:nvPr/>
+        </p:nvSpPr>
+        <p:spPr>
+          <a:xfrm>
+            <a:off x="640080" y="2642616"/>
+            <a:ext cx="128016" cy="128016"/>
+          </a:xfrm>
+          <a:prstGeom prst="ellipse">
+            <a:avLst/>
+          </a:prstGeom>
+          <a:solidFill>
+            <a:srgbClr val="1F8A9C"/>
+          </a:solidFill>
+          <a:ln/>
+        </p:spPr>
+      </p:sp>
+      <p:sp>
+        <p:nvSpPr>
+          <p:cNvPr id="8" name="Text 5"/>
+          <p:cNvSpPr txBox="1"/>
+          <p:nvPr/>
+        </p:nvSpPr>
+        <p:spPr>
+          <a:xfrm>
+            <a:off x="932688" y="2551176"/>
+            <a:ext cx="4553712" cy="731520"/>
+          </a:xfrm>
+          <a:prstGeom prst="rect">
+            <a:avLst/>
+          </a:prstGeom>
+          <a:noFill/>
+          <a:ln/>
+        </p:spPr>
+        <p:txBody>
+          <a:bodyPr wrap="square" lIns="0" tIns="0" rIns="0" bIns="0" rtlCol="0" anchor="ctr"/>
+          <a:lstStyle/>
+          <a:p>
+            <a:pPr indent="0" marL="0">
+              <a:lnSpc>
+                <a:spcPts val="1950"/>
+              </a:lnSpc>
+              <a:buNone/>
+            </a:pPr>
+            <a:r>
+              <a:rPr lang="en-US" sz="1450" dirty="0">
+                <a:solidFill>
+                  <a:srgbClr val="9FB0CF"/>
+                </a:solidFill>
+                <a:latin typeface="Calibri" pitchFamily="34" charset="0"/>
+                <a:ea typeface="Calibri" pitchFamily="34" charset="-122"/>
+                <a:cs typeface="Calibri" pitchFamily="34" charset="-120"/>
+              </a:rPr>
+              <a:t>Soft velcro band holds the processor, battery and Bluetooth.</a:t>
+            </a:r>
+            <a:endParaRPr lang="en-US" sz="1450" dirty="0"/>
+          </a:p>
+        </p:txBody>
+      </p:sp>
+      <p:sp>
+        <p:nvSpPr>
+          <p:cNvPr id="9" name="Shape 6"/>
+          <p:cNvSpPr/>
+          <p:nvPr/>
+        </p:nvSpPr>
+        <p:spPr>
+          <a:xfrm>
+            <a:off x="640080" y="3209544"/>
+            <a:ext cx="128016" cy="128016"/>
+          </a:xfrm>
+          <a:prstGeom prst="ellipse">
+            <a:avLst/>
+          </a:prstGeom>
+          <a:solidFill>
+            <a:srgbClr val="1F8A9C"/>
+          </a:solidFill>
+          <a:ln/>
+        </p:spPr>
+      </p:sp>
+      <p:sp>
+        <p:nvSpPr>
+          <p:cNvPr id="10" name="Text 7"/>
+          <p:cNvSpPr txBox="1"/>
+          <p:nvPr/>
+        </p:nvSpPr>
+        <p:spPr>
+          <a:xfrm>
+            <a:off x="932688" y="3118104"/>
+            <a:ext cx="4553712" cy="731520"/>
+          </a:xfrm>
+          <a:prstGeom prst="rect">
+            <a:avLst/>
+          </a:prstGeom>
+          <a:noFill/>
+          <a:ln/>
+        </p:spPr>
+        <p:txBody>
+          <a:bodyPr wrap="square" lIns="0" tIns="0" rIns="0" bIns="0" rtlCol="0" anchor="ctr"/>
+          <a:lstStyle/>
+          <a:p>
+            <a:pPr indent="0" marL="0">
+              <a:lnSpc>
+                <a:spcPts val="1950"/>
+              </a:lnSpc>
+              <a:buNone/>
+            </a:pPr>
+            <a:r>
+              <a:rPr lang="en-US" sz="1450" dirty="0">
+                <a:solidFill>
+                  <a:srgbClr val="9FB0CF"/>
+                </a:solidFill>
+                <a:latin typeface="Calibri" pitchFamily="34" charset="0"/>
+                <a:ea typeface="Calibri" pitchFamily="34" charset="-122"/>
+                <a:cs typeface="Calibri" pitchFamily="34" charset="-120"/>
+              </a:rPr>
+              <a:t>A fingertip sensor reads blood oxygen and pulse.</a:t>
+            </a:r>
+            <a:endParaRPr lang="en-US" sz="1450" dirty="0"/>
+          </a:p>
+        </p:txBody>
+      </p:sp>
+      <p:sp>
+        <p:nvSpPr>
+          <p:cNvPr id="11" name="Shape 8"/>
+          <p:cNvSpPr/>
+          <p:nvPr/>
+        </p:nvSpPr>
+        <p:spPr>
+          <a:xfrm>
+            <a:off x="640080" y="3776472"/>
+            <a:ext cx="128016" cy="128016"/>
+          </a:xfrm>
+          <a:prstGeom prst="ellipse">
+            <a:avLst/>
+          </a:prstGeom>
+          <a:solidFill>
+            <a:srgbClr val="1F8A9C"/>
+          </a:solidFill>
+          <a:ln/>
+        </p:spPr>
+      </p:sp>
+      <p:sp>
+        <p:nvSpPr>
+          <p:cNvPr id="12" name="Text 9"/>
+          <p:cNvSpPr txBox="1"/>
+          <p:nvPr/>
+        </p:nvSpPr>
+        <p:spPr>
+          <a:xfrm>
+            <a:off x="932688" y="3685032"/>
+            <a:ext cx="4553712" cy="731520"/>
+          </a:xfrm>
+          <a:prstGeom prst="rect">
+            <a:avLst/>
+          </a:prstGeom>
+          <a:noFill/>
+          <a:ln/>
+        </p:spPr>
+        <p:txBody>
+          <a:bodyPr wrap="square" lIns="0" tIns="0" rIns="0" bIns="0" rtlCol="0" anchor="ctr"/>
+          <a:lstStyle/>
+          <a:p>
+            <a:pPr indent="0" marL="0">
+              <a:lnSpc>
+                <a:spcPts val="1950"/>
+              </a:lnSpc>
+              <a:buNone/>
+            </a:pPr>
+            <a:r>
+              <a:rPr lang="en-US" sz="1450" dirty="0">
+                <a:solidFill>
+                  <a:srgbClr val="9FB0CF"/>
+                </a:solidFill>
+                <a:latin typeface="Calibri" pitchFamily="34" charset="0"/>
+                <a:ea typeface="Calibri" pitchFamily="34" charset="-122"/>
+                <a:cs typeface="Calibri" pitchFamily="34" charset="-120"/>
+              </a:rPr>
+              <a:t>Charges by USB and runs all night, cordless.</a:t>
+            </a:r>
+            <a:endParaRPr lang="en-US" sz="1450" dirty="0"/>
+          </a:p>
+        </p:txBody>
+      </p:sp>
+      <p:sp>
+        <p:nvSpPr>
+          <p:cNvPr id="13" name="Shape 10"/>
+          <p:cNvSpPr/>
+          <p:nvPr/>
+        </p:nvSpPr>
+        <p:spPr>
+          <a:xfrm>
+            <a:off x="640080" y="4937760"/>
+            <a:ext cx="4846320" cy="914400"/>
+          </a:xfrm>
+          <a:prstGeom prst="roundRect">
+            <a:avLst>
+              <a:gd name="adj" fmla="val 10000"/>
+            </a:avLst>
+          </a:prstGeom>
+          <a:solidFill>
+            <a:srgbClr val="18233F"/>
+          </a:solidFill>
+          <a:ln w="12700">
+            <a:solidFill>
+              <a:srgbClr val="1F8A9C"/>
+            </a:solidFill>
+            <a:prstDash val="solid"/>
+          </a:ln>
+        </p:spPr>
+      </p:sp>
+      <p:sp>
+        <p:nvSpPr>
+          <p:cNvPr id="14" name="Text 11"/>
+          <p:cNvSpPr txBox="1"/>
+          <p:nvPr/>
+        </p:nvSpPr>
+        <p:spPr>
+          <a:xfrm>
+            <a:off x="868680" y="5120640"/>
+            <a:ext cx="4480560" cy="640080"/>
+          </a:xfrm>
+          <a:prstGeom prst="rect">
+            <a:avLst/>
+          </a:prstGeom>
+          <a:noFill/>
+          <a:ln/>
+        </p:spPr>
+        <p:txBody>
+          <a:bodyPr wrap="square" lIns="0" tIns="0" rIns="0" bIns="0" rtlCol="0" anchor="ctr"/>
+          <a:lstStyle/>
+          <a:p>
+            <a:pPr indent="0" marL="0">
+              <a:lnSpc>
+                <a:spcPts val="1800"/>
+              </a:lnSpc>
+              <a:buNone/>
+            </a:pPr>
+            <a:r>
+              <a:rPr lang="en-US" sz="1300" b="1" dirty="0">
+                <a:solidFill>
+                  <a:srgbClr val="3FB8CC"/>
+                </a:solidFill>
+                <a:latin typeface="Calibri" pitchFamily="34" charset="0"/>
+                <a:ea typeface="Calibri" pitchFamily="34" charset="-122"/>
+                <a:cs typeface="Calibri" pitchFamily="34" charset="-120"/>
+              </a:rPr>
+              <a:t>Live demo:  </a:t>
+            </a:r>
+            <a:pPr indent="0" marL="0">
+              <a:lnSpc>
+                <a:spcPts val="1800"/>
+              </a:lnSpc>
+              <a:buNone/>
+            </a:pPr>
+            <a:r>
+              <a:rPr lang="en-US" sz="1300" dirty="0">
+                <a:solidFill>
+                  <a:srgbClr val="FFFFFF"/>
+                </a:solidFill>
+                <a:latin typeface="Calibri" pitchFamily="34" charset="0"/>
+                <a:ea typeface="Calibri" pitchFamily="34" charset="-122"/>
+                <a:cs typeface="Calibri" pitchFamily="34" charset="-120"/>
+              </a:rPr>
+              <a:t>an interactive 3D model can be spun around on screen at the fair.</a:t>
+            </a:r>
+            <a:endParaRPr lang="en-US" sz="1300" dirty="0"/>
+          </a:p>
+        </p:txBody>
+      </p:sp>
+    </p:spTree>
+  </p:cSld>
+  <p:clrMapOvr>
+    <a:masterClrMapping/>
+  </p:clrMapOvr>
+</p:sld>
+</file>
+
+<file path=ppt/slides/slide6.xml><?xml version="1.0" encoding="utf-8"?>
+<p:sld xmlns:a="http://schemas.openxmlformats.org/drawingml/2006/main" xmlns:r="http://schemas.openxmlformats.org/officeDocument/2006/relationships" xmlns:p="http://schemas.openxmlformats.org/presentationml/2006/main">
+  <p:cSld name="Slide 6">
+    <p:bg>
+      <p:bgPr>
+        <a:solidFill>
           <a:srgbClr val="FFFFFF"/>
         </a:solidFill>
       </p:bgPr>
@@ -5951,7 +6997,7 @@
       </p:sp>
       <p:graphicFrame>
         <p:nvGraphicFramePr>
-          <p:cNvPr id="6" name="Table 0"/>
+          <p:cNvPr id="7" name="Table 0"/>
           <p:cNvGraphicFramePr>
             <a:graphicFrameLocks noGrp="1"/>
           </p:cNvGraphicFramePr>
@@ -6785,9 +7831,9 @@
 </p:sld>
 </file>
 
-<file path=ppt/slides/slide6.xml><?xml version="1.0" encoding="utf-8"?>
+<file path=ppt/slides/slide7.xml><?xml version="1.0" encoding="utf-8"?>
 <p:sld xmlns:a="http://schemas.openxmlformats.org/drawingml/2006/main" xmlns:r="http://schemas.openxmlformats.org/officeDocument/2006/relationships" xmlns:p="http://schemas.openxmlformats.org/presentationml/2006/main">
-  <p:cSld name="Slide 6">
+  <p:cSld name="Slide 7">
     <p:bg>
       <p:bgPr>
         <a:solidFill>
@@ -7204,7 +8250,7 @@
       </p:sp>
       <p:graphicFrame>
         <p:nvGraphicFramePr>
-          <p:cNvPr id="7" name="Table 0"/>
+          <p:cNvPr id="8" name="Table 0"/>
           <p:cNvGraphicFramePr>
             <a:graphicFrameLocks noGrp="1"/>
           </p:cNvGraphicFramePr>
@@ -7901,9 +8947,9 @@
 </p:sld>
 </file>
 
-<file path=ppt/slides/slide7.xml><?xml version="1.0" encoding="utf-8"?>
+<file path=ppt/slides/slide8.xml><?xml version="1.0" encoding="utf-8"?>
 <p:sld xmlns:a="http://schemas.openxmlformats.org/drawingml/2006/main" xmlns:r="http://schemas.openxmlformats.org/officeDocument/2006/relationships" xmlns:p="http://schemas.openxmlformats.org/presentationml/2006/main">
-  <p:cSld name="Slide 7">
+  <p:cSld name="Slide 8">
     <p:bg>
       <p:bgPr>
         <a:solidFill>
@@ -8365,631 +9411,6 @@
               <a:t>a simple change — sleeping on your side — could reduce events.</a:t>
             </a:r>
             <a:endParaRPr lang="en-US" sz="1400" dirty="0"/>
-          </a:p>
-        </p:txBody>
-      </p:sp>
-    </p:spTree>
-  </p:cSld>
-  <p:clrMapOvr>
-    <a:masterClrMapping/>
-  </p:clrMapOvr>
-</p:sld>
-</file>
-
-<file path=ppt/slides/slide8.xml><?xml version="1.0" encoding="utf-8"?>
-<p:sld xmlns:a="http://schemas.openxmlformats.org/drawingml/2006/main" xmlns:r="http://schemas.openxmlformats.org/officeDocument/2006/relationships" xmlns:p="http://schemas.openxmlformats.org/presentationml/2006/main">
-  <p:cSld name="Slide 8">
-    <p:bg>
-      <p:bgPr>
-        <a:solidFill>
-          <a:srgbClr val="0E1830"/>
-        </a:solidFill>
-      </p:bgPr>
-    </p:bg>
-    <p:spTree>
-      <p:nvGrpSpPr>
-        <p:cNvPr id="1" name=""/>
-        <p:cNvGrpSpPr/>
-        <p:nvPr/>
-      </p:nvGrpSpPr>
-      <p:grpSpPr>
-        <a:xfrm>
-          <a:off x="0" y="0"/>
-          <a:ext cx="0" cy="0"/>
-          <a:chOff x="0" y="0"/>
-          <a:chExt cx="0" cy="0"/>
-        </a:xfrm>
-      </p:grpSpPr>
-      <p:sp>
-        <p:nvSpPr>
-          <p:cNvPr id="2" name="Text 0"/>
-          <p:cNvSpPr txBox="1"/>
-          <p:nvPr/>
-        </p:nvSpPr>
-        <p:spPr>
-          <a:xfrm>
-            <a:off x="640080" y="457200"/>
-            <a:ext cx="10881360" cy="274320"/>
-          </a:xfrm>
-          <a:prstGeom prst="rect">
-            <a:avLst/>
-          </a:prstGeom>
-          <a:noFill/>
-          <a:ln/>
-        </p:spPr>
-        <p:txBody>
-          <a:bodyPr wrap="square" lIns="0" tIns="0" rIns="0" bIns="0" rtlCol="0" anchor="ctr"/>
-          <a:lstStyle/>
-          <a:p>
-            <a:pPr indent="0" marL="0">
-              <a:buNone/>
-            </a:pPr>
-            <a:r>
-              <a:rPr lang="en-US" sz="1200" b="1" spc="300" kern="0" dirty="0">
-                <a:solidFill>
-                  <a:srgbClr val="3FB8CC"/>
-                </a:solidFill>
-                <a:latin typeface="Calibri" pitchFamily="34" charset="0"/>
-                <a:ea typeface="Calibri" pitchFamily="34" charset="-122"/>
-                <a:cs typeface="Calibri" pitchFamily="34" charset="-120"/>
-              </a:rPr>
-              <a:t>ANALYSIS</a:t>
-            </a:r>
-            <a:endParaRPr lang="en-US" sz="1200" dirty="0"/>
-          </a:p>
-        </p:txBody>
-      </p:sp>
-      <p:sp>
-        <p:nvSpPr>
-          <p:cNvPr id="3" name="Text 1"/>
-          <p:cNvSpPr txBox="1"/>
-          <p:nvPr/>
-        </p:nvSpPr>
-        <p:spPr>
-          <a:xfrm>
-            <a:off x="640080" y="822960"/>
-            <a:ext cx="10881360" cy="914400"/>
-          </a:xfrm>
-          <a:prstGeom prst="rect">
-            <a:avLst/>
-          </a:prstGeom>
-          <a:noFill/>
-          <a:ln/>
-        </p:spPr>
-        <p:txBody>
-          <a:bodyPr wrap="square" lIns="0" tIns="0" rIns="0" bIns="0" rtlCol="0" anchor="ctr"/>
-          <a:lstStyle/>
-          <a:p>
-            <a:pPr indent="0" marL="0">
-              <a:lnSpc>
-                <a:spcPts val="3400"/>
-              </a:lnSpc>
-              <a:buNone/>
-            </a:pPr>
-            <a:r>
-              <a:rPr lang="en-US" sz="3000" b="1" dirty="0">
-                <a:solidFill>
-                  <a:srgbClr val="FFFFFF"/>
-                </a:solidFill>
-                <a:latin typeface="Calibri" pitchFamily="34" charset="0"/>
-                <a:ea typeface="Calibri" pitchFamily="34" charset="-122"/>
-                <a:cs typeface="Calibri" pitchFamily="34" charset="-120"/>
-              </a:rPr>
-              <a:t>What the results mean</a:t>
-            </a:r>
-            <a:endParaRPr lang="en-US" sz="3000" dirty="0"/>
-          </a:p>
-        </p:txBody>
-      </p:sp>
-      <p:sp>
-        <p:nvSpPr>
-          <p:cNvPr id="4" name="Text 2"/>
-          <p:cNvSpPr txBox="1"/>
-          <p:nvPr/>
-        </p:nvSpPr>
-        <p:spPr>
-          <a:xfrm>
-            <a:off x="640080" y="1828800"/>
-            <a:ext cx="5120640" cy="365760"/>
-          </a:xfrm>
-          <a:prstGeom prst="rect">
-            <a:avLst/>
-          </a:prstGeom>
-          <a:noFill/>
-          <a:ln/>
-        </p:spPr>
-        <p:txBody>
-          <a:bodyPr wrap="square" lIns="0" tIns="0" rIns="0" bIns="0" rtlCol="0" anchor="ctr"/>
-          <a:lstStyle/>
-          <a:p>
-            <a:pPr indent="0" marL="0">
-              <a:buNone/>
-            </a:pPr>
-            <a:r>
-              <a:rPr lang="en-US" sz="1600" b="1" dirty="0">
-                <a:solidFill>
-                  <a:srgbClr val="3FB8CC"/>
-                </a:solidFill>
-                <a:latin typeface="Calibri" pitchFamily="34" charset="0"/>
-                <a:ea typeface="Calibri" pitchFamily="34" charset="-122"/>
-                <a:cs typeface="Calibri" pitchFamily="34" charset="-120"/>
-              </a:rPr>
-              <a:t>Interpretation</a:t>
-            </a:r>
-            <a:endParaRPr lang="en-US" sz="1600" dirty="0"/>
-          </a:p>
-        </p:txBody>
-      </p:sp>
-      <p:sp>
-        <p:nvSpPr>
-          <p:cNvPr id="5" name="Shape 3"/>
-          <p:cNvSpPr/>
-          <p:nvPr/>
-        </p:nvSpPr>
-        <p:spPr>
-          <a:xfrm>
-            <a:off x="640080" y="2350008"/>
-            <a:ext cx="128016" cy="128016"/>
-          </a:xfrm>
-          <a:prstGeom prst="ellipse">
-            <a:avLst/>
-          </a:prstGeom>
-          <a:solidFill>
-            <a:srgbClr val="1F8A9C"/>
-          </a:solidFill>
-          <a:ln/>
-        </p:spPr>
-      </p:sp>
-      <p:sp>
-        <p:nvSpPr>
-          <p:cNvPr id="6" name="Text 4"/>
-          <p:cNvSpPr txBox="1"/>
-          <p:nvPr/>
-        </p:nvSpPr>
-        <p:spPr>
-          <a:xfrm>
-            <a:off x="932688" y="2258568"/>
-            <a:ext cx="5010912" cy="731520"/>
-          </a:xfrm>
-          <a:prstGeom prst="rect">
-            <a:avLst/>
-          </a:prstGeom>
-          <a:noFill/>
-          <a:ln/>
-        </p:spPr>
-        <p:txBody>
-          <a:bodyPr wrap="square" lIns="0" tIns="0" rIns="0" bIns="0" rtlCol="0" anchor="ctr"/>
-          <a:lstStyle/>
-          <a:p>
-            <a:pPr indent="0" marL="0">
-              <a:lnSpc>
-                <a:spcPts val="1850"/>
-              </a:lnSpc>
-              <a:buNone/>
-            </a:pPr>
-            <a:r>
-              <a:rPr lang="en-US" sz="1350" dirty="0">
-                <a:solidFill>
-                  <a:srgbClr val="9FB0CF"/>
-                </a:solidFill>
-                <a:latin typeface="Calibri" pitchFamily="34" charset="0"/>
-                <a:ea typeface="Calibri" pitchFamily="34" charset="-122"/>
-                <a:cs typeface="Calibri" pitchFamily="34" charset="-120"/>
-              </a:rPr>
-              <a:t>The device agreed with a reference oximeter within ~0.6% — accurate enough to trust its readings.</a:t>
-            </a:r>
-            <a:endParaRPr lang="en-US" sz="1350" dirty="0"/>
-          </a:p>
-        </p:txBody>
-      </p:sp>
-      <p:sp>
-        <p:nvSpPr>
-          <p:cNvPr id="7" name="Shape 5"/>
-          <p:cNvSpPr/>
-          <p:nvPr/>
-        </p:nvSpPr>
-        <p:spPr>
-          <a:xfrm>
-            <a:off x="640080" y="3218688"/>
-            <a:ext cx="128016" cy="128016"/>
-          </a:xfrm>
-          <a:prstGeom prst="ellipse">
-            <a:avLst/>
-          </a:prstGeom>
-          <a:solidFill>
-            <a:srgbClr val="1F8A9C"/>
-          </a:solidFill>
-          <a:ln/>
-        </p:spPr>
-      </p:sp>
-      <p:sp>
-        <p:nvSpPr>
-          <p:cNvPr id="8" name="Text 6"/>
-          <p:cNvSpPr txBox="1"/>
-          <p:nvPr/>
-        </p:nvSpPr>
-        <p:spPr>
-          <a:xfrm>
-            <a:off x="932688" y="3127248"/>
-            <a:ext cx="5010912" cy="731520"/>
-          </a:xfrm>
-          <a:prstGeom prst="rect">
-            <a:avLst/>
-          </a:prstGeom>
-          <a:noFill/>
-          <a:ln/>
-        </p:spPr>
-        <p:txBody>
-          <a:bodyPr wrap="square" lIns="0" tIns="0" rIns="0" bIns="0" rtlCol="0" anchor="ctr"/>
-          <a:lstStyle/>
-          <a:p>
-            <a:pPr indent="0" marL="0">
-              <a:lnSpc>
-                <a:spcPts val="1850"/>
-              </a:lnSpc>
-              <a:buNone/>
-            </a:pPr>
-            <a:r>
-              <a:rPr lang="en-US" sz="1350" dirty="0">
-                <a:solidFill>
-                  <a:srgbClr val="9FB0CF"/>
-                </a:solidFill>
-                <a:latin typeface="Calibri" pitchFamily="34" charset="0"/>
-                <a:ea typeface="Calibri" pitchFamily="34" charset="-122"/>
-                <a:cs typeface="Calibri" pitchFamily="34" charset="-120"/>
-              </a:rPr>
-              <a:t>It reliably flagged the oxygen drops that mark apnea events.</a:t>
-            </a:r>
-            <a:endParaRPr lang="en-US" sz="1350" dirty="0"/>
-          </a:p>
-        </p:txBody>
-      </p:sp>
-      <p:sp>
-        <p:nvSpPr>
-          <p:cNvPr id="9" name="Shape 7"/>
-          <p:cNvSpPr/>
-          <p:nvPr/>
-        </p:nvSpPr>
-        <p:spPr>
-          <a:xfrm>
-            <a:off x="640080" y="3785616"/>
-            <a:ext cx="128016" cy="128016"/>
-          </a:xfrm>
-          <a:prstGeom prst="ellipse">
-            <a:avLst/>
-          </a:prstGeom>
-          <a:solidFill>
-            <a:srgbClr val="1F8A9C"/>
-          </a:solidFill>
-          <a:ln/>
-        </p:spPr>
-      </p:sp>
-      <p:sp>
-        <p:nvSpPr>
-          <p:cNvPr id="10" name="Text 8"/>
-          <p:cNvSpPr txBox="1"/>
-          <p:nvPr/>
-        </p:nvSpPr>
-        <p:spPr>
-          <a:xfrm>
-            <a:off x="932688" y="3694176"/>
-            <a:ext cx="5010912" cy="731520"/>
-          </a:xfrm>
-          <a:prstGeom prst="rect">
-            <a:avLst/>
-          </a:prstGeom>
-          <a:noFill/>
-          <a:ln/>
-        </p:spPr>
-        <p:txBody>
-          <a:bodyPr wrap="square" lIns="0" tIns="0" rIns="0" bIns="0" rtlCol="0" anchor="ctr"/>
-          <a:lstStyle/>
-          <a:p>
-            <a:pPr indent="0" marL="0">
-              <a:lnSpc>
-                <a:spcPts val="1850"/>
-              </a:lnSpc>
-              <a:buNone/>
-            </a:pPr>
-            <a:r>
-              <a:rPr lang="en-US" sz="1350" dirty="0">
-                <a:solidFill>
-                  <a:srgbClr val="9FB0CF"/>
-                </a:solidFill>
-                <a:latin typeface="Calibri" pitchFamily="34" charset="0"/>
-                <a:ea typeface="Calibri" pitchFamily="34" charset="-122"/>
-                <a:cs typeface="Calibri" pitchFamily="34" charset="-120"/>
-              </a:rPr>
-              <a:t>Back-sleeping produced the most events, matching medical literature.</a:t>
-            </a:r>
-            <a:endParaRPr lang="en-US" sz="1350" dirty="0"/>
-          </a:p>
-        </p:txBody>
-      </p:sp>
-      <p:sp>
-        <p:nvSpPr>
-          <p:cNvPr id="11" name="Text 9"/>
-          <p:cNvSpPr txBox="1"/>
-          <p:nvPr/>
-        </p:nvSpPr>
-        <p:spPr>
-          <a:xfrm>
-            <a:off x="6309360" y="1828800"/>
-            <a:ext cx="5120640" cy="365760"/>
-          </a:xfrm>
-          <a:prstGeom prst="rect">
-            <a:avLst/>
-          </a:prstGeom>
-          <a:noFill/>
-          <a:ln/>
-        </p:spPr>
-        <p:txBody>
-          <a:bodyPr wrap="square" lIns="0" tIns="0" rIns="0" bIns="0" rtlCol="0" anchor="ctr"/>
-          <a:lstStyle/>
-          <a:p>
-            <a:pPr indent="0" marL="0">
-              <a:buNone/>
-            </a:pPr>
-            <a:r>
-              <a:rPr lang="en-US" sz="1600" b="1" dirty="0">
-                <a:solidFill>
-                  <a:srgbClr val="E4568A"/>
-                </a:solidFill>
-                <a:latin typeface="Calibri" pitchFamily="34" charset="0"/>
-                <a:ea typeface="Calibri" pitchFamily="34" charset="-122"/>
-                <a:cs typeface="Calibri" pitchFamily="34" charset="-120"/>
-              </a:rPr>
-              <a:t>Sources of error</a:t>
-            </a:r>
-            <a:endParaRPr lang="en-US" sz="1600" dirty="0"/>
-          </a:p>
-        </p:txBody>
-      </p:sp>
-      <p:sp>
-        <p:nvSpPr>
-          <p:cNvPr id="12" name="Shape 10"/>
-          <p:cNvSpPr/>
-          <p:nvPr/>
-        </p:nvSpPr>
-        <p:spPr>
-          <a:xfrm>
-            <a:off x="6309360" y="2350008"/>
-            <a:ext cx="128016" cy="128016"/>
-          </a:xfrm>
-          <a:prstGeom prst="ellipse">
-            <a:avLst/>
-          </a:prstGeom>
-          <a:solidFill>
-            <a:srgbClr val="1F8A9C"/>
-          </a:solidFill>
-          <a:ln/>
-        </p:spPr>
-      </p:sp>
-      <p:sp>
-        <p:nvSpPr>
-          <p:cNvPr id="13" name="Text 11"/>
-          <p:cNvSpPr txBox="1"/>
-          <p:nvPr/>
-        </p:nvSpPr>
-        <p:spPr>
-          <a:xfrm>
-            <a:off x="6601968" y="2258568"/>
-            <a:ext cx="4919472" cy="731520"/>
-          </a:xfrm>
-          <a:prstGeom prst="rect">
-            <a:avLst/>
-          </a:prstGeom>
-          <a:noFill/>
-          <a:ln/>
-        </p:spPr>
-        <p:txBody>
-          <a:bodyPr wrap="square" lIns="0" tIns="0" rIns="0" bIns="0" rtlCol="0" anchor="ctr"/>
-          <a:lstStyle/>
-          <a:p>
-            <a:pPr indent="0" marL="0">
-              <a:lnSpc>
-                <a:spcPts val="1850"/>
-              </a:lnSpc>
-              <a:buNone/>
-            </a:pPr>
-            <a:r>
-              <a:rPr lang="en-US" sz="1350" dirty="0">
-                <a:solidFill>
-                  <a:srgbClr val="9FB0CF"/>
-                </a:solidFill>
-                <a:latin typeface="Calibri" pitchFamily="34" charset="0"/>
-                <a:ea typeface="Calibri" pitchFamily="34" charset="-122"/>
-                <a:cs typeface="Calibri" pitchFamily="34" charset="-120"/>
-              </a:rPr>
-              <a:t>A $8 sensor is less precise than clinical equipment.</a:t>
-            </a:r>
-            <a:endParaRPr lang="en-US" sz="1350" dirty="0"/>
-          </a:p>
-        </p:txBody>
-      </p:sp>
-      <p:sp>
-        <p:nvSpPr>
-          <p:cNvPr id="14" name="Shape 12"/>
-          <p:cNvSpPr/>
-          <p:nvPr/>
-        </p:nvSpPr>
-        <p:spPr>
-          <a:xfrm>
-            <a:off x="6309360" y="2916936"/>
-            <a:ext cx="128016" cy="128016"/>
-          </a:xfrm>
-          <a:prstGeom prst="ellipse">
-            <a:avLst/>
-          </a:prstGeom>
-          <a:solidFill>
-            <a:srgbClr val="1F8A9C"/>
-          </a:solidFill>
-          <a:ln/>
-        </p:spPr>
-      </p:sp>
-      <p:sp>
-        <p:nvSpPr>
-          <p:cNvPr id="15" name="Text 13"/>
-          <p:cNvSpPr txBox="1"/>
-          <p:nvPr/>
-        </p:nvSpPr>
-        <p:spPr>
-          <a:xfrm>
-            <a:off x="6601968" y="2825496"/>
-            <a:ext cx="4919472" cy="731520"/>
-          </a:xfrm>
-          <a:prstGeom prst="rect">
-            <a:avLst/>
-          </a:prstGeom>
-          <a:noFill/>
-          <a:ln/>
-        </p:spPr>
-        <p:txBody>
-          <a:bodyPr wrap="square" lIns="0" tIns="0" rIns="0" bIns="0" rtlCol="0" anchor="ctr"/>
-          <a:lstStyle/>
-          <a:p>
-            <a:pPr indent="0" marL="0">
-              <a:lnSpc>
-                <a:spcPts val="1850"/>
-              </a:lnSpc>
-              <a:buNone/>
-            </a:pPr>
-            <a:r>
-              <a:rPr lang="en-US" sz="1350" dirty="0">
-                <a:solidFill>
-                  <a:srgbClr val="9FB0CF"/>
-                </a:solidFill>
-                <a:latin typeface="Calibri" pitchFamily="34" charset="0"/>
-                <a:ea typeface="Calibri" pitchFamily="34" charset="-122"/>
-                <a:cs typeface="Calibri" pitchFamily="34" charset="-120"/>
-              </a:rPr>
-              <a:t>Breath-holds while awake imitate, but aren’t identical to, real apnea.</a:t>
-            </a:r>
-            <a:endParaRPr lang="en-US" sz="1350" dirty="0"/>
-          </a:p>
-        </p:txBody>
-      </p:sp>
-      <p:sp>
-        <p:nvSpPr>
-          <p:cNvPr id="16" name="Shape 14"/>
-          <p:cNvSpPr/>
-          <p:nvPr/>
-        </p:nvSpPr>
-        <p:spPr>
-          <a:xfrm>
-            <a:off x="6309360" y="3785616"/>
-            <a:ext cx="128016" cy="128016"/>
-          </a:xfrm>
-          <a:prstGeom prst="ellipse">
-            <a:avLst/>
-          </a:prstGeom>
-          <a:solidFill>
-            <a:srgbClr val="1F8A9C"/>
-          </a:solidFill>
-          <a:ln/>
-        </p:spPr>
-      </p:sp>
-      <p:sp>
-        <p:nvSpPr>
-          <p:cNvPr id="17" name="Text 15"/>
-          <p:cNvSpPr txBox="1"/>
-          <p:nvPr/>
-        </p:nvSpPr>
-        <p:spPr>
-          <a:xfrm>
-            <a:off x="6601968" y="3694176"/>
-            <a:ext cx="4919472" cy="731520"/>
-          </a:xfrm>
-          <a:prstGeom prst="rect">
-            <a:avLst/>
-          </a:prstGeom>
-          <a:noFill/>
-          <a:ln/>
-        </p:spPr>
-        <p:txBody>
-          <a:bodyPr wrap="square" lIns="0" tIns="0" rIns="0" bIns="0" rtlCol="0" anchor="ctr"/>
-          <a:lstStyle/>
-          <a:p>
-            <a:pPr indent="0" marL="0">
-              <a:lnSpc>
-                <a:spcPts val="1850"/>
-              </a:lnSpc>
-              <a:buNone/>
-            </a:pPr>
-            <a:r>
-              <a:rPr lang="en-US" sz="1350" dirty="0">
-                <a:solidFill>
-                  <a:srgbClr val="9FB0CF"/>
-                </a:solidFill>
-                <a:latin typeface="Calibri" pitchFamily="34" charset="0"/>
-                <a:ea typeface="Calibri" pitchFamily="34" charset="-122"/>
-                <a:cs typeface="Calibri" pitchFamily="34" charset="-120"/>
-              </a:rPr>
-              <a:t>Tested on one person over few nights — a small sample.</a:t>
-            </a:r>
-            <a:endParaRPr lang="en-US" sz="1350" dirty="0"/>
-          </a:p>
-        </p:txBody>
-      </p:sp>
-      <p:sp>
-        <p:nvSpPr>
-          <p:cNvPr id="18" name="Shape 16"/>
-          <p:cNvSpPr/>
-          <p:nvPr/>
-        </p:nvSpPr>
-        <p:spPr>
-          <a:xfrm>
-            <a:off x="6309360" y="4352544"/>
-            <a:ext cx="128016" cy="128016"/>
-          </a:xfrm>
-          <a:prstGeom prst="ellipse">
-            <a:avLst/>
-          </a:prstGeom>
-          <a:solidFill>
-            <a:srgbClr val="1F8A9C"/>
-          </a:solidFill>
-          <a:ln/>
-        </p:spPr>
-      </p:sp>
-      <p:sp>
-        <p:nvSpPr>
-          <p:cNvPr id="19" name="Text 17"/>
-          <p:cNvSpPr txBox="1"/>
-          <p:nvPr/>
-        </p:nvSpPr>
-        <p:spPr>
-          <a:xfrm>
-            <a:off x="6601968" y="4261104"/>
-            <a:ext cx="4919472" cy="731520"/>
-          </a:xfrm>
-          <a:prstGeom prst="rect">
-            <a:avLst/>
-          </a:prstGeom>
-          <a:noFill/>
-          <a:ln/>
-        </p:spPr>
-        <p:txBody>
-          <a:bodyPr wrap="square" lIns="0" tIns="0" rIns="0" bIns="0" rtlCol="0" anchor="ctr"/>
-          <a:lstStyle/>
-          <a:p>
-            <a:pPr indent="0" marL="0">
-              <a:lnSpc>
-                <a:spcPts val="1850"/>
-              </a:lnSpc>
-              <a:buNone/>
-            </a:pPr>
-            <a:r>
-              <a:rPr lang="en-US" sz="1350" dirty="0">
-                <a:solidFill>
-                  <a:srgbClr val="9FB0CF"/>
-                </a:solidFill>
-                <a:latin typeface="Calibri" pitchFamily="34" charset="0"/>
-                <a:ea typeface="Calibri" pitchFamily="34" charset="-122"/>
-                <a:cs typeface="Calibri" pitchFamily="34" charset="-120"/>
-              </a:rPr>
-              <a:t>Finger movement adds noise the software must smooth out.</a:t>
-            </a:r>
-            <a:endParaRPr lang="en-US" sz="1350" dirty="0"/>
           </a:p>
         </p:txBody>
       </p:sp>
@@ -9058,7 +9479,7 @@
                 <a:ea typeface="Calibri" pitchFamily="34" charset="-122"/>
                 <a:cs typeface="Calibri" pitchFamily="34" charset="-120"/>
               </a:rPr>
-              <a:t>CONCLUSION</a:t>
+              <a:t>ANALYSIS</a:t>
             </a:r>
             <a:endParaRPr lang="en-US" sz="1200" dirty="0"/>
           </a:p>
@@ -9100,7 +9521,7 @@
                 <a:ea typeface="Calibri" pitchFamily="34" charset="-122"/>
                 <a:cs typeface="Calibri" pitchFamily="34" charset="-120"/>
               </a:rPr>
-              <a:t>Back to the hypothesis</a:t>
+              <a:t>What the results mean</a:t>
             </a:r>
             <a:endParaRPr lang="en-US" sz="3000" dirty="0"/>
           </a:p>
@@ -9108,138 +9529,52 @@
       </p:sp>
       <p:sp>
         <p:nvSpPr>
-          <p:cNvPr id="4" name="Shape 2"/>
+          <p:cNvPr id="4" name="Text 2"/>
+          <p:cNvSpPr txBox="1"/>
+          <p:nvPr/>
+        </p:nvSpPr>
+        <p:spPr>
+          <a:xfrm>
+            <a:off x="640080" y="1828800"/>
+            <a:ext cx="5120640" cy="365760"/>
+          </a:xfrm>
+          <a:prstGeom prst="rect">
+            <a:avLst/>
+          </a:prstGeom>
+          <a:noFill/>
+          <a:ln/>
+        </p:spPr>
+        <p:txBody>
+          <a:bodyPr wrap="square" lIns="0" tIns="0" rIns="0" bIns="0" rtlCol="0" anchor="ctr"/>
+          <a:lstStyle/>
+          <a:p>
+            <a:pPr indent="0" marL="0">
+              <a:buNone/>
+            </a:pPr>
+            <a:r>
+              <a:rPr lang="en-US" sz="1600" b="1" dirty="0">
+                <a:solidFill>
+                  <a:srgbClr val="3FB8CC"/>
+                </a:solidFill>
+                <a:latin typeface="Calibri" pitchFamily="34" charset="0"/>
+                <a:ea typeface="Calibri" pitchFamily="34" charset="-122"/>
+                <a:cs typeface="Calibri" pitchFamily="34" charset="-120"/>
+              </a:rPr>
+              <a:t>Interpretation</a:t>
+            </a:r>
+            <a:endParaRPr lang="en-US" sz="1600" dirty="0"/>
+          </a:p>
+        </p:txBody>
+      </p:sp>
+      <p:sp>
+        <p:nvSpPr>
+          <p:cNvPr id="5" name="Shape 3"/>
           <p:cNvSpPr/>
           <p:nvPr/>
         </p:nvSpPr>
         <p:spPr>
           <a:xfrm>
-            <a:off x="640080" y="1828800"/>
-            <a:ext cx="10881360" cy="1280160"/>
-          </a:xfrm>
-          <a:prstGeom prst="roundRect">
-            <a:avLst>
-              <a:gd name="adj" fmla="val 7143"/>
-            </a:avLst>
-          </a:prstGeom>
-          <a:solidFill>
-            <a:srgbClr val="18233F"/>
-          </a:solidFill>
-          <a:ln w="12700">
-            <a:solidFill>
-              <a:srgbClr val="1F8A9C"/>
-            </a:solidFill>
-            <a:prstDash val="solid"/>
-          </a:ln>
-        </p:spPr>
-      </p:sp>
-      <p:sp>
-        <p:nvSpPr>
-          <p:cNvPr id="5" name="Text 3"/>
-          <p:cNvSpPr txBox="1"/>
-          <p:nvPr/>
-        </p:nvSpPr>
-        <p:spPr>
-          <a:xfrm>
-            <a:off x="914400" y="2011680"/>
-            <a:ext cx="10332720" cy="1005840"/>
-          </a:xfrm>
-          <a:prstGeom prst="rect">
-            <a:avLst/>
-          </a:prstGeom>
-          <a:noFill/>
-          <a:ln/>
-        </p:spPr>
-        <p:txBody>
-          <a:bodyPr wrap="square" lIns="0" tIns="0" rIns="0" bIns="0" rtlCol="0" anchor="ctr"/>
-          <a:lstStyle/>
-          <a:p>
-            <a:pPr indent="0" marL="0">
-              <a:lnSpc>
-                <a:spcPts val="2300"/>
-              </a:lnSpc>
-              <a:buNone/>
-            </a:pPr>
-            <a:r>
-              <a:rPr lang="en-US" sz="1600" b="1" dirty="0">
-                <a:solidFill>
-                  <a:srgbClr val="3FB8CC"/>
-                </a:solidFill>
-                <a:latin typeface="Calibri" pitchFamily="34" charset="0"/>
-                <a:ea typeface="Calibri" pitchFamily="34" charset="-122"/>
-                <a:cs typeface="Calibri" pitchFamily="34" charset="-120"/>
-              </a:rPr>
-              <a:t>Hypothesis supported. </a:t>
-            </a:r>
-            <a:pPr indent="0" marL="0">
-              <a:lnSpc>
-                <a:spcPts val="2300"/>
-              </a:lnSpc>
-              <a:buNone/>
-            </a:pPr>
-            <a:r>
-              <a:rPr lang="en-US" sz="1600" dirty="0">
-                <a:solidFill>
-                  <a:srgbClr val="FFFFFF"/>
-                </a:solidFill>
-                <a:latin typeface="Calibri" pitchFamily="34" charset="0"/>
-                <a:ea typeface="Calibri" pitchFamily="34" charset="-122"/>
-                <a:cs typeface="Calibri" pitchFamily="34" charset="-120"/>
-              </a:rPr>
-              <a:t>A $35 wearable detected apnea’s oxygen drops, agreed closely with a medical oximeter, estimated an AHI severity, and revealed that back-sleeping caused more events.</a:t>
-            </a:r>
-            <a:endParaRPr lang="en-US" sz="1600" dirty="0"/>
-          </a:p>
-        </p:txBody>
-      </p:sp>
-      <p:sp>
-        <p:nvSpPr>
-          <p:cNvPr id="6" name="Text 4"/>
-          <p:cNvSpPr txBox="1"/>
-          <p:nvPr/>
-        </p:nvSpPr>
-        <p:spPr>
-          <a:xfrm>
-            <a:off x="640080" y="3474720"/>
-            <a:ext cx="10058400" cy="365760"/>
-          </a:xfrm>
-          <a:prstGeom prst="rect">
-            <a:avLst/>
-          </a:prstGeom>
-          <a:noFill/>
-          <a:ln/>
-        </p:spPr>
-        <p:txBody>
-          <a:bodyPr wrap="square" lIns="0" tIns="0" rIns="0" bIns="0" rtlCol="0" anchor="ctr"/>
-          <a:lstStyle/>
-          <a:p>
-            <a:pPr indent="0" marL="0">
-              <a:buNone/>
-            </a:pPr>
-            <a:r>
-              <a:rPr lang="en-US" sz="1600" b="1" dirty="0">
-                <a:solidFill>
-                  <a:srgbClr val="E4568A"/>
-                </a:solidFill>
-                <a:latin typeface="Calibri" pitchFamily="34" charset="0"/>
-                <a:ea typeface="Calibri" pitchFamily="34" charset="-122"/>
-                <a:cs typeface="Calibri" pitchFamily="34" charset="-120"/>
-              </a:rPr>
-              <a:t>Further considerations &amp; improvements</a:t>
-            </a:r>
-            <a:endParaRPr lang="en-US" sz="1600" dirty="0"/>
-          </a:p>
-        </p:txBody>
-      </p:sp>
-      <p:sp>
-        <p:nvSpPr>
-          <p:cNvPr id="7" name="Shape 5"/>
-          <p:cNvSpPr/>
-          <p:nvPr/>
-        </p:nvSpPr>
-        <p:spPr>
-          <a:xfrm>
-            <a:off x="640080" y="3995928"/>
+            <a:off x="640080" y="2350008"/>
             <a:ext cx="128016" cy="128016"/>
           </a:xfrm>
           <a:prstGeom prst="ellipse">
@@ -9253,14 +9588,14 @@
       </p:sp>
       <p:sp>
         <p:nvSpPr>
-          <p:cNvPr id="8" name="Text 6"/>
+          <p:cNvPr id="6" name="Text 4"/>
           <p:cNvSpPr txBox="1"/>
           <p:nvPr/>
         </p:nvSpPr>
         <p:spPr>
           <a:xfrm>
-            <a:off x="932688" y="3904488"/>
-            <a:ext cx="10314432" cy="731520"/>
+            <a:off x="932688" y="2258568"/>
+            <a:ext cx="5010912" cy="731520"/>
           </a:xfrm>
           <a:prstGeom prst="rect">
             <a:avLst/>
@@ -9274,12 +9609,12 @@
           <a:p>
             <a:pPr indent="0" marL="0">
               <a:lnSpc>
-                <a:spcPts val="1900"/>
+                <a:spcPts val="1850"/>
               </a:lnSpc>
               <a:buNone/>
             </a:pPr>
             <a:r>
-              <a:rPr lang="en-US" sz="1400" dirty="0">
+              <a:rPr lang="en-US" sz="1350" dirty="0">
                 <a:solidFill>
                   <a:srgbClr val="9FB0CF"/>
                 </a:solidFill>
@@ -9287,21 +9622,21 @@
                 <a:ea typeface="Calibri" pitchFamily="34" charset="-122"/>
                 <a:cs typeface="Calibri" pitchFamily="34" charset="-120"/>
               </a:rPr>
-              <a:t>Test more people, for more full nights, to strengthen the data.</a:t>
-            </a:r>
-            <a:endParaRPr lang="en-US" sz="1400" dirty="0"/>
-          </a:p>
-        </p:txBody>
-      </p:sp>
-      <p:sp>
-        <p:nvSpPr>
-          <p:cNvPr id="9" name="Shape 7"/>
+              <a:t>The device agreed with a reference oximeter within ~0.6% — accurate enough to trust its readings.</a:t>
+            </a:r>
+            <a:endParaRPr lang="en-US" sz="1350" dirty="0"/>
+          </a:p>
+        </p:txBody>
+      </p:sp>
+      <p:sp>
+        <p:nvSpPr>
+          <p:cNvPr id="7" name="Shape 5"/>
           <p:cNvSpPr/>
           <p:nvPr/>
         </p:nvSpPr>
         <p:spPr>
           <a:xfrm>
-            <a:off x="640080" y="4864608"/>
+            <a:off x="640080" y="3218688"/>
             <a:ext cx="128016" cy="128016"/>
           </a:xfrm>
           <a:prstGeom prst="ellipse">
@@ -9315,14 +9650,14 @@
       </p:sp>
       <p:sp>
         <p:nvSpPr>
-          <p:cNvPr id="10" name="Text 8"/>
+          <p:cNvPr id="8" name="Text 6"/>
           <p:cNvSpPr txBox="1"/>
           <p:nvPr/>
         </p:nvSpPr>
         <p:spPr>
           <a:xfrm>
-            <a:off x="932688" y="4773168"/>
-            <a:ext cx="10314432" cy="731520"/>
+            <a:off x="932688" y="3127248"/>
+            <a:ext cx="5010912" cy="731520"/>
           </a:xfrm>
           <a:prstGeom prst="rect">
             <a:avLst/>
@@ -9336,12 +9671,12 @@
           <a:p>
             <a:pPr indent="0" marL="0">
               <a:lnSpc>
-                <a:spcPts val="1900"/>
+                <a:spcPts val="1850"/>
               </a:lnSpc>
               <a:buNone/>
             </a:pPr>
             <a:r>
-              <a:rPr lang="en-US" sz="1400" dirty="0">
+              <a:rPr lang="en-US" sz="1350" dirty="0">
                 <a:solidFill>
                   <a:srgbClr val="9FB0CF"/>
                 </a:solidFill>
@@ -9349,21 +9684,21 @@
                 <a:ea typeface="Calibri" pitchFamily="34" charset="-122"/>
                 <a:cs typeface="Calibri" pitchFamily="34" charset="-120"/>
               </a:rPr>
-              <a:t>Switch to Bluetooth Low Energy for a live phone app.</a:t>
-            </a:r>
-            <a:endParaRPr lang="en-US" sz="1400" dirty="0"/>
-          </a:p>
-        </p:txBody>
-      </p:sp>
-      <p:sp>
-        <p:nvSpPr>
-          <p:cNvPr id="11" name="Shape 9"/>
+              <a:t>It reliably flagged the oxygen drops that mark apnea events.</a:t>
+            </a:r>
+            <a:endParaRPr lang="en-US" sz="1350" dirty="0"/>
+          </a:p>
+        </p:txBody>
+      </p:sp>
+      <p:sp>
+        <p:nvSpPr>
+          <p:cNvPr id="9" name="Shape 7"/>
           <p:cNvSpPr/>
           <p:nvPr/>
         </p:nvSpPr>
         <p:spPr>
           <a:xfrm>
-            <a:off x="640080" y="5431536"/>
+            <a:off x="640080" y="3785616"/>
             <a:ext cx="128016" cy="128016"/>
           </a:xfrm>
           <a:prstGeom prst="ellipse">
@@ -9377,14 +9712,14 @@
       </p:sp>
       <p:sp>
         <p:nvSpPr>
-          <p:cNvPr id="12" name="Text 10"/>
+          <p:cNvPr id="10" name="Text 8"/>
           <p:cNvSpPr txBox="1"/>
           <p:nvPr/>
         </p:nvSpPr>
         <p:spPr>
           <a:xfrm>
-            <a:off x="932688" y="5340096"/>
-            <a:ext cx="10314432" cy="731520"/>
+            <a:off x="932688" y="3694176"/>
+            <a:ext cx="5010912" cy="731520"/>
           </a:xfrm>
           <a:prstGeom prst="rect">
             <a:avLst/>
@@ -9398,12 +9733,12 @@
           <a:p>
             <a:pPr indent="0" marL="0">
               <a:lnSpc>
-                <a:spcPts val="1900"/>
+                <a:spcPts val="1850"/>
               </a:lnSpc>
               <a:buNone/>
             </a:pPr>
             <a:r>
-              <a:rPr lang="en-US" sz="1400" dirty="0">
+              <a:rPr lang="en-US" sz="1350" dirty="0">
                 <a:solidFill>
                   <a:srgbClr val="9FB0CF"/>
                 </a:solidFill>
@@ -9411,21 +9746,60 @@
                 <a:ea typeface="Calibri" pitchFamily="34" charset="-122"/>
                 <a:cs typeface="Calibri" pitchFamily="34" charset="-120"/>
               </a:rPr>
-              <a:t>Shrink the device into a comfortable finger-ring form.</a:t>
-            </a:r>
-            <a:endParaRPr lang="en-US" sz="1400" dirty="0"/>
-          </a:p>
-        </p:txBody>
-      </p:sp>
-      <p:sp>
-        <p:nvSpPr>
-          <p:cNvPr id="13" name="Shape 11"/>
+              <a:t>Back-sleeping produced the most events, matching medical literature.</a:t>
+            </a:r>
+            <a:endParaRPr lang="en-US" sz="1350" dirty="0"/>
+          </a:p>
+        </p:txBody>
+      </p:sp>
+      <p:sp>
+        <p:nvSpPr>
+          <p:cNvPr id="11" name="Text 9"/>
+          <p:cNvSpPr txBox="1"/>
+          <p:nvPr/>
+        </p:nvSpPr>
+        <p:spPr>
+          <a:xfrm>
+            <a:off x="6309360" y="1828800"/>
+            <a:ext cx="5120640" cy="365760"/>
+          </a:xfrm>
+          <a:prstGeom prst="rect">
+            <a:avLst/>
+          </a:prstGeom>
+          <a:noFill/>
+          <a:ln/>
+        </p:spPr>
+        <p:txBody>
+          <a:bodyPr wrap="square" lIns="0" tIns="0" rIns="0" bIns="0" rtlCol="0" anchor="ctr"/>
+          <a:lstStyle/>
+          <a:p>
+            <a:pPr indent="0" marL="0">
+              <a:buNone/>
+            </a:pPr>
+            <a:r>
+              <a:rPr lang="en-US" sz="1600" b="1" dirty="0">
+                <a:solidFill>
+                  <a:srgbClr val="E4568A"/>
+                </a:solidFill>
+                <a:latin typeface="Calibri" pitchFamily="34" charset="0"/>
+                <a:ea typeface="Calibri" pitchFamily="34" charset="-122"/>
+                <a:cs typeface="Calibri" pitchFamily="34" charset="-120"/>
+              </a:rPr>
+              <a:t>Sources of error</a:t>
+            </a:r>
+            <a:endParaRPr lang="en-US" sz="1600" dirty="0"/>
+          </a:p>
+        </p:txBody>
+      </p:sp>
+      <p:sp>
+        <p:nvSpPr>
+          <p:cNvPr id="12" name="Shape 10"/>
           <p:cNvSpPr/>
           <p:nvPr/>
         </p:nvSpPr>
         <p:spPr>
           <a:xfrm>
-            <a:off x="640080" y="5998464"/>
+            <a:off x="6309360" y="2350008"/>
             <a:ext cx="128016" cy="128016"/>
           </a:xfrm>
           <a:prstGeom prst="ellipse">
@@ -9439,14 +9813,14 @@
       </p:sp>
       <p:sp>
         <p:nvSpPr>
-          <p:cNvPr id="14" name="Text 12"/>
+          <p:cNvPr id="13" name="Text 11"/>
           <p:cNvSpPr txBox="1"/>
           <p:nvPr/>
         </p:nvSpPr>
         <p:spPr>
           <a:xfrm>
-            <a:off x="932688" y="5907024"/>
-            <a:ext cx="10314432" cy="731520"/>
+            <a:off x="6601968" y="2258568"/>
+            <a:ext cx="4919472" cy="731520"/>
           </a:xfrm>
           <a:prstGeom prst="rect">
             <a:avLst/>
@@ -9460,12 +9834,12 @@
           <a:p>
             <a:pPr indent="0" marL="0">
               <a:lnSpc>
-                <a:spcPts val="1900"/>
+                <a:spcPts val="1850"/>
               </a:lnSpc>
               <a:buNone/>
             </a:pPr>
             <a:r>
-              <a:rPr lang="en-US" sz="1400" dirty="0">
+              <a:rPr lang="en-US" sz="1350" dirty="0">
                 <a:solidFill>
                   <a:srgbClr val="9FB0CF"/>
                 </a:solidFill>
@@ -9473,9 +9847,195 @@
                 <a:ea typeface="Calibri" pitchFamily="34" charset="-122"/>
                 <a:cs typeface="Calibri" pitchFamily="34" charset="-120"/>
               </a:rPr>
-              <a:t>Compare results directly against a real clinical sleep study.</a:t>
-            </a:r>
-            <a:endParaRPr lang="en-US" sz="1400" dirty="0"/>
+              <a:t>A $8 sensor is less precise than clinical equipment.</a:t>
+            </a:r>
+            <a:endParaRPr lang="en-US" sz="1350" dirty="0"/>
+          </a:p>
+        </p:txBody>
+      </p:sp>
+      <p:sp>
+        <p:nvSpPr>
+          <p:cNvPr id="14" name="Shape 12"/>
+          <p:cNvSpPr/>
+          <p:nvPr/>
+        </p:nvSpPr>
+        <p:spPr>
+          <a:xfrm>
+            <a:off x="6309360" y="2916936"/>
+            <a:ext cx="128016" cy="128016"/>
+          </a:xfrm>
+          <a:prstGeom prst="ellipse">
+            <a:avLst/>
+          </a:prstGeom>
+          <a:solidFill>
+            <a:srgbClr val="1F8A9C"/>
+          </a:solidFill>
+          <a:ln/>
+        </p:spPr>
+      </p:sp>
+      <p:sp>
+        <p:nvSpPr>
+          <p:cNvPr id="15" name="Text 13"/>
+          <p:cNvSpPr txBox="1"/>
+          <p:nvPr/>
+        </p:nvSpPr>
+        <p:spPr>
+          <a:xfrm>
+            <a:off x="6601968" y="2825496"/>
+            <a:ext cx="4919472" cy="731520"/>
+          </a:xfrm>
+          <a:prstGeom prst="rect">
+            <a:avLst/>
+          </a:prstGeom>
+          <a:noFill/>
+          <a:ln/>
+        </p:spPr>
+        <p:txBody>
+          <a:bodyPr wrap="square" lIns="0" tIns="0" rIns="0" bIns="0" rtlCol="0" anchor="ctr"/>
+          <a:lstStyle/>
+          <a:p>
+            <a:pPr indent="0" marL="0">
+              <a:lnSpc>
+                <a:spcPts val="1850"/>
+              </a:lnSpc>
+              <a:buNone/>
+            </a:pPr>
+            <a:r>
+              <a:rPr lang="en-US" sz="1350" dirty="0">
+                <a:solidFill>
+                  <a:srgbClr val="9FB0CF"/>
+                </a:solidFill>
+                <a:latin typeface="Calibri" pitchFamily="34" charset="0"/>
+                <a:ea typeface="Calibri" pitchFamily="34" charset="-122"/>
+                <a:cs typeface="Calibri" pitchFamily="34" charset="-120"/>
+              </a:rPr>
+              <a:t>Breath-holds while awake imitate, but aren’t identical to, real apnea.</a:t>
+            </a:r>
+            <a:endParaRPr lang="en-US" sz="1350" dirty="0"/>
+          </a:p>
+        </p:txBody>
+      </p:sp>
+      <p:sp>
+        <p:nvSpPr>
+          <p:cNvPr id="16" name="Shape 14"/>
+          <p:cNvSpPr/>
+          <p:nvPr/>
+        </p:nvSpPr>
+        <p:spPr>
+          <a:xfrm>
+            <a:off x="6309360" y="3785616"/>
+            <a:ext cx="128016" cy="128016"/>
+          </a:xfrm>
+          <a:prstGeom prst="ellipse">
+            <a:avLst/>
+          </a:prstGeom>
+          <a:solidFill>
+            <a:srgbClr val="1F8A9C"/>
+          </a:solidFill>
+          <a:ln/>
+        </p:spPr>
+      </p:sp>
+      <p:sp>
+        <p:nvSpPr>
+          <p:cNvPr id="17" name="Text 15"/>
+          <p:cNvSpPr txBox="1"/>
+          <p:nvPr/>
+        </p:nvSpPr>
+        <p:spPr>
+          <a:xfrm>
+            <a:off x="6601968" y="3694176"/>
+            <a:ext cx="4919472" cy="731520"/>
+          </a:xfrm>
+          <a:prstGeom prst="rect">
+            <a:avLst/>
+          </a:prstGeom>
+          <a:noFill/>
+          <a:ln/>
+        </p:spPr>
+        <p:txBody>
+          <a:bodyPr wrap="square" lIns="0" tIns="0" rIns="0" bIns="0" rtlCol="0" anchor="ctr"/>
+          <a:lstStyle/>
+          <a:p>
+            <a:pPr indent="0" marL="0">
+              <a:lnSpc>
+                <a:spcPts val="1850"/>
+              </a:lnSpc>
+              <a:buNone/>
+            </a:pPr>
+            <a:r>
+              <a:rPr lang="en-US" sz="1350" dirty="0">
+                <a:solidFill>
+                  <a:srgbClr val="9FB0CF"/>
+                </a:solidFill>
+                <a:latin typeface="Calibri" pitchFamily="34" charset="0"/>
+                <a:ea typeface="Calibri" pitchFamily="34" charset="-122"/>
+                <a:cs typeface="Calibri" pitchFamily="34" charset="-120"/>
+              </a:rPr>
+              <a:t>Tested on one person over few nights — a small sample.</a:t>
+            </a:r>
+            <a:endParaRPr lang="en-US" sz="1350" dirty="0"/>
+          </a:p>
+        </p:txBody>
+      </p:sp>
+      <p:sp>
+        <p:nvSpPr>
+          <p:cNvPr id="18" name="Shape 16"/>
+          <p:cNvSpPr/>
+          <p:nvPr/>
+        </p:nvSpPr>
+        <p:spPr>
+          <a:xfrm>
+            <a:off x="6309360" y="4352544"/>
+            <a:ext cx="128016" cy="128016"/>
+          </a:xfrm>
+          <a:prstGeom prst="ellipse">
+            <a:avLst/>
+          </a:prstGeom>
+          <a:solidFill>
+            <a:srgbClr val="1F8A9C"/>
+          </a:solidFill>
+          <a:ln/>
+        </p:spPr>
+      </p:sp>
+      <p:sp>
+        <p:nvSpPr>
+          <p:cNvPr id="19" name="Text 17"/>
+          <p:cNvSpPr txBox="1"/>
+          <p:nvPr/>
+        </p:nvSpPr>
+        <p:spPr>
+          <a:xfrm>
+            <a:off x="6601968" y="4261104"/>
+            <a:ext cx="4919472" cy="731520"/>
+          </a:xfrm>
+          <a:prstGeom prst="rect">
+            <a:avLst/>
+          </a:prstGeom>
+          <a:noFill/>
+          <a:ln/>
+        </p:spPr>
+        <p:txBody>
+          <a:bodyPr wrap="square" lIns="0" tIns="0" rIns="0" bIns="0" rtlCol="0" anchor="ctr"/>
+          <a:lstStyle/>
+          <a:p>
+            <a:pPr indent="0" marL="0">
+              <a:lnSpc>
+                <a:spcPts val="1850"/>
+              </a:lnSpc>
+              <a:buNone/>
+            </a:pPr>
+            <a:r>
+              <a:rPr lang="en-US" sz="1350" dirty="0">
+                <a:solidFill>
+                  <a:srgbClr val="9FB0CF"/>
+                </a:solidFill>
+                <a:latin typeface="Calibri" pitchFamily="34" charset="0"/>
+                <a:ea typeface="Calibri" pitchFamily="34" charset="-122"/>
+                <a:cs typeface="Calibri" pitchFamily="34" charset="-120"/>
+              </a:rPr>
+              <a:t>Finger movement adds noise the software must smooth out.</a:t>
+            </a:r>
+            <a:endParaRPr lang="en-US" sz="1350" dirty="0"/>
           </a:p>
         </p:txBody>
       </p:sp>

</xml_diff>

<commit_message>
Switch every part to an Amazon.ca listing with its listed size
- Parts list (app, deck appendix, README) now links each part to Amazon.ca:
  AITRIP ESP32 30-pin, HiLetgo MAX30102 (14 x 14 mm), HiLetgo GY-521,
  503035 500 mAh LiPo (35 x 30 x 6 mm), Treedix TP4056 USB-C, Rakstore
  TPS63020 3.3 V buck-boost, HoHaing 70 x 45 x 29 mm box (66 x 41 x 25 mm
  inside), VELCRO 1 in roll, Elite Medica reference oximeter.
- 3D model resized to the new case and parts (incl. pre-soldered ESP32
  pins); layer stack ~22 mm fits the 25 mm inside height.
- Deck design slide, appendix A and C updated; app and slides rebuilt.

Co-Authored-By: Claude Opus 5.5 <noreply@anthropic.com>
Claude-Session: https://claude.ai/code/session_01CxrUMy4UZKTNYh6kiz9919
</commit_message>
<xml_diff>
--- a/science-fair/night-signal/Night_Signal_Presentation.pptx
+++ b/science-fair/night-signal/Night_Signal_Presentation.pptx
@@ -2020,7 +2020,7 @@
           <a:p>
             <a:r>
               <a:rPr lang="en-US" dirty="0"/>
-              <a:t>[0:40] Here's the design. A small case — a 60 by 35 millimetre Hammond box — rides on a velcro strap and holds the ESP32 processor, battery, charger and a motion sensor. A cable runs to a velcro finger clip with the MAX30102 oxygen sensor. On the right is the exploded view with every part at its real size; you can spin the interactive version with this QR code.</a:t>
+              <a:t>[0:40] Here's the design. A small case — a 70 by 45 millimetre project box — rides on a velcro strap and holds the ESP32 processor, battery, charger and a motion sensor. A cable runs to a velcro finger clip with the MAX30102 oxygen sensor. On the right is the exploded view with every part at its real size; you can spin the interactive version with this QR code.</a:t>
             </a:r>
             <a:endParaRPr lang="en-US" dirty="0"/>
           </a:p>
@@ -5793,11 +5793,10 @@
             <a:tbl>
               <a:tblPr/>
               <a:tblGrid>
-                <a:gridCol w="3383280"/>
-                <a:gridCol w="2194560"/>
-                <a:gridCol w="2194560"/>
-                <a:gridCol w="2011680"/>
-                <a:gridCol w="1097280"/>
+                <a:gridCol w="3840480"/>
+                <a:gridCol w="3200400"/>
+                <a:gridCol w="2560320"/>
+                <a:gridCol w="1280160"/>
               </a:tblGrid>
               <a:tr h="384048">
                 <a:tc>
@@ -5809,7 +5808,7 @@
                         <a:buNone/>
                       </a:pPr>
                       <a:r>
-                        <a:rPr lang="en-US" sz="1150" b="1" dirty="0">
+                        <a:rPr lang="en-US" sz="1100" b="1" dirty="0">
                           <a:solidFill>
                             <a:srgbClr val="FFFFFF"/>
                           </a:solidFill>
@@ -5819,7 +5818,7 @@
                         </a:rPr>
                         <a:t>Part</a:t>
                       </a:r>
-                      <a:endParaRPr lang="en-US" sz="1150" dirty="0">
+                      <a:endParaRPr lang="en-US" sz="1100" dirty="0">
                         <a:latin typeface="Calibri" charset="0"/>
                         <a:ea typeface="Calibri" charset="0"/>
                         <a:cs typeface="Calibri" charset="0"/>
@@ -5877,7 +5876,7 @@
                         <a:buNone/>
                       </a:pPr>
                       <a:r>
-                        <a:rPr lang="en-US" sz="1150" b="1" dirty="0">
+                        <a:rPr lang="en-US" sz="1100" b="1" dirty="0">
                           <a:solidFill>
                             <a:srgbClr val="FFFFFF"/>
                           </a:solidFill>
@@ -5887,7 +5886,7 @@
                         </a:rPr>
                         <a:t>Size</a:t>
                       </a:r>
-                      <a:endParaRPr lang="en-US" sz="1150" dirty="0">
+                      <a:endParaRPr lang="en-US" sz="1100" dirty="0">
                         <a:latin typeface="Calibri" charset="0"/>
                         <a:ea typeface="Calibri" charset="0"/>
                         <a:cs typeface="Calibri" charset="0"/>
@@ -5945,7 +5944,7 @@
                         <a:buNone/>
                       </a:pPr>
                       <a:r>
-                        <a:rPr lang="en-US" sz="1150" b="1" dirty="0">
+                        <a:rPr lang="en-US" sz="1100" b="1" dirty="0">
                           <a:solidFill>
                             <a:srgbClr val="FFFFFF"/>
                           </a:solidFill>
@@ -5955,7 +5954,7 @@
                         </a:rPr>
                         <a:t>Purpose</a:t>
                       </a:r>
-                      <a:endParaRPr lang="en-US" sz="1150" dirty="0">
+                      <a:endParaRPr lang="en-US" sz="1100" dirty="0">
                         <a:latin typeface="Calibri" charset="0"/>
                         <a:ea typeface="Calibri" charset="0"/>
                         <a:cs typeface="Calibri" charset="0"/>
@@ -6013,7 +6012,7 @@
                         <a:buNone/>
                       </a:pPr>
                       <a:r>
-                        <a:rPr lang="en-US" sz="1150" b="1" dirty="0">
+                        <a:rPr lang="en-US" sz="1100" b="1" dirty="0">
                           <a:solidFill>
                             <a:srgbClr val="FFFFFF"/>
                           </a:solidFill>
@@ -6021,77 +6020,9 @@
                           <a:ea typeface="Calibri" pitchFamily="34" charset="-122"/>
                           <a:cs typeface="Calibri" pitchFamily="34" charset="-120"/>
                         </a:rPr>
-                        <a:t>Where</a:t>
+                        <a:t>Buy</a:t>
                       </a:r>
-                      <a:endParaRPr lang="en-US" sz="1150" dirty="0">
-                        <a:latin typeface="Calibri" charset="0"/>
-                        <a:ea typeface="Calibri" charset="0"/>
-                        <a:cs typeface="Calibri" charset="0"/>
-                      </a:endParaRPr>
-                    </a:p>
-                  </a:txBody>
-                  <a:tcPr marL="91440" marR="91440" marT="45720" marB="45720" anchor="ctr">
-                    <a:lnL w="12700" cap="flat" cmpd="sng" algn="ctr">
-                      <a:solidFill>
-                        <a:srgbClr val="DBE1EC"/>
-                      </a:solidFill>
-                      <a:prstDash val="solid"/>
-                      <a:round/>
-                      <a:headEnd type="none" w="med" len="med"/>
-                      <a:tailEnd type="none" w="med" len="med"/>
-                    </a:lnL>
-                    <a:lnR w="12700" cap="flat" cmpd="sng" algn="ctr">
-                      <a:solidFill>
-                        <a:srgbClr val="DBE1EC"/>
-                      </a:solidFill>
-                      <a:prstDash val="solid"/>
-                      <a:round/>
-                      <a:headEnd type="none" w="med" len="med"/>
-                      <a:tailEnd type="none" w="med" len="med"/>
-                    </a:lnR>
-                    <a:lnT w="12700" cap="flat" cmpd="sng" algn="ctr">
-                      <a:solidFill>
-                        <a:srgbClr val="DBE1EC"/>
-                      </a:solidFill>
-                      <a:prstDash val="solid"/>
-                      <a:round/>
-                      <a:headEnd type="none" w="med" len="med"/>
-                      <a:tailEnd type="none" w="med" len="med"/>
-                    </a:lnT>
-                    <a:lnB w="12700" cap="flat" cmpd="sng" algn="ctr">
-                      <a:solidFill>
-                        <a:srgbClr val="DBE1EC"/>
-                      </a:solidFill>
-                      <a:prstDash val="solid"/>
-                      <a:round/>
-                      <a:headEnd type="none" w="med" len="med"/>
-                      <a:tailEnd type="none" w="med" len="med"/>
-                    </a:lnB>
-                    <a:solidFill>
-                      <a:srgbClr val="1F8A9C"/>
-                    </a:solidFill>
-                  </a:tcPr>
-                </a:tc>
-                <a:tc>
-                  <a:txBody>
-                    <a:bodyPr/>
-                    <a:lstStyle/>
-                    <a:p>
-                      <a:pPr indent="0" marL="0">
-                        <a:buNone/>
-                      </a:pPr>
-                      <a:r>
-                        <a:rPr lang="en-US" sz="1150" b="1" dirty="0">
-                          <a:solidFill>
-                            <a:srgbClr val="FFFFFF"/>
-                          </a:solidFill>
-                          <a:latin typeface="Calibri" pitchFamily="34" charset="0"/>
-                          <a:ea typeface="Calibri" pitchFamily="34" charset="-122"/>
-                          <a:cs typeface="Calibri" pitchFamily="34" charset="-120"/>
-                        </a:rPr>
-                        <a:t>≈ CAD</a:t>
-                      </a:r>
-                      <a:endParaRPr lang="en-US" sz="1150" dirty="0">
+                      <a:endParaRPr lang="en-US" sz="1100" dirty="0">
                         <a:latin typeface="Calibri" charset="0"/>
                         <a:ea typeface="Calibri" charset="0"/>
                         <a:cs typeface="Calibri" charset="0"/>
@@ -6151,7 +6082,7 @@
                         <a:buNone/>
                       </a:pPr>
                       <a:r>
-                        <a:rPr lang="en-US" sz="1150" dirty="0">
+                        <a:rPr lang="en-US" sz="1100" dirty="0">
                           <a:solidFill>
                             <a:srgbClr val="141A26"/>
                           </a:solidFill>
@@ -6159,9 +6090,9 @@
                           <a:ea typeface="Calibri" pitchFamily="34" charset="-122"/>
                           <a:cs typeface="Calibri" pitchFamily="34" charset="-120"/>
                         </a:rPr>
-                        <a:t>ESP32 DevKit (ESP-WROOM-32)</a:t>
+                        <a:t>AITRIP ESP32 ESP-WROOM-32 (30-pin, CP2102, USB-C)</a:t>
                       </a:r>
-                      <a:endParaRPr lang="en-US" sz="1150" dirty="0">
+                      <a:endParaRPr lang="en-US" sz="1100" dirty="0">
                         <a:latin typeface="Calibri" charset="0"/>
                         <a:ea typeface="Calibri" charset="0"/>
                         <a:cs typeface="Calibri" charset="0"/>
@@ -6216,7 +6147,7 @@
                         <a:buNone/>
                       </a:pPr>
                       <a:r>
-                        <a:rPr lang="en-US" sz="1150" dirty="0">
+                        <a:rPr lang="en-US" sz="1100" dirty="0">
                           <a:solidFill>
                             <a:srgbClr val="141A26"/>
                           </a:solidFill>
@@ -6224,9 +6155,9 @@
                           <a:ea typeface="Calibri" pitchFamily="34" charset="-122"/>
                           <a:cs typeface="Calibri" pitchFamily="34" charset="-120"/>
                         </a:rPr>
-                        <a:t>≈ 51 × 28 mm</a:t>
+                        <a:t>≈ 52 × 28 mm · 13 mm tall with pins</a:t>
                       </a:r>
-                      <a:endParaRPr lang="en-US" sz="1150" dirty="0">
+                      <a:endParaRPr lang="en-US" sz="1100" dirty="0">
                         <a:latin typeface="Calibri" charset="0"/>
                         <a:ea typeface="Calibri" charset="0"/>
                         <a:cs typeface="Calibri" charset="0"/>
@@ -6281,7 +6212,7 @@
                         <a:buNone/>
                       </a:pPr>
                       <a:r>
-                        <a:rPr lang="en-US" sz="1150" dirty="0">
+                        <a:rPr lang="en-US" sz="1100" dirty="0">
                           <a:solidFill>
                             <a:srgbClr val="141A26"/>
                           </a:solidFill>
@@ -6289,9 +6220,9 @@
                           <a:ea typeface="Calibri" pitchFamily="34" charset="-122"/>
                           <a:cs typeface="Calibri" pitchFamily="34" charset="-120"/>
                         </a:rPr>
-                        <a:t>Processor + Bluetooth</a:t>
+                        <a:t>Processor + Bluetooth Classic</a:t>
                       </a:r>
-                      <a:endParaRPr lang="en-US" sz="1150" dirty="0">
+                      <a:endParaRPr lang="en-US" sz="1100" dirty="0">
                         <a:latin typeface="Calibri" charset="0"/>
                         <a:ea typeface="Calibri" charset="0"/>
                         <a:cs typeface="Calibri" charset="0"/>
@@ -6346,14 +6277,14 @@
                         <a:buNone/>
                       </a:pPr>
                       <a:r>
-                        <a:rPr lang="en-US" sz="1150" u="sng" dirty="0">
+                        <a:rPr lang="en-US" sz="1100" u="sng" dirty="0">
                           <a:solidFill>
                             <a:srgbClr val="1F8A9C"/>
                           </a:solidFill>
                           <a:latin typeface="Calibri" pitchFamily="34" charset="0"/>
                           <a:ea typeface="Calibri" pitchFamily="34" charset="-122"/>
                           <a:cs typeface="Calibri" pitchFamily="34" charset="-120"/>
-                          <a:hlinkClick r:id="rId1" invalidUrl="" action="" tgtFrame="" tooltip="https://www.canadarobotix.com/products/2594" history="1" highlightClick="0" endSnd="0">
+                          <a:hlinkClick r:id="rId1" invalidUrl="" action="" tgtFrame="" tooltip="https://www.amazon.ca/AITRIP-ESP-WROOM-32-Development-Microcontroller-Compatible/dp/B0DF2YJSHN" history="1" highlightClick="0" endSnd="0">
                             <a:extLst>
                               <a:ext uri="{A12FA001-AC4F-418D-AE19-62706E023703}">
                                 <ahyp:hlinkClr xmlns:ahyp="http://schemas.microsoft.com/office/drawing/2018/hyperlinkcolor" val="tx"/>
@@ -6361,74 +6292,9 @@
                             </a:extLst>
                           </a:hlinkClick>
                         </a:rPr>
-                        <a:t>Canada Robotix</a:t>
+                        <a:t>Amazon.ca</a:t>
                       </a:r>
-                      <a:endParaRPr lang="en-US" sz="1150" dirty="0">
-                        <a:latin typeface="Calibri" charset="0"/>
-                        <a:ea typeface="Calibri" charset="0"/>
-                        <a:cs typeface="Calibri" charset="0"/>
-                      </a:endParaRPr>
-                    </a:p>
-                  </a:txBody>
-                  <a:tcPr marL="91440" marR="91440" marT="45720" marB="45720" anchor="ctr">
-                    <a:lnL w="12700" cap="flat" cmpd="sng" algn="ctr">
-                      <a:solidFill>
-                        <a:srgbClr val="DBE1EC"/>
-                      </a:solidFill>
-                      <a:prstDash val="solid"/>
-                      <a:round/>
-                      <a:headEnd type="none" w="med" len="med"/>
-                      <a:tailEnd type="none" w="med" len="med"/>
-                    </a:lnL>
-                    <a:lnR w="12700" cap="flat" cmpd="sng" algn="ctr">
-                      <a:solidFill>
-                        <a:srgbClr val="DBE1EC"/>
-                      </a:solidFill>
-                      <a:prstDash val="solid"/>
-                      <a:round/>
-                      <a:headEnd type="none" w="med" len="med"/>
-                      <a:tailEnd type="none" w="med" len="med"/>
-                    </a:lnR>
-                    <a:lnT w="12700" cap="flat" cmpd="sng" algn="ctr">
-                      <a:solidFill>
-                        <a:srgbClr val="DBE1EC"/>
-                      </a:solidFill>
-                      <a:prstDash val="solid"/>
-                      <a:round/>
-                      <a:headEnd type="none" w="med" len="med"/>
-                      <a:tailEnd type="none" w="med" len="med"/>
-                    </a:lnT>
-                    <a:lnB w="12700" cap="flat" cmpd="sng" algn="ctr">
-                      <a:solidFill>
-                        <a:srgbClr val="DBE1EC"/>
-                      </a:solidFill>
-                      <a:prstDash val="solid"/>
-                      <a:round/>
-                      <a:headEnd type="none" w="med" len="med"/>
-                      <a:tailEnd type="none" w="med" len="med"/>
-                    </a:lnB>
-                  </a:tcPr>
-                </a:tc>
-                <a:tc>
-                  <a:txBody>
-                    <a:bodyPr/>
-                    <a:lstStyle/>
-                    <a:p>
-                      <a:pPr indent="0" marL="0">
-                        <a:buNone/>
-                      </a:pPr>
-                      <a:r>
-                        <a:rPr lang="en-US" sz="1150" dirty="0">
-                          <a:solidFill>
-                            <a:srgbClr val="141A26"/>
-                          </a:solidFill>
-                          <a:latin typeface="Calibri" pitchFamily="34" charset="0"/>
-                          <a:ea typeface="Calibri" pitchFamily="34" charset="-122"/>
-                          <a:cs typeface="Calibri" pitchFamily="34" charset="-120"/>
-                        </a:rPr>
-                        <a:t>$10</a:t>
-                      </a:r>
-                      <a:endParaRPr lang="en-US" sz="1150" dirty="0">
+                      <a:endParaRPr lang="en-US" sz="1100" dirty="0">
                         <a:latin typeface="Calibri" charset="0"/>
                         <a:ea typeface="Calibri" charset="0"/>
                         <a:cs typeface="Calibri" charset="0"/>
@@ -6485,7 +6351,7 @@
                         <a:buNone/>
                       </a:pPr>
                       <a:r>
-                        <a:rPr lang="en-US" sz="1150" dirty="0">
+                        <a:rPr lang="en-US" sz="1100" dirty="0">
                           <a:solidFill>
                             <a:srgbClr val="141A26"/>
                           </a:solidFill>
@@ -6493,9 +6359,9 @@
                           <a:ea typeface="Calibri" pitchFamily="34" charset="-122"/>
                           <a:cs typeface="Calibri" pitchFamily="34" charset="-120"/>
                         </a:rPr>
-                        <a:t>MAX30102 oxygen sensor</a:t>
+                        <a:t>HiLetgo MAX30102 sensor</a:t>
                       </a:r>
-                      <a:endParaRPr lang="en-US" sz="1150" dirty="0">
+                      <a:endParaRPr lang="en-US" sz="1100" dirty="0">
                         <a:latin typeface="Calibri" charset="0"/>
                         <a:ea typeface="Calibri" charset="0"/>
                         <a:cs typeface="Calibri" charset="0"/>
@@ -6550,7 +6416,7 @@
                         <a:buNone/>
                       </a:pPr>
                       <a:r>
-                        <a:rPr lang="en-US" sz="1150" dirty="0">
+                        <a:rPr lang="en-US" sz="1100" dirty="0">
                           <a:solidFill>
                             <a:srgbClr val="141A26"/>
                           </a:solidFill>
@@ -6558,9 +6424,9 @@
                           <a:ea typeface="Calibri" pitchFamily="34" charset="-122"/>
                           <a:cs typeface="Calibri" pitchFamily="34" charset="-120"/>
                         </a:rPr>
-                        <a:t>≈ 18 × 14 mm</a:t>
+                        <a:t>14 × 14 mm</a:t>
                       </a:r>
-                      <a:endParaRPr lang="en-US" sz="1150" dirty="0">
+                      <a:endParaRPr lang="en-US" sz="1100" dirty="0">
                         <a:latin typeface="Calibri" charset="0"/>
                         <a:ea typeface="Calibri" charset="0"/>
                         <a:cs typeface="Calibri" charset="0"/>
@@ -6615,7 +6481,7 @@
                         <a:buNone/>
                       </a:pPr>
                       <a:r>
-                        <a:rPr lang="en-US" sz="1150" dirty="0">
+                        <a:rPr lang="en-US" sz="1100" dirty="0">
                           <a:solidFill>
                             <a:srgbClr val="141A26"/>
                           </a:solidFill>
@@ -6623,9 +6489,9 @@
                           <a:ea typeface="Calibri" pitchFamily="34" charset="-122"/>
                           <a:cs typeface="Calibri" pitchFamily="34" charset="-120"/>
                         </a:rPr>
-                        <a:t>SpO₂ + pulse</a:t>
+                        <a:t>SpO₂ + heart rate (finger clip)</a:t>
                       </a:r>
-                      <a:endParaRPr lang="en-US" sz="1150" dirty="0">
+                      <a:endParaRPr lang="en-US" sz="1100" dirty="0">
                         <a:latin typeface="Calibri" charset="0"/>
                         <a:ea typeface="Calibri" charset="0"/>
                         <a:cs typeface="Calibri" charset="0"/>
@@ -6680,14 +6546,14 @@
                         <a:buNone/>
                       </a:pPr>
                       <a:r>
-                        <a:rPr lang="en-US" sz="1150" u="sng" dirty="0">
+                        <a:rPr lang="en-US" sz="1100" u="sng" dirty="0">
                           <a:solidFill>
                             <a:srgbClr val="1F8A9C"/>
                           </a:solidFill>
                           <a:latin typeface="Calibri" pitchFamily="34" charset="0"/>
                           <a:ea typeface="Calibri" pitchFamily="34" charset="-122"/>
                           <a:cs typeface="Calibri" pitchFamily="34" charset="-120"/>
-                          <a:hlinkClick r:id="rId2" invalidUrl="" action="" tgtFrame="" tooltip="https://x2robotics.ca/pulse-oximeter-and-heart-rate-sensor-max30102" history="1" highlightClick="0" endSnd="0">
+                          <a:hlinkClick r:id="rId2" invalidUrl="" action="" tgtFrame="" tooltip="https://www.amazon.ca/HiLetgo-MAX30102-Breakout-Oximetry-Solution/dp/B07QC67KMQ" history="1" highlightClick="0" endSnd="0">
                             <a:extLst>
                               <a:ext uri="{A12FA001-AC4F-418D-AE19-62706E023703}">
                                 <ahyp:hlinkClr xmlns:ahyp="http://schemas.microsoft.com/office/drawing/2018/hyperlinkcolor" val="tx"/>
@@ -6695,74 +6561,9 @@
                             </a:extLst>
                           </a:hlinkClick>
                         </a:rPr>
-                        <a:t>X2 Robotics</a:t>
+                        <a:t>Amazon.ca</a:t>
                       </a:r>
-                      <a:endParaRPr lang="en-US" sz="1150" dirty="0">
-                        <a:latin typeface="Calibri" charset="0"/>
-                        <a:ea typeface="Calibri" charset="0"/>
-                        <a:cs typeface="Calibri" charset="0"/>
-                      </a:endParaRPr>
-                    </a:p>
-                  </a:txBody>
-                  <a:tcPr marL="91440" marR="91440" marT="45720" marB="45720" anchor="ctr">
-                    <a:lnL w="12700" cap="flat" cmpd="sng" algn="ctr">
-                      <a:solidFill>
-                        <a:srgbClr val="DBE1EC"/>
-                      </a:solidFill>
-                      <a:prstDash val="solid"/>
-                      <a:round/>
-                      <a:headEnd type="none" w="med" len="med"/>
-                      <a:tailEnd type="none" w="med" len="med"/>
-                    </a:lnL>
-                    <a:lnR w="12700" cap="flat" cmpd="sng" algn="ctr">
-                      <a:solidFill>
-                        <a:srgbClr val="DBE1EC"/>
-                      </a:solidFill>
-                      <a:prstDash val="solid"/>
-                      <a:round/>
-                      <a:headEnd type="none" w="med" len="med"/>
-                      <a:tailEnd type="none" w="med" len="med"/>
-                    </a:lnR>
-                    <a:lnT w="12700" cap="flat" cmpd="sng" algn="ctr">
-                      <a:solidFill>
-                        <a:srgbClr val="DBE1EC"/>
-                      </a:solidFill>
-                      <a:prstDash val="solid"/>
-                      <a:round/>
-                      <a:headEnd type="none" w="med" len="med"/>
-                      <a:tailEnd type="none" w="med" len="med"/>
-                    </a:lnT>
-                    <a:lnB w="12700" cap="flat" cmpd="sng" algn="ctr">
-                      <a:solidFill>
-                        <a:srgbClr val="DBE1EC"/>
-                      </a:solidFill>
-                      <a:prstDash val="solid"/>
-                      <a:round/>
-                      <a:headEnd type="none" w="med" len="med"/>
-                      <a:tailEnd type="none" w="med" len="med"/>
-                    </a:lnB>
-                  </a:tcPr>
-                </a:tc>
-                <a:tc>
-                  <a:txBody>
-                    <a:bodyPr/>
-                    <a:lstStyle/>
-                    <a:p>
-                      <a:pPr indent="0" marL="0">
-                        <a:buNone/>
-                      </a:pPr>
-                      <a:r>
-                        <a:rPr lang="en-US" sz="1150" dirty="0">
-                          <a:solidFill>
-                            <a:srgbClr val="141A26"/>
-                          </a:solidFill>
-                          <a:latin typeface="Calibri" pitchFamily="34" charset="0"/>
-                          <a:ea typeface="Calibri" pitchFamily="34" charset="-122"/>
-                          <a:cs typeface="Calibri" pitchFamily="34" charset="-120"/>
-                        </a:rPr>
-                        <a:t>≈ $10</a:t>
-                      </a:r>
-                      <a:endParaRPr lang="en-US" sz="1150" dirty="0">
+                      <a:endParaRPr lang="en-US" sz="1100" dirty="0">
                         <a:latin typeface="Calibri" charset="0"/>
                         <a:ea typeface="Calibri" charset="0"/>
                         <a:cs typeface="Calibri" charset="0"/>
@@ -6819,7 +6620,7 @@
                         <a:buNone/>
                       </a:pPr>
                       <a:r>
-                        <a:rPr lang="en-US" sz="1150" dirty="0">
+                        <a:rPr lang="en-US" sz="1100" dirty="0">
                           <a:solidFill>
                             <a:srgbClr val="141A26"/>
                           </a:solidFill>
@@ -6827,9 +6628,9 @@
                           <a:ea typeface="Calibri" pitchFamily="34" charset="-122"/>
                           <a:cs typeface="Calibri" pitchFamily="34" charset="-120"/>
                         </a:rPr>
-                        <a:t>MPU-6050 (Adafruit 3886)</a:t>
+                        <a:t>HiLetgo GY-521 MPU-6050 (3-pack)</a:t>
                       </a:r>
-                      <a:endParaRPr lang="en-US" sz="1150" dirty="0">
+                      <a:endParaRPr lang="en-US" sz="1100" dirty="0">
                         <a:latin typeface="Calibri" charset="0"/>
                         <a:ea typeface="Calibri" charset="0"/>
                         <a:cs typeface="Calibri" charset="0"/>
@@ -6884,7 +6685,7 @@
                         <a:buNone/>
                       </a:pPr>
                       <a:r>
-                        <a:rPr lang="en-US" sz="1150" dirty="0">
+                        <a:rPr lang="en-US" sz="1100" dirty="0">
                           <a:solidFill>
                             <a:srgbClr val="141A26"/>
                           </a:solidFill>
@@ -6892,9 +6693,9 @@
                           <a:ea typeface="Calibri" pitchFamily="34" charset="-122"/>
                           <a:cs typeface="Calibri" pitchFamily="34" charset="-120"/>
                         </a:rPr>
-                        <a:t>26.0 × 17.8 × 4.6 mm</a:t>
+                        <a:t>≈ 21 × 16 mm</a:t>
                       </a:r>
-                      <a:endParaRPr lang="en-US" sz="1150" dirty="0">
+                      <a:endParaRPr lang="en-US" sz="1100" dirty="0">
                         <a:latin typeface="Calibri" charset="0"/>
                         <a:ea typeface="Calibri" charset="0"/>
                         <a:cs typeface="Calibri" charset="0"/>
@@ -6949,7 +6750,7 @@
                         <a:buNone/>
                       </a:pPr>
                       <a:r>
-                        <a:rPr lang="en-US" sz="1150" dirty="0">
+                        <a:rPr lang="en-US" sz="1100" dirty="0">
                           <a:solidFill>
                             <a:srgbClr val="141A26"/>
                           </a:solidFill>
@@ -6957,9 +6758,9 @@
                           <a:ea typeface="Calibri" pitchFamily="34" charset="-122"/>
                           <a:cs typeface="Calibri" pitchFamily="34" charset="-120"/>
                         </a:rPr>
-                        <a:t>Position + coughs</a:t>
+                        <a:t>Sleep position + cough jolts</a:t>
                       </a:r>
-                      <a:endParaRPr lang="en-US" sz="1150" dirty="0">
+                      <a:endParaRPr lang="en-US" sz="1100" dirty="0">
                         <a:latin typeface="Calibri" charset="0"/>
                         <a:ea typeface="Calibri" charset="0"/>
                         <a:cs typeface="Calibri" charset="0"/>
@@ -7014,14 +6815,14 @@
                         <a:buNone/>
                       </a:pPr>
                       <a:r>
-                        <a:rPr lang="en-US" sz="1150" u="sng" dirty="0">
+                        <a:rPr lang="en-US" sz="1100" u="sng" dirty="0">
                           <a:solidFill>
                             <a:srgbClr val="1F8A9C"/>
                           </a:solidFill>
                           <a:latin typeface="Calibri" pitchFamily="34" charset="0"/>
                           <a:ea typeface="Calibri" pitchFamily="34" charset="-122"/>
                           <a:cs typeface="Calibri" pitchFamily="34" charset="-120"/>
-                          <a:hlinkClick r:id="rId3" invalidUrl="" action="" tgtFrame="" tooltip="https://www.adafruit.com/product/3886" history="1" highlightClick="0" endSnd="0">
+                          <a:hlinkClick r:id="rId3" invalidUrl="" action="" tgtFrame="" tooltip="https://www.amazon.ca/Hiletgo-MPU6050-Acc%C3%A9l%C3%A9rom%C3%A8tre-gyroscope-convertisseur/dp/B00LP25V1A" history="1" highlightClick="0" endSnd="0">
                             <a:extLst>
                               <a:ext uri="{A12FA001-AC4F-418D-AE19-62706E023703}">
                                 <ahyp:hlinkClr xmlns:ahyp="http://schemas.microsoft.com/office/drawing/2018/hyperlinkcolor" val="tx"/>
@@ -7029,74 +6830,9 @@
                             </a:extLst>
                           </a:hlinkClick>
                         </a:rPr>
-                        <a:t>Adafruit</a:t>
+                        <a:t>Amazon.ca</a:t>
                       </a:r>
-                      <a:endParaRPr lang="en-US" sz="1150" dirty="0">
-                        <a:latin typeface="Calibri" charset="0"/>
-                        <a:ea typeface="Calibri" charset="0"/>
-                        <a:cs typeface="Calibri" charset="0"/>
-                      </a:endParaRPr>
-                    </a:p>
-                  </a:txBody>
-                  <a:tcPr marL="91440" marR="91440" marT="45720" marB="45720" anchor="ctr">
-                    <a:lnL w="12700" cap="flat" cmpd="sng" algn="ctr">
-                      <a:solidFill>
-                        <a:srgbClr val="DBE1EC"/>
-                      </a:solidFill>
-                      <a:prstDash val="solid"/>
-                      <a:round/>
-                      <a:headEnd type="none" w="med" len="med"/>
-                      <a:tailEnd type="none" w="med" len="med"/>
-                    </a:lnL>
-                    <a:lnR w="12700" cap="flat" cmpd="sng" algn="ctr">
-                      <a:solidFill>
-                        <a:srgbClr val="DBE1EC"/>
-                      </a:solidFill>
-                      <a:prstDash val="solid"/>
-                      <a:round/>
-                      <a:headEnd type="none" w="med" len="med"/>
-                      <a:tailEnd type="none" w="med" len="med"/>
-                    </a:lnR>
-                    <a:lnT w="12700" cap="flat" cmpd="sng" algn="ctr">
-                      <a:solidFill>
-                        <a:srgbClr val="DBE1EC"/>
-                      </a:solidFill>
-                      <a:prstDash val="solid"/>
-                      <a:round/>
-                      <a:headEnd type="none" w="med" len="med"/>
-                      <a:tailEnd type="none" w="med" len="med"/>
-                    </a:lnT>
-                    <a:lnB w="12700" cap="flat" cmpd="sng" algn="ctr">
-                      <a:solidFill>
-                        <a:srgbClr val="DBE1EC"/>
-                      </a:solidFill>
-                      <a:prstDash val="solid"/>
-                      <a:round/>
-                      <a:headEnd type="none" w="med" len="med"/>
-                      <a:tailEnd type="none" w="med" len="med"/>
-                    </a:lnB>
-                  </a:tcPr>
-                </a:tc>
-                <a:tc>
-                  <a:txBody>
-                    <a:bodyPr/>
-                    <a:lstStyle/>
-                    <a:p>
-                      <a:pPr indent="0" marL="0">
-                        <a:buNone/>
-                      </a:pPr>
-                      <a:r>
-                        <a:rPr lang="en-US" sz="1150" dirty="0">
-                          <a:solidFill>
-                            <a:srgbClr val="141A26"/>
-                          </a:solidFill>
-                          <a:latin typeface="Calibri" pitchFamily="34" charset="0"/>
-                          <a:ea typeface="Calibri" pitchFamily="34" charset="-122"/>
-                          <a:cs typeface="Calibri" pitchFamily="34" charset="-120"/>
-                        </a:rPr>
-                        <a:t>≈ $10</a:t>
-                      </a:r>
-                      <a:endParaRPr lang="en-US" sz="1150" dirty="0">
+                      <a:endParaRPr lang="en-US" sz="1100" dirty="0">
                         <a:latin typeface="Calibri" charset="0"/>
                         <a:ea typeface="Calibri" charset="0"/>
                         <a:cs typeface="Calibri" charset="0"/>
@@ -7153,7 +6889,7 @@
                         <a:buNone/>
                       </a:pPr>
                       <a:r>
-                        <a:rPr lang="en-US" sz="1150" dirty="0">
+                        <a:rPr lang="en-US" sz="1100" dirty="0">
                           <a:solidFill>
                             <a:srgbClr val="141A26"/>
                           </a:solidFill>
@@ -7161,9 +6897,9 @@
                           <a:ea typeface="Calibri" pitchFamily="34" charset="-122"/>
                           <a:cs typeface="Calibri" pitchFamily="34" charset="-120"/>
                         </a:rPr>
-                        <a:t>LiPo 3.7 V 500 mAh (Adafruit 1578)</a:t>
+                        <a:t>LiPo 3.7 V 500 mAh 503035, JST PH2.0</a:t>
                       </a:r>
-                      <a:endParaRPr lang="en-US" sz="1150" dirty="0">
+                      <a:endParaRPr lang="en-US" sz="1100" dirty="0">
                         <a:latin typeface="Calibri" charset="0"/>
                         <a:ea typeface="Calibri" charset="0"/>
                         <a:cs typeface="Calibri" charset="0"/>
@@ -7218,7 +6954,7 @@
                         <a:buNone/>
                       </a:pPr>
                       <a:r>
-                        <a:rPr lang="en-US" sz="1150" dirty="0">
+                        <a:rPr lang="en-US" sz="1100" dirty="0">
                           <a:solidFill>
                             <a:srgbClr val="141A26"/>
                           </a:solidFill>
@@ -7226,9 +6962,9 @@
                           <a:ea typeface="Calibri" pitchFamily="34" charset="-122"/>
                           <a:cs typeface="Calibri" pitchFamily="34" charset="-120"/>
                         </a:rPr>
-                        <a:t>36 × 29 × 4.75 mm</a:t>
+                        <a:t>35 × 30 × 6 mm</a:t>
                       </a:r>
-                      <a:endParaRPr lang="en-US" sz="1150" dirty="0">
+                      <a:endParaRPr lang="en-US" sz="1100" dirty="0">
                         <a:latin typeface="Calibri" charset="0"/>
                         <a:ea typeface="Calibri" charset="0"/>
                         <a:cs typeface="Calibri" charset="0"/>
@@ -7283,7 +7019,7 @@
                         <a:buNone/>
                       </a:pPr>
                       <a:r>
-                        <a:rPr lang="en-US" sz="1150" dirty="0">
+                        <a:rPr lang="en-US" sz="1100" dirty="0">
                           <a:solidFill>
                             <a:srgbClr val="141A26"/>
                           </a:solidFill>
@@ -7291,9 +7027,9 @@
                           <a:ea typeface="Calibri" pitchFamily="34" charset="-122"/>
                           <a:cs typeface="Calibri" pitchFamily="34" charset="-120"/>
                         </a:rPr>
-                        <a:t>Battery (≈ 4–5 h)</a:t>
+                        <a:t>Battery (≈ 4–5 h — test it)</a:t>
                       </a:r>
-                      <a:endParaRPr lang="en-US" sz="1150" dirty="0">
+                      <a:endParaRPr lang="en-US" sz="1100" dirty="0">
                         <a:latin typeface="Calibri" charset="0"/>
                         <a:ea typeface="Calibri" charset="0"/>
                         <a:cs typeface="Calibri" charset="0"/>
@@ -7348,14 +7084,14 @@
                         <a:buNone/>
                       </a:pPr>
                       <a:r>
-                        <a:rPr lang="en-US" sz="1150" u="sng" dirty="0">
+                        <a:rPr lang="en-US" sz="1100" u="sng" dirty="0">
                           <a:solidFill>
                             <a:srgbClr val="1F8A9C"/>
                           </a:solidFill>
                           <a:latin typeface="Calibri" pitchFamily="34" charset="0"/>
                           <a:ea typeface="Calibri" pitchFamily="34" charset="-122"/>
                           <a:cs typeface="Calibri" pitchFamily="34" charset="-120"/>
-                          <a:hlinkClick r:id="rId4" invalidUrl="" action="" tgtFrame="" tooltip="https://www.adafruit.com/product/1578" history="1" highlightClick="0" endSnd="0">
+                          <a:hlinkClick r:id="rId4" invalidUrl="" action="" tgtFrame="" tooltip="https://www.amazon.ca/Battery-Rechargeable-Lithium-Polymer-Connector/dp/B07S84SBV3" history="1" highlightClick="0" endSnd="0">
                             <a:extLst>
                               <a:ext uri="{A12FA001-AC4F-418D-AE19-62706E023703}">
                                 <ahyp:hlinkClr xmlns:ahyp="http://schemas.microsoft.com/office/drawing/2018/hyperlinkcolor" val="tx"/>
@@ -7363,74 +7099,9 @@
                             </a:extLst>
                           </a:hlinkClick>
                         </a:rPr>
-                        <a:t>Adafruit</a:t>
+                        <a:t>Amazon.ca</a:t>
                       </a:r>
-                      <a:endParaRPr lang="en-US" sz="1150" dirty="0">
-                        <a:latin typeface="Calibri" charset="0"/>
-                        <a:ea typeface="Calibri" charset="0"/>
-                        <a:cs typeface="Calibri" charset="0"/>
-                      </a:endParaRPr>
-                    </a:p>
-                  </a:txBody>
-                  <a:tcPr marL="91440" marR="91440" marT="45720" marB="45720" anchor="ctr">
-                    <a:lnL w="12700" cap="flat" cmpd="sng" algn="ctr">
-                      <a:solidFill>
-                        <a:srgbClr val="DBE1EC"/>
-                      </a:solidFill>
-                      <a:prstDash val="solid"/>
-                      <a:round/>
-                      <a:headEnd type="none" w="med" len="med"/>
-                      <a:tailEnd type="none" w="med" len="med"/>
-                    </a:lnL>
-                    <a:lnR w="12700" cap="flat" cmpd="sng" algn="ctr">
-                      <a:solidFill>
-                        <a:srgbClr val="DBE1EC"/>
-                      </a:solidFill>
-                      <a:prstDash val="solid"/>
-                      <a:round/>
-                      <a:headEnd type="none" w="med" len="med"/>
-                      <a:tailEnd type="none" w="med" len="med"/>
-                    </a:lnR>
-                    <a:lnT w="12700" cap="flat" cmpd="sng" algn="ctr">
-                      <a:solidFill>
-                        <a:srgbClr val="DBE1EC"/>
-                      </a:solidFill>
-                      <a:prstDash val="solid"/>
-                      <a:round/>
-                      <a:headEnd type="none" w="med" len="med"/>
-                      <a:tailEnd type="none" w="med" len="med"/>
-                    </a:lnT>
-                    <a:lnB w="12700" cap="flat" cmpd="sng" algn="ctr">
-                      <a:solidFill>
-                        <a:srgbClr val="DBE1EC"/>
-                      </a:solidFill>
-                      <a:prstDash val="solid"/>
-                      <a:round/>
-                      <a:headEnd type="none" w="med" len="med"/>
-                      <a:tailEnd type="none" w="med" len="med"/>
-                    </a:lnB>
-                  </a:tcPr>
-                </a:tc>
-                <a:tc>
-                  <a:txBody>
-                    <a:bodyPr/>
-                    <a:lstStyle/>
-                    <a:p>
-                      <a:pPr indent="0" marL="0">
-                        <a:buNone/>
-                      </a:pPr>
-                      <a:r>
-                        <a:rPr lang="en-US" sz="1150" dirty="0">
-                          <a:solidFill>
-                            <a:srgbClr val="141A26"/>
-                          </a:solidFill>
-                          <a:latin typeface="Calibri" pitchFamily="34" charset="0"/>
-                          <a:ea typeface="Calibri" pitchFamily="34" charset="-122"/>
-                          <a:cs typeface="Calibri" pitchFamily="34" charset="-120"/>
-                        </a:rPr>
-                        <a:t>≈ $12</a:t>
-                      </a:r>
-                      <a:endParaRPr lang="en-US" sz="1150" dirty="0">
+                      <a:endParaRPr lang="en-US" sz="1100" dirty="0">
                         <a:latin typeface="Calibri" charset="0"/>
                         <a:ea typeface="Calibri" charset="0"/>
                         <a:cs typeface="Calibri" charset="0"/>
@@ -7487,7 +7158,7 @@
                         <a:buNone/>
                       </a:pPr>
                       <a:r>
-                        <a:rPr lang="en-US" sz="1150" dirty="0">
+                        <a:rPr lang="en-US" sz="1100" dirty="0">
                           <a:solidFill>
                             <a:srgbClr val="141A26"/>
                           </a:solidFill>
@@ -7495,9 +7166,9 @@
                           <a:ea typeface="Calibri" pitchFamily="34" charset="-122"/>
                           <a:cs typeface="Calibri" pitchFamily="34" charset="-120"/>
                         </a:rPr>
-                        <a:t>TP4056 USB-C charger</a:t>
+                        <a:t>Treedix TP4056 USB-C charger (6-pack)</a:t>
                       </a:r>
-                      <a:endParaRPr lang="en-US" sz="1150" dirty="0">
+                      <a:endParaRPr lang="en-US" sz="1100" dirty="0">
                         <a:latin typeface="Calibri" charset="0"/>
                         <a:ea typeface="Calibri" charset="0"/>
                         <a:cs typeface="Calibri" charset="0"/>
@@ -7552,7 +7223,7 @@
                         <a:buNone/>
                       </a:pPr>
                       <a:r>
-                        <a:rPr lang="en-US" sz="1150" dirty="0">
+                        <a:rPr lang="en-US" sz="1100" dirty="0">
                           <a:solidFill>
                             <a:srgbClr val="141A26"/>
                           </a:solidFill>
@@ -7562,7 +7233,7 @@
                         </a:rPr>
                         <a:t>≈ 28 × 17 mm</a:t>
                       </a:r>
-                      <a:endParaRPr lang="en-US" sz="1150" dirty="0">
+                      <a:endParaRPr lang="en-US" sz="1100" dirty="0">
                         <a:latin typeface="Calibri" charset="0"/>
                         <a:ea typeface="Calibri" charset="0"/>
                         <a:cs typeface="Calibri" charset="0"/>
@@ -7617,7 +7288,7 @@
                         <a:buNone/>
                       </a:pPr>
                       <a:r>
-                        <a:rPr lang="en-US" sz="1150" dirty="0">
+                        <a:rPr lang="en-US" sz="1100" dirty="0">
                           <a:solidFill>
                             <a:srgbClr val="141A26"/>
                           </a:solidFill>
@@ -7625,9 +7296,9 @@
                           <a:ea typeface="Calibri" pitchFamily="34" charset="-122"/>
                           <a:cs typeface="Calibri" pitchFamily="34" charset="-120"/>
                         </a:rPr>
-                        <a:t>Charges battery</a:t>
+                        <a:t>Charges the battery safely</a:t>
                       </a:r>
-                      <a:endParaRPr lang="en-US" sz="1150" dirty="0">
+                      <a:endParaRPr lang="en-US" sz="1100" dirty="0">
                         <a:latin typeface="Calibri" charset="0"/>
                         <a:ea typeface="Calibri" charset="0"/>
                         <a:cs typeface="Calibri" charset="0"/>
@@ -7682,14 +7353,14 @@
                         <a:buNone/>
                       </a:pPr>
                       <a:r>
-                        <a:rPr lang="en-US" sz="1150" u="sng" dirty="0">
+                        <a:rPr lang="en-US" sz="1100" u="sng" dirty="0">
                           <a:solidFill>
                             <a:srgbClr val="1F8A9C"/>
                           </a:solidFill>
                           <a:latin typeface="Calibri" pitchFamily="34" charset="0"/>
                           <a:ea typeface="Calibri" pitchFamily="34" charset="-122"/>
                           <a:cs typeface="Calibri" pitchFamily="34" charset="-120"/>
-                          <a:hlinkClick r:id="rId5" invalidUrl="" action="" tgtFrame="" tooltip="https://www.amazon.ca/s?k=TP4056+type+c+lithium+charger+module+protection" history="1" highlightClick="0" endSnd="0">
+                          <a:hlinkClick r:id="rId5" invalidUrl="" action="" tgtFrame="" tooltip="https://www.amazon.ca/Treedix-Lithium-Charging-Protection-Functions/dp/B09LTVTY5J" history="1" highlightClick="0" endSnd="0">
                             <a:extLst>
                               <a:ext uri="{A12FA001-AC4F-418D-AE19-62706E023703}">
                                 <ahyp:hlinkClr xmlns:ahyp="http://schemas.microsoft.com/office/drawing/2018/hyperlinkcolor" val="tx"/>
@@ -7699,72 +7370,7 @@
                         </a:rPr>
                         <a:t>Amazon.ca</a:t>
                       </a:r>
-                      <a:endParaRPr lang="en-US" sz="1150" dirty="0">
-                        <a:latin typeface="Calibri" charset="0"/>
-                        <a:ea typeface="Calibri" charset="0"/>
-                        <a:cs typeface="Calibri" charset="0"/>
-                      </a:endParaRPr>
-                    </a:p>
-                  </a:txBody>
-                  <a:tcPr marL="91440" marR="91440" marT="45720" marB="45720" anchor="ctr">
-                    <a:lnL w="12700" cap="flat" cmpd="sng" algn="ctr">
-                      <a:solidFill>
-                        <a:srgbClr val="DBE1EC"/>
-                      </a:solidFill>
-                      <a:prstDash val="solid"/>
-                      <a:round/>
-                      <a:headEnd type="none" w="med" len="med"/>
-                      <a:tailEnd type="none" w="med" len="med"/>
-                    </a:lnL>
-                    <a:lnR w="12700" cap="flat" cmpd="sng" algn="ctr">
-                      <a:solidFill>
-                        <a:srgbClr val="DBE1EC"/>
-                      </a:solidFill>
-                      <a:prstDash val="solid"/>
-                      <a:round/>
-                      <a:headEnd type="none" w="med" len="med"/>
-                      <a:tailEnd type="none" w="med" len="med"/>
-                    </a:lnR>
-                    <a:lnT w="12700" cap="flat" cmpd="sng" algn="ctr">
-                      <a:solidFill>
-                        <a:srgbClr val="DBE1EC"/>
-                      </a:solidFill>
-                      <a:prstDash val="solid"/>
-                      <a:round/>
-                      <a:headEnd type="none" w="med" len="med"/>
-                      <a:tailEnd type="none" w="med" len="med"/>
-                    </a:lnT>
-                    <a:lnB w="12700" cap="flat" cmpd="sng" algn="ctr">
-                      <a:solidFill>
-                        <a:srgbClr val="DBE1EC"/>
-                      </a:solidFill>
-                      <a:prstDash val="solid"/>
-                      <a:round/>
-                      <a:headEnd type="none" w="med" len="med"/>
-                      <a:tailEnd type="none" w="med" len="med"/>
-                    </a:lnB>
-                  </a:tcPr>
-                </a:tc>
-                <a:tc>
-                  <a:txBody>
-                    <a:bodyPr/>
-                    <a:lstStyle/>
-                    <a:p>
-                      <a:pPr indent="0" marL="0">
-                        <a:buNone/>
-                      </a:pPr>
-                      <a:r>
-                        <a:rPr lang="en-US" sz="1150" dirty="0">
-                          <a:solidFill>
-                            <a:srgbClr val="141A26"/>
-                          </a:solidFill>
-                          <a:latin typeface="Calibri" pitchFamily="34" charset="0"/>
-                          <a:ea typeface="Calibri" pitchFamily="34" charset="-122"/>
-                          <a:cs typeface="Calibri" pitchFamily="34" charset="-120"/>
-                        </a:rPr>
-                        <a:t>≈ $3</a:t>
-                      </a:r>
-                      <a:endParaRPr lang="en-US" sz="1150" dirty="0">
+                      <a:endParaRPr lang="en-US" sz="1100" dirty="0">
                         <a:latin typeface="Calibri" charset="0"/>
                         <a:ea typeface="Calibri" charset="0"/>
                         <a:cs typeface="Calibri" charset="0"/>
@@ -7821,7 +7427,7 @@
                         <a:buNone/>
                       </a:pPr>
                       <a:r>
-                        <a:rPr lang="en-US" sz="1150" dirty="0">
+                        <a:rPr lang="en-US" sz="1100" dirty="0">
                           <a:solidFill>
                             <a:srgbClr val="141A26"/>
                           </a:solidFill>
@@ -7829,9 +7435,9 @@
                           <a:ea typeface="Calibri" pitchFamily="34" charset="-122"/>
                           <a:cs typeface="Calibri" pitchFamily="34" charset="-120"/>
                         </a:rPr>
-                        <a:t>Pololu 3.3 V regulator S7V8F3</a:t>
+                        <a:t>Rakstore TPS63020 3.3 V buck-boost</a:t>
                       </a:r>
-                      <a:endParaRPr lang="en-US" sz="1150" dirty="0">
+                      <a:endParaRPr lang="en-US" sz="1100" dirty="0">
                         <a:latin typeface="Calibri" charset="0"/>
                         <a:ea typeface="Calibri" charset="0"/>
                         <a:cs typeface="Calibri" charset="0"/>
@@ -7886,7 +7492,7 @@
                         <a:buNone/>
                       </a:pPr>
                       <a:r>
-                        <a:rPr lang="en-US" sz="1150" dirty="0">
+                        <a:rPr lang="en-US" sz="1100" dirty="0">
                           <a:solidFill>
                             <a:srgbClr val="141A26"/>
                           </a:solidFill>
@@ -7894,9 +7500,9 @@
                           <a:ea typeface="Calibri" pitchFamily="34" charset="-122"/>
                           <a:cs typeface="Calibri" pitchFamily="34" charset="-120"/>
                         </a:rPr>
-                        <a:t>11 × 17 × 3 mm</a:t>
+                        <a:t>1.8–5 V in → 3.3 V out</a:t>
                       </a:r>
-                      <a:endParaRPr lang="en-US" sz="1150" dirty="0">
+                      <a:endParaRPr lang="en-US" sz="1100" dirty="0">
                         <a:latin typeface="Calibri" charset="0"/>
                         <a:ea typeface="Calibri" charset="0"/>
                         <a:cs typeface="Calibri" charset="0"/>
@@ -7951,7 +7557,7 @@
                         <a:buNone/>
                       </a:pPr>
                       <a:r>
-                        <a:rPr lang="en-US" sz="1150" dirty="0">
+                        <a:rPr lang="en-US" sz="1100" dirty="0">
                           <a:solidFill>
                             <a:srgbClr val="141A26"/>
                           </a:solidFill>
@@ -7959,9 +7565,9 @@
                           <a:ea typeface="Calibri" pitchFamily="34" charset="-122"/>
                           <a:cs typeface="Calibri" pitchFamily="34" charset="-120"/>
                         </a:rPr>
-                        <a:t>Steady 3.3 V</a:t>
+                        <a:t>Steady 3.3 V as the battery drains</a:t>
                       </a:r>
-                      <a:endParaRPr lang="en-US" sz="1150" dirty="0">
+                      <a:endParaRPr lang="en-US" sz="1100" dirty="0">
                         <a:latin typeface="Calibri" charset="0"/>
                         <a:ea typeface="Calibri" charset="0"/>
                         <a:cs typeface="Calibri" charset="0"/>
@@ -8016,14 +7622,14 @@
                         <a:buNone/>
                       </a:pPr>
                       <a:r>
-                        <a:rPr lang="en-US" sz="1150" u="sng" dirty="0">
+                        <a:rPr lang="en-US" sz="1100" u="sng" dirty="0">
                           <a:solidFill>
                             <a:srgbClr val="1F8A9C"/>
                           </a:solidFill>
                           <a:latin typeface="Calibri" pitchFamily="34" charset="0"/>
                           <a:ea typeface="Calibri" pitchFamily="34" charset="-122"/>
                           <a:cs typeface="Calibri" pitchFamily="34" charset="-120"/>
-                          <a:hlinkClick r:id="rId6" invalidUrl="" action="" tgtFrame="" tooltip="https://www.pololu.com/product/2122" history="1" highlightClick="0" endSnd="0">
+                          <a:hlinkClick r:id="rId6" invalidUrl="" action="" tgtFrame="" tooltip="https://www.amazon.ca/Rakstore-TPS63020-Automatic-Buck-Boost-Converter/dp/B09V4SHLTJ" history="1" highlightClick="0" endSnd="0">
                             <a:extLst>
                               <a:ext uri="{A12FA001-AC4F-418D-AE19-62706E023703}">
                                 <ahyp:hlinkClr xmlns:ahyp="http://schemas.microsoft.com/office/drawing/2018/hyperlinkcolor" val="tx"/>
@@ -8031,74 +7637,9 @@
                             </a:extLst>
                           </a:hlinkClick>
                         </a:rPr>
-                        <a:t>Pololu</a:t>
+                        <a:t>Amazon.ca</a:t>
                       </a:r>
-                      <a:endParaRPr lang="en-US" sz="1150" dirty="0">
-                        <a:latin typeface="Calibri" charset="0"/>
-                        <a:ea typeface="Calibri" charset="0"/>
-                        <a:cs typeface="Calibri" charset="0"/>
-                      </a:endParaRPr>
-                    </a:p>
-                  </a:txBody>
-                  <a:tcPr marL="91440" marR="91440" marT="45720" marB="45720" anchor="ctr">
-                    <a:lnL w="12700" cap="flat" cmpd="sng" algn="ctr">
-                      <a:solidFill>
-                        <a:srgbClr val="DBE1EC"/>
-                      </a:solidFill>
-                      <a:prstDash val="solid"/>
-                      <a:round/>
-                      <a:headEnd type="none" w="med" len="med"/>
-                      <a:tailEnd type="none" w="med" len="med"/>
-                    </a:lnL>
-                    <a:lnR w="12700" cap="flat" cmpd="sng" algn="ctr">
-                      <a:solidFill>
-                        <a:srgbClr val="DBE1EC"/>
-                      </a:solidFill>
-                      <a:prstDash val="solid"/>
-                      <a:round/>
-                      <a:headEnd type="none" w="med" len="med"/>
-                      <a:tailEnd type="none" w="med" len="med"/>
-                    </a:lnR>
-                    <a:lnT w="12700" cap="flat" cmpd="sng" algn="ctr">
-                      <a:solidFill>
-                        <a:srgbClr val="DBE1EC"/>
-                      </a:solidFill>
-                      <a:prstDash val="solid"/>
-                      <a:round/>
-                      <a:headEnd type="none" w="med" len="med"/>
-                      <a:tailEnd type="none" w="med" len="med"/>
-                    </a:lnT>
-                    <a:lnB w="12700" cap="flat" cmpd="sng" algn="ctr">
-                      <a:solidFill>
-                        <a:srgbClr val="DBE1EC"/>
-                      </a:solidFill>
-                      <a:prstDash val="solid"/>
-                      <a:round/>
-                      <a:headEnd type="none" w="med" len="med"/>
-                      <a:tailEnd type="none" w="med" len="med"/>
-                    </a:lnB>
-                  </a:tcPr>
-                </a:tc>
-                <a:tc>
-                  <a:txBody>
-                    <a:bodyPr/>
-                    <a:lstStyle/>
-                    <a:p>
-                      <a:pPr indent="0" marL="0">
-                        <a:buNone/>
-                      </a:pPr>
-                      <a:r>
-                        <a:rPr lang="en-US" sz="1150" dirty="0">
-                          <a:solidFill>
-                            <a:srgbClr val="141A26"/>
-                          </a:solidFill>
-                          <a:latin typeface="Calibri" pitchFamily="34" charset="0"/>
-                          <a:ea typeface="Calibri" pitchFamily="34" charset="-122"/>
-                          <a:cs typeface="Calibri" pitchFamily="34" charset="-120"/>
-                        </a:rPr>
-                        <a:t>≈ $8</a:t>
-                      </a:r>
-                      <a:endParaRPr lang="en-US" sz="1150" dirty="0">
+                      <a:endParaRPr lang="en-US" sz="1100" dirty="0">
                         <a:latin typeface="Calibri" charset="0"/>
                         <a:ea typeface="Calibri" charset="0"/>
                         <a:cs typeface="Calibri" charset="0"/>
@@ -8155,7 +7696,7 @@
                         <a:buNone/>
                       </a:pPr>
                       <a:r>
-                        <a:rPr lang="en-US" sz="1150" dirty="0">
+                        <a:rPr lang="en-US" sz="1100" dirty="0">
                           <a:solidFill>
                             <a:srgbClr val="141A26"/>
                           </a:solidFill>
@@ -8163,9 +7704,9 @@
                           <a:ea typeface="Calibri" pitchFamily="34" charset="-122"/>
                           <a:cs typeface="Calibri" pitchFamily="34" charset="-120"/>
                         </a:rPr>
-                        <a:t>Hammond 1551HBK case</a:t>
+                        <a:t>HoHaing ABS project box (8-pack)</a:t>
                       </a:r>
-                      <a:endParaRPr lang="en-US" sz="1150" dirty="0">
+                      <a:endParaRPr lang="en-US" sz="1100" dirty="0">
                         <a:latin typeface="Calibri" charset="0"/>
                         <a:ea typeface="Calibri" charset="0"/>
                         <a:cs typeface="Calibri" charset="0"/>
@@ -8220,7 +7761,7 @@
                         <a:buNone/>
                       </a:pPr>
                       <a:r>
-                        <a:rPr lang="en-US" sz="1150" dirty="0">
+                        <a:rPr lang="en-US" sz="1100" dirty="0">
                           <a:solidFill>
                             <a:srgbClr val="141A26"/>
                           </a:solidFill>
@@ -8228,9 +7769,9 @@
                           <a:ea typeface="Calibri" pitchFamily="34" charset="-122"/>
                           <a:cs typeface="Calibri" pitchFamily="34" charset="-120"/>
                         </a:rPr>
-                        <a:t>60 × 35 × 20 mm</a:t>
+                        <a:t>70 × 45 × 29 mm · inside 66 × 41 × 25 mm</a:t>
                       </a:r>
-                      <a:endParaRPr lang="en-US" sz="1150" dirty="0">
+                      <a:endParaRPr lang="en-US" sz="1100" dirty="0">
                         <a:latin typeface="Calibri" charset="0"/>
                         <a:ea typeface="Calibri" charset="0"/>
                         <a:cs typeface="Calibri" charset="0"/>
@@ -8285,7 +7826,7 @@
                         <a:buNone/>
                       </a:pPr>
                       <a:r>
-                        <a:rPr lang="en-US" sz="1150" dirty="0">
+                        <a:rPr lang="en-US" sz="1100" dirty="0">
                           <a:solidFill>
                             <a:srgbClr val="141A26"/>
                           </a:solidFill>
@@ -8293,9 +7834,9 @@
                           <a:ea typeface="Calibri" pitchFamily="34" charset="-122"/>
                           <a:cs typeface="Calibri" pitchFamily="34" charset="-120"/>
                         </a:rPr>
-                        <a:t>Holds the boards</a:t>
+                        <a:t>The sensor case</a:t>
                       </a:r>
-                      <a:endParaRPr lang="en-US" sz="1150" dirty="0">
+                      <a:endParaRPr lang="en-US" sz="1100" dirty="0">
                         <a:latin typeface="Calibri" charset="0"/>
                         <a:ea typeface="Calibri" charset="0"/>
                         <a:cs typeface="Calibri" charset="0"/>
@@ -8350,14 +7891,14 @@
                         <a:buNone/>
                       </a:pPr>
                       <a:r>
-                        <a:rPr lang="en-US" sz="1150" u="sng" dirty="0">
+                        <a:rPr lang="en-US" sz="1100" u="sng" dirty="0">
                           <a:solidFill>
                             <a:srgbClr val="1F8A9C"/>
                           </a:solidFill>
                           <a:latin typeface="Calibri" pitchFamily="34" charset="0"/>
                           <a:ea typeface="Calibri" pitchFamily="34" charset="-122"/>
                           <a:cs typeface="Calibri" pitchFamily="34" charset="-120"/>
-                          <a:hlinkClick r:id="rId7" invalidUrl="" action="" tgtFrame="" tooltip="https://www.hammfg.com/electronics/small-case/plastic/1551" history="1" highlightClick="0" endSnd="0">
+                          <a:hlinkClick r:id="rId7" invalidUrl="" action="" tgtFrame="" tooltip="https://www.amazon.ca/HoHaing-Electrical-Junction-Enclosure-Electronic/dp/B0CGV22KKG" history="1" highlightClick="0" endSnd="0">
                             <a:extLst>
                               <a:ext uri="{A12FA001-AC4F-418D-AE19-62706E023703}">
                                 <ahyp:hlinkClr xmlns:ahyp="http://schemas.microsoft.com/office/drawing/2018/hyperlinkcolor" val="tx"/>
@@ -8365,74 +7906,9 @@
                             </a:extLst>
                           </a:hlinkClick>
                         </a:rPr>
-                        <a:t>Hammond</a:t>
+                        <a:t>Amazon.ca</a:t>
                       </a:r>
-                      <a:endParaRPr lang="en-US" sz="1150" dirty="0">
-                        <a:latin typeface="Calibri" charset="0"/>
-                        <a:ea typeface="Calibri" charset="0"/>
-                        <a:cs typeface="Calibri" charset="0"/>
-                      </a:endParaRPr>
-                    </a:p>
-                  </a:txBody>
-                  <a:tcPr marL="91440" marR="91440" marT="45720" marB="45720" anchor="ctr">
-                    <a:lnL w="12700" cap="flat" cmpd="sng" algn="ctr">
-                      <a:solidFill>
-                        <a:srgbClr val="DBE1EC"/>
-                      </a:solidFill>
-                      <a:prstDash val="solid"/>
-                      <a:round/>
-                      <a:headEnd type="none" w="med" len="med"/>
-                      <a:tailEnd type="none" w="med" len="med"/>
-                    </a:lnL>
-                    <a:lnR w="12700" cap="flat" cmpd="sng" algn="ctr">
-                      <a:solidFill>
-                        <a:srgbClr val="DBE1EC"/>
-                      </a:solidFill>
-                      <a:prstDash val="solid"/>
-                      <a:round/>
-                      <a:headEnd type="none" w="med" len="med"/>
-                      <a:tailEnd type="none" w="med" len="med"/>
-                    </a:lnR>
-                    <a:lnT w="12700" cap="flat" cmpd="sng" algn="ctr">
-                      <a:solidFill>
-                        <a:srgbClr val="DBE1EC"/>
-                      </a:solidFill>
-                      <a:prstDash val="solid"/>
-                      <a:round/>
-                      <a:headEnd type="none" w="med" len="med"/>
-                      <a:tailEnd type="none" w="med" len="med"/>
-                    </a:lnT>
-                    <a:lnB w="12700" cap="flat" cmpd="sng" algn="ctr">
-                      <a:solidFill>
-                        <a:srgbClr val="DBE1EC"/>
-                      </a:solidFill>
-                      <a:prstDash val="solid"/>
-                      <a:round/>
-                      <a:headEnd type="none" w="med" len="med"/>
-                      <a:tailEnd type="none" w="med" len="med"/>
-                    </a:lnB>
-                  </a:tcPr>
-                </a:tc>
-                <a:tc>
-                  <a:txBody>
-                    <a:bodyPr/>
-                    <a:lstStyle/>
-                    <a:p>
-                      <a:pPr indent="0" marL="0">
-                        <a:buNone/>
-                      </a:pPr>
-                      <a:r>
-                        <a:rPr lang="en-US" sz="1150" dirty="0">
-                          <a:solidFill>
-                            <a:srgbClr val="141A26"/>
-                          </a:solidFill>
-                          <a:latin typeface="Calibri" pitchFamily="34" charset="0"/>
-                          <a:ea typeface="Calibri" pitchFamily="34" charset="-122"/>
-                          <a:cs typeface="Calibri" pitchFamily="34" charset="-120"/>
-                        </a:rPr>
-                        <a:t>≈ $6</a:t>
-                      </a:r>
-                      <a:endParaRPr lang="en-US" sz="1150" dirty="0">
+                      <a:endParaRPr lang="en-US" sz="1100" dirty="0">
                         <a:latin typeface="Calibri" charset="0"/>
                         <a:ea typeface="Calibri" charset="0"/>
                         <a:cs typeface="Calibri" charset="0"/>
@@ -8489,7 +7965,7 @@
                         <a:buNone/>
                       </a:pPr>
                       <a:r>
-                        <a:rPr lang="en-US" sz="1150" dirty="0">
+                        <a:rPr lang="en-US" sz="1100" dirty="0">
                           <a:solidFill>
                             <a:srgbClr val="141A26"/>
                           </a:solidFill>
@@ -8497,9 +7973,9 @@
                           <a:ea typeface="Calibri" pitchFamily="34" charset="-122"/>
                           <a:cs typeface="Calibri" pitchFamily="34" charset="-120"/>
                         </a:rPr>
-                        <a:t>Velcro one-wrap strap</a:t>
+                        <a:t>VELCRO Brand 1 in × 30 ft roll</a:t>
                       </a:r>
-                      <a:endParaRPr lang="en-US" sz="1150" dirty="0">
+                      <a:endParaRPr lang="en-US" sz="1100" dirty="0">
                         <a:latin typeface="Calibri" charset="0"/>
                         <a:ea typeface="Calibri" charset="0"/>
                         <a:cs typeface="Calibri" charset="0"/>
@@ -8554,7 +8030,7 @@
                         <a:buNone/>
                       </a:pPr>
                       <a:r>
-                        <a:rPr lang="en-US" sz="1150" dirty="0">
+                        <a:rPr lang="en-US" sz="1100" dirty="0">
                           <a:solidFill>
                             <a:srgbClr val="141A26"/>
                           </a:solidFill>
@@ -8562,9 +8038,9 @@
                           <a:ea typeface="Calibri" pitchFamily="34" charset="-122"/>
                           <a:cs typeface="Calibri" pitchFamily="34" charset="-120"/>
                         </a:rPr>
-                        <a:t>25 mm × ≈ 250 mm</a:t>
+                        <a:t>25 mm wide · cut ≈ 300 mm + ≈ 80 mm</a:t>
                       </a:r>
-                      <a:endParaRPr lang="en-US" sz="1150" dirty="0">
+                      <a:endParaRPr lang="en-US" sz="1100" dirty="0">
                         <a:latin typeface="Calibri" charset="0"/>
                         <a:ea typeface="Calibri" charset="0"/>
                         <a:cs typeface="Calibri" charset="0"/>
@@ -8619,7 +8095,7 @@
                         <a:buNone/>
                       </a:pPr>
                       <a:r>
-                        <a:rPr lang="en-US" sz="1150" dirty="0">
+                        <a:rPr lang="en-US" sz="1100" dirty="0">
                           <a:solidFill>
                             <a:srgbClr val="141A26"/>
                           </a:solidFill>
@@ -8627,9 +8103,9 @@
                           <a:ea typeface="Calibri" pitchFamily="34" charset="-122"/>
                           <a:cs typeface="Calibri" pitchFamily="34" charset="-120"/>
                         </a:rPr>
-                        <a:t>Arm strap + finger cuff</a:t>
+                        <a:t>Arm strap + finger loop</a:t>
                       </a:r>
-                      <a:endParaRPr lang="en-US" sz="1150" dirty="0">
+                      <a:endParaRPr lang="en-US" sz="1100" dirty="0">
                         <a:latin typeface="Calibri" charset="0"/>
                         <a:ea typeface="Calibri" charset="0"/>
                         <a:cs typeface="Calibri" charset="0"/>
@@ -8684,14 +8160,14 @@
                         <a:buNone/>
                       </a:pPr>
                       <a:r>
-                        <a:rPr lang="en-US" sz="1150" u="sng" dirty="0">
+                        <a:rPr lang="en-US" sz="1100" u="sng" dirty="0">
                           <a:solidFill>
                             <a:srgbClr val="1F8A9C"/>
                           </a:solidFill>
                           <a:latin typeface="Calibri" pitchFamily="34" charset="0"/>
                           <a:ea typeface="Calibri" pitchFamily="34" charset="-122"/>
                           <a:cs typeface="Calibri" pitchFamily="34" charset="-120"/>
-                          <a:hlinkClick r:id="rId8" invalidUrl="" action="" tgtFrame="" tooltip="https://www.amazon.ca/s?k=velcro+one-wrap+strap+1+inch" history="1" highlightClick="0" endSnd="0">
+                          <a:hlinkClick r:id="rId8" invalidUrl="" action="" tgtFrame="" tooltip="https://www.amazon.ca/VELCRO-Brand-VEL-30768-AMS-Self-Gripping-Organization/dp/B09QH2NVM1" history="1" highlightClick="0" endSnd="0">
                             <a:extLst>
                               <a:ext uri="{A12FA001-AC4F-418D-AE19-62706E023703}">
                                 <ahyp:hlinkClr xmlns:ahyp="http://schemas.microsoft.com/office/drawing/2018/hyperlinkcolor" val="tx"/>
@@ -8701,72 +8177,7 @@
                         </a:rPr>
                         <a:t>Amazon.ca</a:t>
                       </a:r>
-                      <a:endParaRPr lang="en-US" sz="1150" dirty="0">
-                        <a:latin typeface="Calibri" charset="0"/>
-                        <a:ea typeface="Calibri" charset="0"/>
-                        <a:cs typeface="Calibri" charset="0"/>
-                      </a:endParaRPr>
-                    </a:p>
-                  </a:txBody>
-                  <a:tcPr marL="91440" marR="91440" marT="45720" marB="45720" anchor="ctr">
-                    <a:lnL w="12700" cap="flat" cmpd="sng" algn="ctr">
-                      <a:solidFill>
-                        <a:srgbClr val="DBE1EC"/>
-                      </a:solidFill>
-                      <a:prstDash val="solid"/>
-                      <a:round/>
-                      <a:headEnd type="none" w="med" len="med"/>
-                      <a:tailEnd type="none" w="med" len="med"/>
-                    </a:lnL>
-                    <a:lnR w="12700" cap="flat" cmpd="sng" algn="ctr">
-                      <a:solidFill>
-                        <a:srgbClr val="DBE1EC"/>
-                      </a:solidFill>
-                      <a:prstDash val="solid"/>
-                      <a:round/>
-                      <a:headEnd type="none" w="med" len="med"/>
-                      <a:tailEnd type="none" w="med" len="med"/>
-                    </a:lnR>
-                    <a:lnT w="12700" cap="flat" cmpd="sng" algn="ctr">
-                      <a:solidFill>
-                        <a:srgbClr val="DBE1EC"/>
-                      </a:solidFill>
-                      <a:prstDash val="solid"/>
-                      <a:round/>
-                      <a:headEnd type="none" w="med" len="med"/>
-                      <a:tailEnd type="none" w="med" len="med"/>
-                    </a:lnT>
-                    <a:lnB w="12700" cap="flat" cmpd="sng" algn="ctr">
-                      <a:solidFill>
-                        <a:srgbClr val="DBE1EC"/>
-                      </a:solidFill>
-                      <a:prstDash val="solid"/>
-                      <a:round/>
-                      <a:headEnd type="none" w="med" len="med"/>
-                      <a:tailEnd type="none" w="med" len="med"/>
-                    </a:lnB>
-                  </a:tcPr>
-                </a:tc>
-                <a:tc>
-                  <a:txBody>
-                    <a:bodyPr/>
-                    <a:lstStyle/>
-                    <a:p>
-                      <a:pPr indent="0" marL="0">
-                        <a:buNone/>
-                      </a:pPr>
-                      <a:r>
-                        <a:rPr lang="en-US" sz="1150" dirty="0">
-                          <a:solidFill>
-                            <a:srgbClr val="141A26"/>
-                          </a:solidFill>
-                          <a:latin typeface="Calibri" pitchFamily="34" charset="0"/>
-                          <a:ea typeface="Calibri" pitchFamily="34" charset="-122"/>
-                          <a:cs typeface="Calibri" pitchFamily="34" charset="-120"/>
-                        </a:rPr>
-                        <a:t>≈ $5</a:t>
-                      </a:r>
-                      <a:endParaRPr lang="en-US" sz="1150" dirty="0">
+                      <a:endParaRPr lang="en-US" sz="1100" dirty="0">
                         <a:latin typeface="Calibri" charset="0"/>
                         <a:ea typeface="Calibri" charset="0"/>
                         <a:cs typeface="Calibri" charset="0"/>
@@ -8823,7 +8234,7 @@
                         <a:buNone/>
                       </a:pPr>
                       <a:r>
-                        <a:rPr lang="en-US" sz="1150" dirty="0">
+                        <a:rPr lang="en-US" sz="1100" dirty="0">
                           <a:solidFill>
                             <a:srgbClr val="141A26"/>
                           </a:solidFill>
@@ -8831,9 +8242,9 @@
                           <a:ea typeface="Calibri" pitchFamily="34" charset="-122"/>
                           <a:cs typeface="Calibri" pitchFamily="34" charset="-120"/>
                         </a:rPr>
-                        <a:t>2 × 100 kΩ resistors, wire</a:t>
+                        <a:t>100 kΩ resistors (2) + jumper wires</a:t>
                       </a:r>
-                      <a:endParaRPr lang="en-US" sz="1150" dirty="0">
+                      <a:endParaRPr lang="en-US" sz="1100" dirty="0">
                         <a:latin typeface="Calibri" charset="0"/>
                         <a:ea typeface="Calibri" charset="0"/>
                         <a:cs typeface="Calibri" charset="0"/>
@@ -8888,7 +8299,7 @@
                         <a:buNone/>
                       </a:pPr>
                       <a:r>
-                        <a:rPr lang="en-US" sz="1150" dirty="0">
+                        <a:rPr lang="en-US" sz="1100" dirty="0">
                           <a:solidFill>
                             <a:srgbClr val="141A26"/>
                           </a:solidFill>
@@ -8896,9 +8307,9 @@
                           <a:ea typeface="Calibri" pitchFamily="34" charset="-122"/>
                           <a:cs typeface="Calibri" pitchFamily="34" charset="-120"/>
                         </a:rPr>
-                        <a:t>—</a:t>
+                        <a:t>1/4 W</a:t>
                       </a:r>
-                      <a:endParaRPr lang="en-US" sz="1150" dirty="0">
+                      <a:endParaRPr lang="en-US" sz="1100" dirty="0">
                         <a:latin typeface="Calibri" charset="0"/>
                         <a:ea typeface="Calibri" charset="0"/>
                         <a:cs typeface="Calibri" charset="0"/>
@@ -8953,7 +8364,7 @@
                         <a:buNone/>
                       </a:pPr>
                       <a:r>
-                        <a:rPr lang="en-US" sz="1150" dirty="0">
+                        <a:rPr lang="en-US" sz="1100" dirty="0">
                           <a:solidFill>
                             <a:srgbClr val="141A26"/>
                           </a:solidFill>
@@ -8961,9 +8372,9 @@
                           <a:ea typeface="Calibri" pitchFamily="34" charset="-122"/>
                           <a:cs typeface="Calibri" pitchFamily="34" charset="-120"/>
                         </a:rPr>
-                        <a:t>Battery level</a:t>
+                        <a:t>Battery-level reading on GPIO 34</a:t>
                       </a:r>
-                      <a:endParaRPr lang="en-US" sz="1150" dirty="0">
+                      <a:endParaRPr lang="en-US" sz="1100" dirty="0">
                         <a:latin typeface="Calibri" charset="0"/>
                         <a:ea typeface="Calibri" charset="0"/>
                         <a:cs typeface="Calibri" charset="0"/>
@@ -9018,14 +8429,14 @@
                         <a:buNone/>
                       </a:pPr>
                       <a:r>
-                        <a:rPr lang="en-US" sz="1150" u="sng" dirty="0">
+                        <a:rPr lang="en-US" sz="1100" u="sng" dirty="0">
                           <a:solidFill>
                             <a:srgbClr val="1F8A9C"/>
                           </a:solidFill>
                           <a:latin typeface="Calibri" pitchFamily="34" charset="0"/>
                           <a:ea typeface="Calibri" pitchFamily="34" charset="-122"/>
                           <a:cs typeface="Calibri" pitchFamily="34" charset="-120"/>
-                          <a:hlinkClick r:id="rId9" invalidUrl="" action="" tgtFrame="" tooltip="https://www.amazon.ca/s?k=resistor+kit+100k" history="1" highlightClick="0" endSnd="0">
+                          <a:hlinkClick r:id="rId9" invalidUrl="" action="" tgtFrame="" tooltip="https://www.amazon.ca/s?k=100k+ohm+resistor+1%2F4w" history="1" highlightClick="0" endSnd="0">
                             <a:extLst>
                               <a:ext uri="{A12FA001-AC4F-418D-AE19-62706E023703}">
                                 <ahyp:hlinkClr xmlns:ahyp="http://schemas.microsoft.com/office/drawing/2018/hyperlinkcolor" val="tx"/>
@@ -9035,72 +8446,7 @@
                         </a:rPr>
                         <a:t>Amazon.ca</a:t>
                       </a:r>
-                      <a:endParaRPr lang="en-US" sz="1150" dirty="0">
-                        <a:latin typeface="Calibri" charset="0"/>
-                        <a:ea typeface="Calibri" charset="0"/>
-                        <a:cs typeface="Calibri" charset="0"/>
-                      </a:endParaRPr>
-                    </a:p>
-                  </a:txBody>
-                  <a:tcPr marL="91440" marR="91440" marT="45720" marB="45720" anchor="ctr">
-                    <a:lnL w="12700" cap="flat" cmpd="sng" algn="ctr">
-                      <a:solidFill>
-                        <a:srgbClr val="DBE1EC"/>
-                      </a:solidFill>
-                      <a:prstDash val="solid"/>
-                      <a:round/>
-                      <a:headEnd type="none" w="med" len="med"/>
-                      <a:tailEnd type="none" w="med" len="med"/>
-                    </a:lnL>
-                    <a:lnR w="12700" cap="flat" cmpd="sng" algn="ctr">
-                      <a:solidFill>
-                        <a:srgbClr val="DBE1EC"/>
-                      </a:solidFill>
-                      <a:prstDash val="solid"/>
-                      <a:round/>
-                      <a:headEnd type="none" w="med" len="med"/>
-                      <a:tailEnd type="none" w="med" len="med"/>
-                    </a:lnR>
-                    <a:lnT w="12700" cap="flat" cmpd="sng" algn="ctr">
-                      <a:solidFill>
-                        <a:srgbClr val="DBE1EC"/>
-                      </a:solidFill>
-                      <a:prstDash val="solid"/>
-                      <a:round/>
-                      <a:headEnd type="none" w="med" len="med"/>
-                      <a:tailEnd type="none" w="med" len="med"/>
-                    </a:lnT>
-                    <a:lnB w="12700" cap="flat" cmpd="sng" algn="ctr">
-                      <a:solidFill>
-                        <a:srgbClr val="DBE1EC"/>
-                      </a:solidFill>
-                      <a:prstDash val="solid"/>
-                      <a:round/>
-                      <a:headEnd type="none" w="med" len="med"/>
-                      <a:tailEnd type="none" w="med" len="med"/>
-                    </a:lnB>
-                  </a:tcPr>
-                </a:tc>
-                <a:tc>
-                  <a:txBody>
-                    <a:bodyPr/>
-                    <a:lstStyle/>
-                    <a:p>
-                      <a:pPr indent="0" marL="0">
-                        <a:buNone/>
-                      </a:pPr>
-                      <a:r>
-                        <a:rPr lang="en-US" sz="1150" dirty="0">
-                          <a:solidFill>
-                            <a:srgbClr val="141A26"/>
-                          </a:solidFill>
-                          <a:latin typeface="Calibri" pitchFamily="34" charset="0"/>
-                          <a:ea typeface="Calibri" pitchFamily="34" charset="-122"/>
-                          <a:cs typeface="Calibri" pitchFamily="34" charset="-120"/>
-                        </a:rPr>
-                        <a:t>≈ $5</a:t>
-                      </a:r>
-                      <a:endParaRPr lang="en-US" sz="1150" dirty="0">
+                      <a:endParaRPr lang="en-US" sz="1100" dirty="0">
                         <a:latin typeface="Calibri" charset="0"/>
                         <a:ea typeface="Calibri" charset="0"/>
                         <a:cs typeface="Calibri" charset="0"/>
@@ -9157,7 +8503,7 @@
                         <a:buNone/>
                       </a:pPr>
                       <a:r>
-                        <a:rPr lang="en-US" sz="1150" dirty="0">
+                        <a:rPr lang="en-US" sz="1100" dirty="0">
                           <a:solidFill>
                             <a:srgbClr val="141A26"/>
                           </a:solidFill>
@@ -9165,9 +8511,9 @@
                           <a:ea typeface="Calibri" pitchFamily="34" charset="-122"/>
                           <a:cs typeface="Calibri" pitchFamily="34" charset="-120"/>
                         </a:rPr>
-                        <a:t>Fingertip pulse oximeter</a:t>
+                        <a:t>Elite Medica fingertip pulse oximeter</a:t>
                       </a:r>
-                      <a:endParaRPr lang="en-US" sz="1150" dirty="0">
+                      <a:endParaRPr lang="en-US" sz="1100" dirty="0">
                         <a:latin typeface="Calibri" charset="0"/>
                         <a:ea typeface="Calibri" charset="0"/>
                         <a:cs typeface="Calibri" charset="0"/>
@@ -9222,7 +8568,7 @@
                         <a:buNone/>
                       </a:pPr>
                       <a:r>
-                        <a:rPr lang="en-US" sz="1150" dirty="0">
+                        <a:rPr lang="en-US" sz="1100" dirty="0">
                           <a:solidFill>
                             <a:srgbClr val="141A26"/>
                           </a:solidFill>
@@ -9230,9 +8576,9 @@
                           <a:ea typeface="Calibri" pitchFamily="34" charset="-122"/>
                           <a:cs typeface="Calibri" pitchFamily="34" charset="-120"/>
                         </a:rPr>
-                        <a:t>—</a:t>
+                        <a:t>Health Canada authorized</a:t>
                       </a:r>
-                      <a:endParaRPr lang="en-US" sz="1150" dirty="0">
+                      <a:endParaRPr lang="en-US" sz="1100" dirty="0">
                         <a:latin typeface="Calibri" charset="0"/>
                         <a:ea typeface="Calibri" charset="0"/>
                         <a:cs typeface="Calibri" charset="0"/>
@@ -9287,7 +8633,7 @@
                         <a:buNone/>
                       </a:pPr>
                       <a:r>
-                        <a:rPr lang="en-US" sz="1150" dirty="0">
+                        <a:rPr lang="en-US" sz="1100" dirty="0">
                           <a:solidFill>
                             <a:srgbClr val="141A26"/>
                           </a:solidFill>
@@ -9295,9 +8641,9 @@
                           <a:ea typeface="Calibri" pitchFamily="34" charset="-122"/>
                           <a:cs typeface="Calibri" pitchFamily="34" charset="-120"/>
                         </a:rPr>
-                        <a:t>Accuracy reference</a:t>
+                        <a:t>Reference for the accuracy test</a:t>
                       </a:r>
-                      <a:endParaRPr lang="en-US" sz="1150" dirty="0">
+                      <a:endParaRPr lang="en-US" sz="1100" dirty="0">
                         <a:latin typeface="Calibri" charset="0"/>
                         <a:ea typeface="Calibri" charset="0"/>
                         <a:cs typeface="Calibri" charset="0"/>
@@ -9352,14 +8698,14 @@
                         <a:buNone/>
                       </a:pPr>
                       <a:r>
-                        <a:rPr lang="en-US" sz="1150" u="sng" dirty="0">
+                        <a:rPr lang="en-US" sz="1100" u="sng" dirty="0">
                           <a:solidFill>
                             <a:srgbClr val="1F8A9C"/>
                           </a:solidFill>
                           <a:latin typeface="Calibri" pitchFamily="34" charset="0"/>
                           <a:ea typeface="Calibri" pitchFamily="34" charset="-122"/>
                           <a:cs typeface="Calibri" pitchFamily="34" charset="-120"/>
-                          <a:hlinkClick r:id="rId10" invalidUrl="" action="" tgtFrame="" tooltip="https://www.amazon.ca/s?k=fingertip+pulse+oximeter" history="1" highlightClick="0" endSnd="0">
+                          <a:hlinkClick r:id="rId10" invalidUrl="" action="" tgtFrame="" tooltip="https://www.amazon.ca/Elite-Medica-Fingertip-Saturation-Batteries/dp/B0DSGP91PB" history="1" highlightClick="0" endSnd="0">
                             <a:extLst>
                               <a:ext uri="{A12FA001-AC4F-418D-AE19-62706E023703}">
                                 <ahyp:hlinkClr xmlns:ahyp="http://schemas.microsoft.com/office/drawing/2018/hyperlinkcolor" val="tx"/>
@@ -9369,7 +8715,7 @@
                         </a:rPr>
                         <a:t>Amazon.ca</a:t>
                       </a:r>
-                      <a:endParaRPr lang="en-US" sz="1150" dirty="0">
+                      <a:endParaRPr lang="en-US" sz="1100" dirty="0">
                         <a:latin typeface="Calibri" charset="0"/>
                         <a:ea typeface="Calibri" charset="0"/>
                         <a:cs typeface="Calibri" charset="0"/>
@@ -9415,71 +8761,6 @@
                     </a:lnB>
                   </a:tcPr>
                 </a:tc>
-                <a:tc>
-                  <a:txBody>
-                    <a:bodyPr/>
-                    <a:lstStyle/>
-                    <a:p>
-                      <a:pPr indent="0" marL="0">
-                        <a:buNone/>
-                      </a:pPr>
-                      <a:r>
-                        <a:rPr lang="en-US" sz="1150" dirty="0">
-                          <a:solidFill>
-                            <a:srgbClr val="141A26"/>
-                          </a:solidFill>
-                          <a:latin typeface="Calibri" pitchFamily="34" charset="0"/>
-                          <a:ea typeface="Calibri" pitchFamily="34" charset="-122"/>
-                          <a:cs typeface="Calibri" pitchFamily="34" charset="-120"/>
-                        </a:rPr>
-                        <a:t>≈ $25</a:t>
-                      </a:r>
-                      <a:endParaRPr lang="en-US" sz="1150" dirty="0">
-                        <a:latin typeface="Calibri" charset="0"/>
-                        <a:ea typeface="Calibri" charset="0"/>
-                        <a:cs typeface="Calibri" charset="0"/>
-                      </a:endParaRPr>
-                    </a:p>
-                  </a:txBody>
-                  <a:tcPr marL="91440" marR="91440" marT="45720" marB="45720" anchor="ctr">
-                    <a:lnL w="12700" cap="flat" cmpd="sng" algn="ctr">
-                      <a:solidFill>
-                        <a:srgbClr val="DBE1EC"/>
-                      </a:solidFill>
-                      <a:prstDash val="solid"/>
-                      <a:round/>
-                      <a:headEnd type="none" w="med" len="med"/>
-                      <a:tailEnd type="none" w="med" len="med"/>
-                    </a:lnL>
-                    <a:lnR w="12700" cap="flat" cmpd="sng" algn="ctr">
-                      <a:solidFill>
-                        <a:srgbClr val="DBE1EC"/>
-                      </a:solidFill>
-                      <a:prstDash val="solid"/>
-                      <a:round/>
-                      <a:headEnd type="none" w="med" len="med"/>
-                      <a:tailEnd type="none" w="med" len="med"/>
-                    </a:lnR>
-                    <a:lnT w="12700" cap="flat" cmpd="sng" algn="ctr">
-                      <a:solidFill>
-                        <a:srgbClr val="DBE1EC"/>
-                      </a:solidFill>
-                      <a:prstDash val="solid"/>
-                      <a:round/>
-                      <a:headEnd type="none" w="med" len="med"/>
-                      <a:tailEnd type="none" w="med" len="med"/>
-                    </a:lnT>
-                    <a:lnB w="12700" cap="flat" cmpd="sng" algn="ctr">
-                      <a:solidFill>
-                        <a:srgbClr val="DBE1EC"/>
-                      </a:solidFill>
-                      <a:prstDash val="solid"/>
-                      <a:round/>
-                      <a:headEnd type="none" w="med" len="med"/>
-                      <a:tailEnd type="none" w="med" len="med"/>
-                    </a:lnB>
-                  </a:tcPr>
-                </a:tc>
               </a:tr>
             </a:tbl>
           </a:graphicData>
@@ -9518,7 +8799,7 @@
                 <a:ea typeface="Calibri" pitchFamily="34" charset="-122"/>
                 <a:cs typeface="Calibri" pitchFamily="34" charset="-120"/>
               </a:rPr>
-              <a:t>Total ≈ $65 for the wearable + ≈ $25 reference oximeter. Board sizes vary about ±2 mm between sellers — measure before assembling.</a:t>
+              <a:t>Every part is on Amazon.ca (click Buy). Prices change and several items are multi-packs. Sizes from the listings — boards vary about ±2 mm, so measure yours.</a:t>
             </a:r>
             <a:endParaRPr lang="en-US" sz="1150" dirty="0"/>
           </a:p>
@@ -11145,7 +10426,7 @@
                           <a:ea typeface="Calibri" pitchFamily="34" charset="-122"/>
                           <a:cs typeface="Calibri" pitchFamily="34" charset="-120"/>
                         </a:rPr>
-                        <a:t>MPU-6050 VCC / GND</a:t>
+                        <a:t>GY-521 (MPU-6050) VCC / GND</a:t>
                       </a:r>
                       <a:endParaRPr lang="en-US" sz="1150" dirty="0">
                         <a:latin typeface="Calibri" charset="0"/>
@@ -11866,7 +11147,7 @@
                           <a:ea typeface="Calibri" pitchFamily="34" charset="-122"/>
                           <a:cs typeface="Calibri" pitchFamily="34" charset="-120"/>
                         </a:rPr>
-                        <a:t>Pololu S7V8F3</a:t>
+                        <a:t>TPS63020 3.3 V</a:t>
                       </a:r>
                       <a:endParaRPr lang="en-US" sz="1150" dirty="0">
                         <a:latin typeface="Calibri" charset="0"/>
@@ -12567,7 +11848,7 @@
                 <a:ea typeface="Calibri" pitchFamily="34" charset="-122"/>
                 <a:cs typeface="Calibri" pitchFamily="34" charset="-120"/>
               </a:rPr>
-              <a:t>Stack inside the 16 mm-tall case</a:t>
+              <a:t>Stack inside the 25 mm-tall case</a:t>
             </a:r>
             <a:endParaRPr lang="en-US" sz="1100" dirty="0"/>
           </a:p>
@@ -12606,7 +11887,7 @@
                 <a:ea typeface="Calibri" pitchFamily="34" charset="-122"/>
                 <a:cs typeface="Calibri" pitchFamily="34" charset="-120"/>
               </a:rPr>
-              <a:t>Layer heights: battery 4.75 mm + ESP32 (no header pins) ≈ 5 mm + MPU-6050 4.6 mm ≈ 15 mm ≤ 16 mm inside height. With header pins soldered, use a case at least 30 mm deep.</a:t>
+              <a:t>Layer heights: battery 6 mm + ESP32 with pins ≈ 13 mm + GY-521 ≈ 3 mm ≈ 22 mm, inside the box’s 25 mm. Battery and TP4056 sit side by side on the bottom (35 + 17 = 52 mm of the 66 mm length).</a:t>
             </a:r>
             <a:endParaRPr lang="en-US" sz="1200" dirty="0"/>
           </a:p>
@@ -16248,7 +15529,7 @@
                 <a:ea typeface="Calibri" pitchFamily="34" charset="-122"/>
                 <a:cs typeface="Calibri" pitchFamily="34" charset="-120"/>
               </a:rPr>
-              <a:t>60 × 35 × 20 mm</a:t>
+              <a:t>70 × 45 × 29 mm</a:t>
             </a:r>
             <a:endParaRPr lang="en-US" sz="2000" dirty="0"/>
           </a:p>
@@ -16404,7 +15685,7 @@
                 <a:ea typeface="Calibri" pitchFamily="34" charset="-122"/>
                 <a:cs typeface="Calibri" pitchFamily="34" charset="-120"/>
               </a:rPr>
-              <a:t>18 × 14 mm</a:t>
+              <a:t>14 × 14 mm</a:t>
             </a:r>
             <a:endParaRPr lang="en-US" sz="2000" dirty="0"/>
           </a:p>

</xml_diff>

<commit_message>
Correct presenter name to Gabriel Mamane in deck, script and proposal
Co-Authored-By: Claude Opus 5.5 <noreply@anthropic.com>
Claude-Session: https://claude.ai/code/session_01CxrUMy4UZKTNYh6kiz9919
</commit_message>
<xml_diff>
--- a/science-fair/night-signal/Night_Signal_Presentation.pptx
+++ b/science-fair/night-signal/Night_Signal_Presentation.pptx
@@ -876,7 +876,7 @@
           <a:p>
             <a:r>
               <a:rPr lang="en-US" dirty="0"/>
-              <a:t>[0:15] Hi, I'm Gabriela. My project is Night Signal: a wearable I designed that watches your blood oxygen while you sleep to catch sleep apnea — and it turns out the same sensor can screen the heart and breathing too.</a:t>
+              <a:t>[0:15] Hi, I’m Gabriel. My project is Night Signal: a wearable I designed that watches your blood oxygen while you sleep to catch sleep apnea — and it turns out the same sensor can screen the heart and breathing too.</a:t>
             </a:r>
             <a:endParaRPr lang="en-US" dirty="0"/>
           </a:p>
@@ -2983,7 +2983,7 @@
                 <a:ea typeface="Calibri" pitchFamily="34" charset="-122"/>
                 <a:cs typeface="Calibri" pitchFamily="34" charset="-120"/>
               </a:rPr>
-              <a:t>Gabriela Mamane</a:t>
+              <a:t>Gabriel Mamane</a:t>
             </a:r>
             <a:pPr indent="0" marL="0">
               <a:buNone/>

</xml_diff>

<commit_message>
Switch to an easy no-solder build (prototype v1)
- Firmware v3.1: motion sensor on its own I2C bus (SDA 33 / SCL 32,
  100 kHz) so each sensor plugs into its own pins with no splicing;
  GY-521 powered from VIN
- Parts: pre-soldered GY-521, Dupont jumper kit, armband pouch, 3 m USB
  cable + adapter; drop LiPo, charger, regulator, resistors and box
- BUILD_GUIDE.md rewritten for plug-in assembly (only 4 header pins on
  the MAX30102 need soldering) plus Mac/Windows Bluetooth pairing
- Deck: v1 prototype vs v2 sealed-case design, full-night power test,
  updated materials, protocol and wiring appendix with diagram
- check_device.py and the app treat a missing battery reading as USB power

Co-Authored-By: Claude Opus 5.5 <noreply@anthropic.com>
Claude-Session: https://claude.ai/code/session_01CxrUMy4UZKTNYh6kiz9919
</commit_message>
<xml_diff>
--- a/science-fair/night-signal/Night_Signal_Presentation.pptx
+++ b/science-fair/night-signal/Night_Signal_Presentation.pptx
@@ -1140,7 +1140,7 @@
           <a:p>
             <a:r>
               <a:rPr lang="en-US" dirty="0"/>
-              <a:t>[0:35] Sources of error: movement, finger pressure and cold hands can distort the light signal; the four-second averaging can blur very short dips; even the reference oximeter is only plus or minus two percent. On the method side, awake breath-holds aren't identical to real apnea, I only measure oxygen — not airflow or brain waves like a sleep lab — and one person isn't enough to generalize. I also caught an engineering problem: the battery only lasts four to five hours with Bluetooth, so I added a runtime test and use a power bank for full nights.</a:t>
+              <a:t>[0:35] Sources of error: movement, finger pressure and cold hands can distort the light signal; the four-second averaging can blur very short dips; even the reference oximeter is only plus or minus two percent. On the method side, awake breath-holds aren't identical to real apnea, I only measure oxygen — not airflow or brain waves like a sleep lab — and one person isn't enough to generalize. I also caught an engineering problem: Bluetooth draws about 100 milliamps, so a small 500 milliamp-hour battery would last only four to five hours. That's why version 1 runs on USB power all night, and version 2 needs a bigger battery or Bluetooth Low Energy.</a:t>
             </a:r>
             <a:endParaRPr lang="en-US" dirty="0"/>
           </a:p>
@@ -1580,7 +1580,7 @@
           <a:p>
             <a:r>
               <a:rPr lang="en-US" dirty="0"/>
-              <a:t>[0:00] Appendix — not presented. Wiring table and the internal layout with layer heights.</a:t>
+              <a:t>[0:00] Appendix — not presented. Prototype v1 wiring table, and the planned v2 case layout with layer heights.</a:t>
             </a:r>
             <a:endParaRPr lang="en-US" dirty="0"/>
           </a:p>
@@ -2020,7 +2020,7 @@
           <a:p>
             <a:r>
               <a:rPr lang="en-US" dirty="0"/>
-              <a:t>[0:40] Here's the design. A small case — a 70 by 45 millimetre project box — rides on a velcro strap and holds the ESP32 processor, battery, charger and a motion sensor. A cable runs to a velcro finger clip with the MAX30102 oxygen sensor. On the right is the exploded view with every part at its real size; you can spin the interactive version with this QR code.</a:t>
+              <a:t>[0:40] Here's the design. My working prototype, version 1, is built to be simple and reliable: the ESP32 sits in a running armband, each sensor plugs into its own pins with no soldered splices, and a USB cable powers it all night. A velcro finger clip holds the MAX30102 oxygen sensor. The 3D model shows version 2 — a 70 by 45 millimetre sealed case with its own battery on a velcro strap. On the right is the exploded view with every part at its real size; you can spin the interactive version with this QR code.</a:t>
             </a:r>
             <a:endParaRPr lang="en-US" dirty="0"/>
           </a:p>
@@ -2196,7 +2196,7 @@
           <a:p>
             <a:r>
               <a:rPr lang="en-US" dirty="0"/>
-              <a:t>[0:45] My key manipulations: one, a device check before every session. Two, an accuracy test — I wear my device and a store-bought oximeter at the same time and compare. Three, a detection test: supervised, awake breath-holds of 10, 15 and 20 seconds — I know exactly when they happened, so I can score my software. Four, a battery runtime test. Five, full recorded nights. Safety first: breath-holds only while awake and supervised, with consent and ethics approval.</a:t>
+              <a:t>[0:45] My key manipulations: one, a device check before every session. Two, an accuracy test — I wear my device and a store-bought oximeter at the same time and compare. Three, a detection test: supervised, awake breath-holds of 10, 15 and 20 seconds — I know exactly when they happened, so I can score my software. Four, a full-night power test — eight hours with no gaps. Five, full recorded nights. Safety first: breath-holds only while awake and supervised, with consent and ethics approval.</a:t>
             </a:r>
             <a:endParaRPr lang="en-US" dirty="0"/>
           </a:p>
@@ -4585,7 +4585,7 @@
                 <a:ea typeface="Calibri" pitchFamily="34" charset="-122"/>
                 <a:cs typeface="Calibri" pitchFamily="34" charset="-120"/>
               </a:rPr>
-              <a:t>Bluetooth draws about 100 mA, so the 500 mAh battery lasts roughly 4–5 hours — not a full night. I added a battery runtime test, and full nights use a small USB power bank.</a:t>
+              <a:t>Bluetooth draws about 100 mA, so a 500 mAh battery would last only 4–5 hours — not a full night. So prototype v1 runs on USB power, and the sealed v2 case needs a bigger battery or Bluetooth Low Energy.</a:t>
             </a:r>
             <a:endParaRPr lang="en-US" sz="1500" dirty="0"/>
           </a:p>
@@ -6155,7 +6155,7 @@
                           <a:ea typeface="Calibri" pitchFamily="34" charset="-122"/>
                           <a:cs typeface="Calibri" pitchFamily="34" charset="-120"/>
                         </a:rPr>
-                        <a:t>≈ 52 × 28 mm · 13 mm tall with pins</a:t>
+                        <a:t>≈ 52 × 28 mm · pins pre-soldered</a:t>
                       </a:r>
                       <a:endParaRPr lang="en-US" sz="1100" dirty="0">
                         <a:latin typeface="Calibri" charset="0"/>
@@ -6424,7 +6424,7 @@
                           <a:ea typeface="Calibri" pitchFamily="34" charset="-122"/>
                           <a:cs typeface="Calibri" pitchFamily="34" charset="-120"/>
                         </a:rPr>
-                        <a:t>14 × 14 mm</a:t>
+                        <a:t>14 × 14 mm · 4 pins to solder</a:t>
                       </a:r>
                       <a:endParaRPr lang="en-US" sz="1100" dirty="0">
                         <a:latin typeface="Calibri" charset="0"/>
@@ -6628,7 +6628,7 @@
                           <a:ea typeface="Calibri" pitchFamily="34" charset="-122"/>
                           <a:cs typeface="Calibri" pitchFamily="34" charset="-120"/>
                         </a:rPr>
-                        <a:t>HiLetgo GY-521 MPU-6050 (3-pack)</a:t>
+                        <a:t>SHILLEHTEK GY-521 MPU-6050, pre-soldered (2-pack)</a:t>
                       </a:r>
                       <a:endParaRPr lang="en-US" sz="1100" dirty="0">
                         <a:latin typeface="Calibri" charset="0"/>
@@ -6822,7 +6822,7 @@
                           <a:latin typeface="Calibri" pitchFamily="34" charset="0"/>
                           <a:ea typeface="Calibri" pitchFamily="34" charset="-122"/>
                           <a:cs typeface="Calibri" pitchFamily="34" charset="-120"/>
-                          <a:hlinkClick r:id="rId3" invalidUrl="" action="" tgtFrame="" tooltip="https://www.amazon.ca/Hiletgo-MPU6050-Acc%C3%A9l%C3%A9rom%C3%A8tre-gyroscope-convertisseur/dp/B00LP25V1A" history="1" highlightClick="0" endSnd="0">
+                          <a:hlinkClick r:id="rId3" invalidUrl="" action="" tgtFrame="" tooltip="https://www.amazon.ca/Pre-Soldered-Accelerometer-Raspberry-Compatible-Arduino/dp/B0BMY15TC4" history="1" highlightClick="0" endSnd="0">
                             <a:extLst>
                               <a:ext uri="{A12FA001-AC4F-418D-AE19-62706E023703}">
                                 <ahyp:hlinkClr xmlns:ahyp="http://schemas.microsoft.com/office/drawing/2018/hyperlinkcolor" val="tx"/>
@@ -6897,7 +6897,7 @@
                           <a:ea typeface="Calibri" pitchFamily="34" charset="-122"/>
                           <a:cs typeface="Calibri" pitchFamily="34" charset="-120"/>
                         </a:rPr>
-                        <a:t>LiPo 3.7 V 500 mAh 503035, JST PH2.0</a:t>
+                        <a:t>ELEGOO 120 Dupont jumper wires (F-F, M-F, M-M)</a:t>
                       </a:r>
                       <a:endParaRPr lang="en-US" sz="1100" dirty="0">
                         <a:latin typeface="Calibri" charset="0"/>
@@ -6962,7 +6962,7 @@
                           <a:ea typeface="Calibri" pitchFamily="34" charset="-122"/>
                           <a:cs typeface="Calibri" pitchFamily="34" charset="-120"/>
                         </a:rPr>
-                        <a:t>35 × 30 × 6 mm</a:t>
+                        <a:t>20 cm each</a:t>
                       </a:r>
                       <a:endParaRPr lang="en-US" sz="1100" dirty="0">
                         <a:latin typeface="Calibri" charset="0"/>
@@ -7027,7 +7027,7 @@
                           <a:ea typeface="Calibri" pitchFamily="34" charset="-122"/>
                           <a:cs typeface="Calibri" pitchFamily="34" charset="-120"/>
                         </a:rPr>
-                        <a:t>Battery (≈ 4–5 h — test it)</a:t>
+                        <a:t>Plug-in wiring, no soldering</a:t>
                       </a:r>
                       <a:endParaRPr lang="en-US" sz="1100" dirty="0">
                         <a:latin typeface="Calibri" charset="0"/>
@@ -7091,7 +7091,7 @@
                           <a:latin typeface="Calibri" pitchFamily="34" charset="0"/>
                           <a:ea typeface="Calibri" pitchFamily="34" charset="-122"/>
                           <a:cs typeface="Calibri" pitchFamily="34" charset="-120"/>
-                          <a:hlinkClick r:id="rId4" invalidUrl="" action="" tgtFrame="" tooltip="https://www.amazon.ca/Battery-Rechargeable-Lithium-Polymer-Connector/dp/B07S84SBV3" history="1" highlightClick="0" endSnd="0">
+                          <a:hlinkClick r:id="rId4" invalidUrl="" action="" tgtFrame="" tooltip="https://www.amazon.ca/Elegoo-120pcs-Multicolored-Breadboard-arduino/dp/B01EV70C78" history="1" highlightClick="0" endSnd="0">
                             <a:extLst>
                               <a:ext uri="{A12FA001-AC4F-418D-AE19-62706E023703}">
                                 <ahyp:hlinkClr xmlns:ahyp="http://schemas.microsoft.com/office/drawing/2018/hyperlinkcolor" val="tx"/>
@@ -7166,7 +7166,7 @@
                           <a:ea typeface="Calibri" pitchFamily="34" charset="-122"/>
                           <a:cs typeface="Calibri" pitchFamily="34" charset="-120"/>
                         </a:rPr>
-                        <a:t>Treedix TP4056 USB-C charger (6-pack)</a:t>
+                        <a:t>Running armband phone pouch</a:t>
                       </a:r>
                       <a:endParaRPr lang="en-US" sz="1100" dirty="0">
                         <a:latin typeface="Calibri" charset="0"/>
@@ -7231,7 +7231,7 @@
                           <a:ea typeface="Calibri" pitchFamily="34" charset="-122"/>
                           <a:cs typeface="Calibri" pitchFamily="34" charset="-120"/>
                         </a:rPr>
-                        <a:t>≈ 28 × 17 mm</a:t>
+                        <a:t>fits phones up to 6.9 in</a:t>
                       </a:r>
                       <a:endParaRPr lang="en-US" sz="1100" dirty="0">
                         <a:latin typeface="Calibri" charset="0"/>
@@ -7296,7 +7296,7 @@
                           <a:ea typeface="Calibri" pitchFamily="34" charset="-122"/>
                           <a:cs typeface="Calibri" pitchFamily="34" charset="-120"/>
                         </a:rPr>
-                        <a:t>Charges the battery safely</a:t>
+                        <a:t>Holds the ESP32 on the forearm</a:t>
                       </a:r>
                       <a:endParaRPr lang="en-US" sz="1100" dirty="0">
                         <a:latin typeface="Calibri" charset="0"/>
@@ -7360,7 +7360,7 @@
                           <a:latin typeface="Calibri" pitchFamily="34" charset="0"/>
                           <a:ea typeface="Calibri" pitchFamily="34" charset="-122"/>
                           <a:cs typeface="Calibri" pitchFamily="34" charset="-120"/>
-                          <a:hlinkClick r:id="rId5" invalidUrl="" action="" tgtFrame="" tooltip="https://www.amazon.ca/Treedix-Lithium-Charging-Protection-Functions/dp/B09LTVTY5J" history="1" highlightClick="0" endSnd="0">
+                          <a:hlinkClick r:id="rId5" invalidUrl="" action="" tgtFrame="" tooltip="https://www.amazon.ca/Running-Armband-Samsung-Resistant-Emergency/dp/B08HZ3BPK4" history="1" highlightClick="0" endSnd="0">
                             <a:extLst>
                               <a:ext uri="{A12FA001-AC4F-418D-AE19-62706E023703}">
                                 <ahyp:hlinkClr xmlns:ahyp="http://schemas.microsoft.com/office/drawing/2018/hyperlinkcolor" val="tx"/>
@@ -7435,7 +7435,7 @@
                           <a:ea typeface="Calibri" pitchFamily="34" charset="-122"/>
                           <a:cs typeface="Calibri" pitchFamily="34" charset="-120"/>
                         </a:rPr>
-                        <a:t>Rakstore TPS63020 3.3 V buck-boost</a:t>
+                        <a:t>Anker Powerline+ USB-A to USB-C cable</a:t>
                       </a:r>
                       <a:endParaRPr lang="en-US" sz="1100" dirty="0">
                         <a:latin typeface="Calibri" charset="0"/>
@@ -7500,7 +7500,7 @@
                           <a:ea typeface="Calibri" pitchFamily="34" charset="-122"/>
                           <a:cs typeface="Calibri" pitchFamily="34" charset="-120"/>
                         </a:rPr>
-                        <a:t>1.8–5 V in → 3.3 V out</a:t>
+                        <a:t>3 m (10 ft)</a:t>
                       </a:r>
                       <a:endParaRPr lang="en-US" sz="1100" dirty="0">
                         <a:latin typeface="Calibri" charset="0"/>
@@ -7565,7 +7565,7 @@
                           <a:ea typeface="Calibri" pitchFamily="34" charset="-122"/>
                           <a:cs typeface="Calibri" pitchFamily="34" charset="-120"/>
                         </a:rPr>
-                        <a:t>Steady 3.3 V as the battery drains</a:t>
+                        <a:t>All-night power from a phone charger</a:t>
                       </a:r>
                       <a:endParaRPr lang="en-US" sz="1100" dirty="0">
                         <a:latin typeface="Calibri" charset="0"/>
@@ -7629,7 +7629,7 @@
                           <a:latin typeface="Calibri" pitchFamily="34" charset="0"/>
                           <a:ea typeface="Calibri" pitchFamily="34" charset="-122"/>
                           <a:cs typeface="Calibri" pitchFamily="34" charset="-120"/>
-                          <a:hlinkClick r:id="rId6" invalidUrl="" action="" tgtFrame="" tooltip="https://www.amazon.ca/Rakstore-TPS63020-Automatic-Buck-Boost-Converter/dp/B09V4SHLTJ" history="1" highlightClick="0" endSnd="0">
+                          <a:hlinkClick r:id="rId6" invalidUrl="" action="" tgtFrame="" tooltip="https://www.amazon.ca/Anker-Powerline-Double-Braided-Charging-Samsung/dp/B07G148YMS" history="1" highlightClick="0" endSnd="0">
                             <a:extLst>
                               <a:ext uri="{A12FA001-AC4F-418D-AE19-62706E023703}">
                                 <ahyp:hlinkClr xmlns:ahyp="http://schemas.microsoft.com/office/drawing/2018/hyperlinkcolor" val="tx"/>
@@ -7704,7 +7704,7 @@
                           <a:ea typeface="Calibri" pitchFamily="34" charset="-122"/>
                           <a:cs typeface="Calibri" pitchFamily="34" charset="-120"/>
                         </a:rPr>
-                        <a:t>HoHaing ABS project box (8-pack)</a:t>
+                        <a:t>Anker USB-C to USB-A adapter (2-pack)</a:t>
                       </a:r>
                       <a:endParaRPr lang="en-US" sz="1100" dirty="0">
                         <a:latin typeface="Calibri" charset="0"/>
@@ -7769,7 +7769,7 @@
                           <a:ea typeface="Calibri" pitchFamily="34" charset="-122"/>
                           <a:cs typeface="Calibri" pitchFamily="34" charset="-120"/>
                         </a:rPr>
-                        <a:t>70 × 45 × 29 mm · inside 66 × 41 × 25 mm</a:t>
+                        <a:t>USB-C → USB-A</a:t>
                       </a:r>
                       <a:endParaRPr lang="en-US" sz="1100" dirty="0">
                         <a:latin typeface="Calibri" charset="0"/>
@@ -7834,7 +7834,7 @@
                           <a:ea typeface="Calibri" pitchFamily="34" charset="-122"/>
                           <a:cs typeface="Calibri" pitchFamily="34" charset="-120"/>
                         </a:rPr>
-                        <a:t>The sensor case</a:t>
+                        <a:t>Plug the cable into a MacBook</a:t>
                       </a:r>
                       <a:endParaRPr lang="en-US" sz="1100" dirty="0">
                         <a:latin typeface="Calibri" charset="0"/>
@@ -7898,7 +7898,7 @@
                           <a:latin typeface="Calibri" pitchFamily="34" charset="0"/>
                           <a:ea typeface="Calibri" pitchFamily="34" charset="-122"/>
                           <a:cs typeface="Calibri" pitchFamily="34" charset="-120"/>
-                          <a:hlinkClick r:id="rId7" invalidUrl="" action="" tgtFrame="" tooltip="https://www.amazon.ca/HoHaing-Electrical-Junction-Enclosure-Electronic/dp/B0CGV22KKG" history="1" highlightClick="0" endSnd="0">
+                          <a:hlinkClick r:id="rId7" invalidUrl="" action="" tgtFrame="" tooltip="https://www.amazon.ca/Adapter-Anker-High-Speed-Transfer-Notebook/dp/B08HZ6PS61" history="1" highlightClick="0" endSnd="0">
                             <a:extLst>
                               <a:ext uri="{A12FA001-AC4F-418D-AE19-62706E023703}">
                                 <ahyp:hlinkClr xmlns:ahyp="http://schemas.microsoft.com/office/drawing/2018/hyperlinkcolor" val="tx"/>
@@ -8038,7 +8038,7 @@
                           <a:ea typeface="Calibri" pitchFamily="34" charset="-122"/>
                           <a:cs typeface="Calibri" pitchFamily="34" charset="-120"/>
                         </a:rPr>
-                        <a:t>25 mm wide · cut ≈ 300 mm + ≈ 80 mm</a:t>
+                        <a:t>25 mm wide · cut ≈ 80 mm</a:t>
                       </a:r>
                       <a:endParaRPr lang="en-US" sz="1100" dirty="0">
                         <a:latin typeface="Calibri" charset="0"/>
@@ -8103,7 +8103,7 @@
                           <a:ea typeface="Calibri" pitchFamily="34" charset="-122"/>
                           <a:cs typeface="Calibri" pitchFamily="34" charset="-120"/>
                         </a:rPr>
-                        <a:t>Arm strap + finger loop</a:t>
+                        <a:t>Finger loop</a:t>
                       </a:r>
                       <a:endParaRPr lang="en-US" sz="1100" dirty="0">
                         <a:latin typeface="Calibri" charset="0"/>
@@ -8242,275 +8242,6 @@
                           <a:ea typeface="Calibri" pitchFamily="34" charset="-122"/>
                           <a:cs typeface="Calibri" pitchFamily="34" charset="-120"/>
                         </a:rPr>
-                        <a:t>100 kΩ resistors (2) + jumper wires</a:t>
-                      </a:r>
-                      <a:endParaRPr lang="en-US" sz="1100" dirty="0">
-                        <a:latin typeface="Calibri" charset="0"/>
-                        <a:ea typeface="Calibri" charset="0"/>
-                        <a:cs typeface="Calibri" charset="0"/>
-                      </a:endParaRPr>
-                    </a:p>
-                  </a:txBody>
-                  <a:tcPr marL="91440" marR="91440" marT="45720" marB="45720" anchor="ctr">
-                    <a:lnL w="12700" cap="flat" cmpd="sng" algn="ctr">
-                      <a:solidFill>
-                        <a:srgbClr val="DBE1EC"/>
-                      </a:solidFill>
-                      <a:prstDash val="solid"/>
-                      <a:round/>
-                      <a:headEnd type="none" w="med" len="med"/>
-                      <a:tailEnd type="none" w="med" len="med"/>
-                    </a:lnL>
-                    <a:lnR w="12700" cap="flat" cmpd="sng" algn="ctr">
-                      <a:solidFill>
-                        <a:srgbClr val="DBE1EC"/>
-                      </a:solidFill>
-                      <a:prstDash val="solid"/>
-                      <a:round/>
-                      <a:headEnd type="none" w="med" len="med"/>
-                      <a:tailEnd type="none" w="med" len="med"/>
-                    </a:lnR>
-                    <a:lnT w="12700" cap="flat" cmpd="sng" algn="ctr">
-                      <a:solidFill>
-                        <a:srgbClr val="DBE1EC"/>
-                      </a:solidFill>
-                      <a:prstDash val="solid"/>
-                      <a:round/>
-                      <a:headEnd type="none" w="med" len="med"/>
-                      <a:tailEnd type="none" w="med" len="med"/>
-                    </a:lnT>
-                    <a:lnB w="12700" cap="flat" cmpd="sng" algn="ctr">
-                      <a:solidFill>
-                        <a:srgbClr val="DBE1EC"/>
-                      </a:solidFill>
-                      <a:prstDash val="solid"/>
-                      <a:round/>
-                      <a:headEnd type="none" w="med" len="med"/>
-                      <a:tailEnd type="none" w="med" len="med"/>
-                    </a:lnB>
-                  </a:tcPr>
-                </a:tc>
-                <a:tc>
-                  <a:txBody>
-                    <a:bodyPr/>
-                    <a:lstStyle/>
-                    <a:p>
-                      <a:pPr indent="0" marL="0">
-                        <a:buNone/>
-                      </a:pPr>
-                      <a:r>
-                        <a:rPr lang="en-US" sz="1100" dirty="0">
-                          <a:solidFill>
-                            <a:srgbClr val="141A26"/>
-                          </a:solidFill>
-                          <a:latin typeface="Calibri" pitchFamily="34" charset="0"/>
-                          <a:ea typeface="Calibri" pitchFamily="34" charset="-122"/>
-                          <a:cs typeface="Calibri" pitchFamily="34" charset="-120"/>
-                        </a:rPr>
-                        <a:t>1/4 W</a:t>
-                      </a:r>
-                      <a:endParaRPr lang="en-US" sz="1100" dirty="0">
-                        <a:latin typeface="Calibri" charset="0"/>
-                        <a:ea typeface="Calibri" charset="0"/>
-                        <a:cs typeface="Calibri" charset="0"/>
-                      </a:endParaRPr>
-                    </a:p>
-                  </a:txBody>
-                  <a:tcPr marL="91440" marR="91440" marT="45720" marB="45720" anchor="ctr">
-                    <a:lnL w="12700" cap="flat" cmpd="sng" algn="ctr">
-                      <a:solidFill>
-                        <a:srgbClr val="DBE1EC"/>
-                      </a:solidFill>
-                      <a:prstDash val="solid"/>
-                      <a:round/>
-                      <a:headEnd type="none" w="med" len="med"/>
-                      <a:tailEnd type="none" w="med" len="med"/>
-                    </a:lnL>
-                    <a:lnR w="12700" cap="flat" cmpd="sng" algn="ctr">
-                      <a:solidFill>
-                        <a:srgbClr val="DBE1EC"/>
-                      </a:solidFill>
-                      <a:prstDash val="solid"/>
-                      <a:round/>
-                      <a:headEnd type="none" w="med" len="med"/>
-                      <a:tailEnd type="none" w="med" len="med"/>
-                    </a:lnR>
-                    <a:lnT w="12700" cap="flat" cmpd="sng" algn="ctr">
-                      <a:solidFill>
-                        <a:srgbClr val="DBE1EC"/>
-                      </a:solidFill>
-                      <a:prstDash val="solid"/>
-                      <a:round/>
-                      <a:headEnd type="none" w="med" len="med"/>
-                      <a:tailEnd type="none" w="med" len="med"/>
-                    </a:lnT>
-                    <a:lnB w="12700" cap="flat" cmpd="sng" algn="ctr">
-                      <a:solidFill>
-                        <a:srgbClr val="DBE1EC"/>
-                      </a:solidFill>
-                      <a:prstDash val="solid"/>
-                      <a:round/>
-                      <a:headEnd type="none" w="med" len="med"/>
-                      <a:tailEnd type="none" w="med" len="med"/>
-                    </a:lnB>
-                  </a:tcPr>
-                </a:tc>
-                <a:tc>
-                  <a:txBody>
-                    <a:bodyPr/>
-                    <a:lstStyle/>
-                    <a:p>
-                      <a:pPr indent="0" marL="0">
-                        <a:buNone/>
-                      </a:pPr>
-                      <a:r>
-                        <a:rPr lang="en-US" sz="1100" dirty="0">
-                          <a:solidFill>
-                            <a:srgbClr val="141A26"/>
-                          </a:solidFill>
-                          <a:latin typeface="Calibri" pitchFamily="34" charset="0"/>
-                          <a:ea typeface="Calibri" pitchFamily="34" charset="-122"/>
-                          <a:cs typeface="Calibri" pitchFamily="34" charset="-120"/>
-                        </a:rPr>
-                        <a:t>Battery-level reading on GPIO 34</a:t>
-                      </a:r>
-                      <a:endParaRPr lang="en-US" sz="1100" dirty="0">
-                        <a:latin typeface="Calibri" charset="0"/>
-                        <a:ea typeface="Calibri" charset="0"/>
-                        <a:cs typeface="Calibri" charset="0"/>
-                      </a:endParaRPr>
-                    </a:p>
-                  </a:txBody>
-                  <a:tcPr marL="91440" marR="91440" marT="45720" marB="45720" anchor="ctr">
-                    <a:lnL w="12700" cap="flat" cmpd="sng" algn="ctr">
-                      <a:solidFill>
-                        <a:srgbClr val="DBE1EC"/>
-                      </a:solidFill>
-                      <a:prstDash val="solid"/>
-                      <a:round/>
-                      <a:headEnd type="none" w="med" len="med"/>
-                      <a:tailEnd type="none" w="med" len="med"/>
-                    </a:lnL>
-                    <a:lnR w="12700" cap="flat" cmpd="sng" algn="ctr">
-                      <a:solidFill>
-                        <a:srgbClr val="DBE1EC"/>
-                      </a:solidFill>
-                      <a:prstDash val="solid"/>
-                      <a:round/>
-                      <a:headEnd type="none" w="med" len="med"/>
-                      <a:tailEnd type="none" w="med" len="med"/>
-                    </a:lnR>
-                    <a:lnT w="12700" cap="flat" cmpd="sng" algn="ctr">
-                      <a:solidFill>
-                        <a:srgbClr val="DBE1EC"/>
-                      </a:solidFill>
-                      <a:prstDash val="solid"/>
-                      <a:round/>
-                      <a:headEnd type="none" w="med" len="med"/>
-                      <a:tailEnd type="none" w="med" len="med"/>
-                    </a:lnT>
-                    <a:lnB w="12700" cap="flat" cmpd="sng" algn="ctr">
-                      <a:solidFill>
-                        <a:srgbClr val="DBE1EC"/>
-                      </a:solidFill>
-                      <a:prstDash val="solid"/>
-                      <a:round/>
-                      <a:headEnd type="none" w="med" len="med"/>
-                      <a:tailEnd type="none" w="med" len="med"/>
-                    </a:lnB>
-                  </a:tcPr>
-                </a:tc>
-                <a:tc>
-                  <a:txBody>
-                    <a:bodyPr/>
-                    <a:lstStyle/>
-                    <a:p>
-                      <a:pPr indent="0" marL="0">
-                        <a:buNone/>
-                      </a:pPr>
-                      <a:r>
-                        <a:rPr lang="en-US" sz="1100" u="sng" dirty="0">
-                          <a:solidFill>
-                            <a:srgbClr val="1F8A9C"/>
-                          </a:solidFill>
-                          <a:latin typeface="Calibri" pitchFamily="34" charset="0"/>
-                          <a:ea typeface="Calibri" pitchFamily="34" charset="-122"/>
-                          <a:cs typeface="Calibri" pitchFamily="34" charset="-120"/>
-                          <a:hlinkClick r:id="rId9" invalidUrl="" action="" tgtFrame="" tooltip="https://www.amazon.ca/s?k=100k+ohm+resistor+1%2F4w" history="1" highlightClick="0" endSnd="0">
-                            <a:extLst>
-                              <a:ext uri="{A12FA001-AC4F-418D-AE19-62706E023703}">
-                                <ahyp:hlinkClr xmlns:ahyp="http://schemas.microsoft.com/office/drawing/2018/hyperlinkcolor" val="tx"/>
-                              </a:ext>
-                            </a:extLst>
-                          </a:hlinkClick>
-                        </a:rPr>
-                        <a:t>Amazon.ca</a:t>
-                      </a:r>
-                      <a:endParaRPr lang="en-US" sz="1100" dirty="0">
-                        <a:latin typeface="Calibri" charset="0"/>
-                        <a:ea typeface="Calibri" charset="0"/>
-                        <a:cs typeface="Calibri" charset="0"/>
-                      </a:endParaRPr>
-                    </a:p>
-                  </a:txBody>
-                  <a:tcPr marL="91440" marR="91440" marT="45720" marB="45720" anchor="ctr">
-                    <a:lnL w="12700" cap="flat" cmpd="sng" algn="ctr">
-                      <a:solidFill>
-                        <a:srgbClr val="DBE1EC"/>
-                      </a:solidFill>
-                      <a:prstDash val="solid"/>
-                      <a:round/>
-                      <a:headEnd type="none" w="med" len="med"/>
-                      <a:tailEnd type="none" w="med" len="med"/>
-                    </a:lnL>
-                    <a:lnR w="12700" cap="flat" cmpd="sng" algn="ctr">
-                      <a:solidFill>
-                        <a:srgbClr val="DBE1EC"/>
-                      </a:solidFill>
-                      <a:prstDash val="solid"/>
-                      <a:round/>
-                      <a:headEnd type="none" w="med" len="med"/>
-                      <a:tailEnd type="none" w="med" len="med"/>
-                    </a:lnR>
-                    <a:lnT w="12700" cap="flat" cmpd="sng" algn="ctr">
-                      <a:solidFill>
-                        <a:srgbClr val="DBE1EC"/>
-                      </a:solidFill>
-                      <a:prstDash val="solid"/>
-                      <a:round/>
-                      <a:headEnd type="none" w="med" len="med"/>
-                      <a:tailEnd type="none" w="med" len="med"/>
-                    </a:lnT>
-                    <a:lnB w="12700" cap="flat" cmpd="sng" algn="ctr">
-                      <a:solidFill>
-                        <a:srgbClr val="DBE1EC"/>
-                      </a:solidFill>
-                      <a:prstDash val="solid"/>
-                      <a:round/>
-                      <a:headEnd type="none" w="med" len="med"/>
-                      <a:tailEnd type="none" w="med" len="med"/>
-                    </a:lnB>
-                  </a:tcPr>
-                </a:tc>
-              </a:tr>
-              <a:tr h="384048">
-                <a:tc>
-                  <a:txBody>
-                    <a:bodyPr/>
-                    <a:lstStyle/>
-                    <a:p>
-                      <a:pPr indent="0" marL="0">
-                        <a:buNone/>
-                      </a:pPr>
-                      <a:r>
-                        <a:rPr lang="en-US" sz="1100" dirty="0">
-                          <a:solidFill>
-                            <a:srgbClr val="141A26"/>
-                          </a:solidFill>
-                          <a:latin typeface="Calibri" pitchFamily="34" charset="0"/>
-                          <a:ea typeface="Calibri" pitchFamily="34" charset="-122"/>
-                          <a:cs typeface="Calibri" pitchFamily="34" charset="-120"/>
-                        </a:rPr>
                         <a:t>Elite Medica fingertip pulse oximeter</a:t>
                       </a:r>
                       <a:endParaRPr lang="en-US" sz="1100" dirty="0">
@@ -8705,7 +8436,7 @@
                           <a:latin typeface="Calibri" pitchFamily="34" charset="0"/>
                           <a:ea typeface="Calibri" pitchFamily="34" charset="-122"/>
                           <a:cs typeface="Calibri" pitchFamily="34" charset="-120"/>
-                          <a:hlinkClick r:id="rId10" invalidUrl="" action="" tgtFrame="" tooltip="https://www.amazon.ca/Elite-Medica-Fingertip-Saturation-Batteries/dp/B0DSGP91PB" history="1" highlightClick="0" endSnd="0">
+                          <a:hlinkClick r:id="rId9" invalidUrl="" action="" tgtFrame="" tooltip="https://www.amazon.ca/Elite-Medica-Fingertip-Saturation-Batteries/dp/B0DSGP91PB" history="1" highlightClick="0" endSnd="0">
                             <a:extLst>
                               <a:ext uri="{A12FA001-AC4F-418D-AE19-62706E023703}">
                                 <ahyp:hlinkClr xmlns:ahyp="http://schemas.microsoft.com/office/drawing/2018/hyperlinkcolor" val="tx"/>
@@ -8799,7 +8530,7 @@
                 <a:ea typeface="Calibri" pitchFamily="34" charset="-122"/>
                 <a:cs typeface="Calibri" pitchFamily="34" charset="-120"/>
               </a:rPr>
-              <a:t>Every part is on Amazon.ca (click Buy). Prices change and several items are multi-packs. Sizes from the listings — boards vary about ±2 mm, so measure yours.</a:t>
+              <a:t>Every part is on Amazon.ca (click Buy). Prices change and several items are multi-packs. Only the MAX30102's 4 header pins need soldering (about 5 minutes); everything else plugs in.</a:t>
             </a:r>
             <a:endParaRPr lang="en-US" sz="1150" dirty="0"/>
           </a:p>
@@ -9053,7 +8784,7 @@
                 <a:ea typeface="Calibri" pitchFamily="34" charset="-122"/>
                 <a:cs typeface="Calibri" pitchFamily="34" charset="-120"/>
               </a:rPr>
-              <a:t>Build: wire MAX30102 and MPU-6050 to the ESP32 (SDA→21, SCL→22, 3V3, GND); battery → TP4056 → 3.3 V regulator → ESP32 3V3; battery divider to GPIO 34. Flash firmware v3.</a:t>
+              <a:t>Build: plug the MAX30102 into 3V3 / GND / GPIO 21 / 22 and the GY-521 into VIN / GND / SDA→GPIO 33 / SCL→GPIO 32 (two separate I²C buses, no splices); ESP32 in the armband, USB power. Flash firmware v3.1.</a:t>
             </a:r>
             <a:endParaRPr lang="en-US" sz="1250" dirty="0"/>
           </a:p>
@@ -9209,7 +8940,7 @@
                 <a:ea typeface="Calibri" pitchFamily="34" charset="-122"/>
                 <a:cs typeface="Calibri" pitchFamily="34" charset="-120"/>
               </a:rPr>
-              <a:t>Battery runtime test: charge fully, stream with a finger on the sensor, record the time until data stops. Repeat 3 times; report the average.</a:t>
+              <a:t>Full-night power test: on USB power, stream with a finger on the sensor for 8 h; confirm there are no gaps in the data.</a:t>
             </a:r>
             <a:endParaRPr lang="en-US" sz="1250" dirty="0"/>
           </a:p>
@@ -9443,7 +9174,7 @@
                 <a:ea typeface="Calibri" pitchFamily="34" charset="-122"/>
                 <a:cs typeface="Calibri" pitchFamily="34" charset="-120"/>
               </a:rPr>
-              <a:t>Recorded nights: ≥ 5 nights; case on the upper arm, finger clip on the index finger; record.py logs all night; note bedtime and wake time.</a:t>
+              <a:t>Recorded nights: ≥ 5 nights; armband on the forearm, finger clip on the index finger; record.py logs all night; note bedtime and wake time.</a:t>
             </a:r>
             <a:endParaRPr lang="en-US" sz="1250" dirty="0"/>
           </a:p>
@@ -9599,7 +9330,7 @@
                 <a:ea typeface="Calibri" pitchFamily="34" charset="-122"/>
                 <a:cs typeface="Calibri" pitchFamily="34" charset="-120"/>
               </a:rPr>
-              <a:t>Controls: same finger, cuff tightness, room temperature, firmware v3 and detection settings (3 % drop, 10 s, 120 s baseline).</a:t>
+              <a:t>Controls: same finger, cuff tightness, room temperature, firmware v3.1 and detection settings (3 % drop, 10 s, 120 s baseline).</a:t>
             </a:r>
             <a:endParaRPr lang="en-US" sz="1250" dirty="0"/>
           </a:p>
@@ -9775,7 +9506,7 @@
                 <a:ea typeface="Calibri" pitchFamily="34" charset="-122"/>
                 <a:cs typeface="Calibri" pitchFamily="34" charset="-120"/>
               </a:rPr>
-              <a:t>Wiring and case layout</a:t>
+              <a:t>Wiring (v1) and case layout (v2)</a:t>
             </a:r>
             <a:endParaRPr lang="en-US" sz="2800" dirty="0"/>
           </a:p>
@@ -10359,7 +10090,7 @@
                           <a:ea typeface="Calibri" pitchFamily="34" charset="-122"/>
                           <a:cs typeface="Calibri" pitchFamily="34" charset="-120"/>
                         </a:rPr>
-                        <a:t>shared I²C bus</a:t>
+                        <a:t>I²C bus 0</a:t>
                       </a:r>
                       <a:endParaRPr lang="en-US" sz="1150" dirty="0">
                         <a:latin typeface="Calibri" charset="0"/>
@@ -10491,7 +10222,7 @@
                           <a:ea typeface="Calibri" pitchFamily="34" charset="-122"/>
                           <a:cs typeface="Calibri" pitchFamily="34" charset="-120"/>
                         </a:rPr>
-                        <a:t>3V3 / GND</a:t>
+                        <a:t>VIN / GND</a:t>
                       </a:r>
                       <a:endParaRPr lang="en-US" sz="1150" dirty="0">
                         <a:latin typeface="Calibri" charset="0"/>
@@ -10556,7 +10287,7 @@
                           <a:ea typeface="Calibri" pitchFamily="34" charset="-122"/>
                           <a:cs typeface="Calibri" pitchFamily="34" charset="-120"/>
                         </a:rPr>
-                        <a:t>address 0x68</a:t>
+                        <a:t>5 V from USB</a:t>
                       </a:r>
                       <a:endParaRPr lang="en-US" sz="1150" dirty="0">
                         <a:latin typeface="Calibri" charset="0"/>
@@ -10623,7 +10354,7 @@
                           <a:ea typeface="Calibri" pitchFamily="34" charset="-122"/>
                           <a:cs typeface="Calibri" pitchFamily="34" charset="-120"/>
                         </a:rPr>
-                        <a:t>MPU-6050 SDA / SCL</a:t>
+                        <a:t>GY-521 SDA / SCL</a:t>
                       </a:r>
                       <a:endParaRPr lang="en-US" sz="1150" dirty="0">
                         <a:latin typeface="Calibri" charset="0"/>
@@ -10688,7 +10419,7 @@
                           <a:ea typeface="Calibri" pitchFamily="34" charset="-122"/>
                           <a:cs typeface="Calibri" pitchFamily="34" charset="-120"/>
                         </a:rPr>
-                        <a:t>GPIO 21 / 22</a:t>
+                        <a:t>GPIO 33 / 32</a:t>
                       </a:r>
                       <a:endParaRPr lang="en-US" sz="1150" dirty="0">
                         <a:latin typeface="Calibri" charset="0"/>
@@ -10753,7 +10484,7 @@
                           <a:ea typeface="Calibri" pitchFamily="34" charset="-122"/>
                           <a:cs typeface="Calibri" pitchFamily="34" charset="-120"/>
                         </a:rPr>
-                        <a:t>wired in parallel</a:t>
+                        <a:t>I²C bus 1, 100 kHz</a:t>
                       </a:r>
                       <a:endParaRPr lang="en-US" sz="1150" dirty="0">
                         <a:latin typeface="Calibri" charset="0"/>
@@ -10820,7 +10551,7 @@
                           <a:ea typeface="Calibri" pitchFamily="34" charset="-122"/>
                           <a:cs typeface="Calibri" pitchFamily="34" charset="-120"/>
                         </a:rPr>
-                        <a:t>Battery + / −</a:t>
+                        <a:t>Power</a:t>
                       </a:r>
                       <a:endParaRPr lang="en-US" sz="1150" dirty="0">
                         <a:latin typeface="Calibri" charset="0"/>
@@ -10885,7 +10616,7 @@
                           <a:ea typeface="Calibri" pitchFamily="34" charset="-122"/>
                           <a:cs typeface="Calibri" pitchFamily="34" charset="-120"/>
                         </a:rPr>
-                        <a:t>TP4056 B+ / B−</a:t>
+                        <a:t>USB-C port</a:t>
                       </a:r>
                       <a:endParaRPr lang="en-US" sz="1150" dirty="0">
                         <a:latin typeface="Calibri" charset="0"/>
@@ -10950,598 +10681,7 @@
                           <a:ea typeface="Calibri" pitchFamily="34" charset="-122"/>
                           <a:cs typeface="Calibri" pitchFamily="34" charset="-120"/>
                         </a:rPr>
-                        <a:t>500 mAh LiPo</a:t>
-                      </a:r>
-                      <a:endParaRPr lang="en-US" sz="1150" dirty="0">
-                        <a:latin typeface="Calibri" charset="0"/>
-                        <a:ea typeface="Calibri" charset="0"/>
-                        <a:cs typeface="Calibri" charset="0"/>
-                      </a:endParaRPr>
-                    </a:p>
-                  </a:txBody>
-                  <a:tcPr marL="91440" marR="91440" marT="45720" marB="45720" anchor="ctr">
-                    <a:lnL w="12700" cap="flat" cmpd="sng" algn="ctr">
-                      <a:solidFill>
-                        <a:srgbClr val="DBE1EC"/>
-                      </a:solidFill>
-                      <a:prstDash val="solid"/>
-                      <a:round/>
-                      <a:headEnd type="none" w="med" len="med"/>
-                      <a:tailEnd type="none" w="med" len="med"/>
-                    </a:lnL>
-                    <a:lnR w="12700" cap="flat" cmpd="sng" algn="ctr">
-                      <a:solidFill>
-                        <a:srgbClr val="DBE1EC"/>
-                      </a:solidFill>
-                      <a:prstDash val="solid"/>
-                      <a:round/>
-                      <a:headEnd type="none" w="med" len="med"/>
-                      <a:tailEnd type="none" w="med" len="med"/>
-                    </a:lnR>
-                    <a:lnT w="12700" cap="flat" cmpd="sng" algn="ctr">
-                      <a:solidFill>
-                        <a:srgbClr val="DBE1EC"/>
-                      </a:solidFill>
-                      <a:prstDash val="solid"/>
-                      <a:round/>
-                      <a:headEnd type="none" w="med" len="med"/>
-                      <a:tailEnd type="none" w="med" len="med"/>
-                    </a:lnT>
-                    <a:lnB w="12700" cap="flat" cmpd="sng" algn="ctr">
-                      <a:solidFill>
-                        <a:srgbClr val="DBE1EC"/>
-                      </a:solidFill>
-                      <a:prstDash val="solid"/>
-                      <a:round/>
-                      <a:headEnd type="none" w="med" len="med"/>
-                      <a:tailEnd type="none" w="med" len="med"/>
-                    </a:lnB>
-                  </a:tcPr>
-                </a:tc>
-              </a:tr>
-              <a:tr h="384048">
-                <a:tc>
-                  <a:txBody>
-                    <a:bodyPr/>
-                    <a:lstStyle/>
-                    <a:p>
-                      <a:pPr indent="0" marL="0">
-                        <a:buNone/>
-                      </a:pPr>
-                      <a:r>
-                        <a:rPr lang="en-US" sz="1150" dirty="0">
-                          <a:solidFill>
-                            <a:srgbClr val="141A26"/>
-                          </a:solidFill>
-                          <a:latin typeface="Calibri" pitchFamily="34" charset="0"/>
-                          <a:ea typeface="Calibri" pitchFamily="34" charset="-122"/>
-                          <a:cs typeface="Calibri" pitchFamily="34" charset="-120"/>
-                        </a:rPr>
-                        <a:t>TP4056 OUT+ / OUT−</a:t>
-                      </a:r>
-                      <a:endParaRPr lang="en-US" sz="1150" dirty="0">
-                        <a:latin typeface="Calibri" charset="0"/>
-                        <a:ea typeface="Calibri" charset="0"/>
-                        <a:cs typeface="Calibri" charset="0"/>
-                      </a:endParaRPr>
-                    </a:p>
-                  </a:txBody>
-                  <a:tcPr marL="91440" marR="91440" marT="45720" marB="45720" anchor="ctr">
-                    <a:lnL w="12700" cap="flat" cmpd="sng" algn="ctr">
-                      <a:solidFill>
-                        <a:srgbClr val="DBE1EC"/>
-                      </a:solidFill>
-                      <a:prstDash val="solid"/>
-                      <a:round/>
-                      <a:headEnd type="none" w="med" len="med"/>
-                      <a:tailEnd type="none" w="med" len="med"/>
-                    </a:lnL>
-                    <a:lnR w="12700" cap="flat" cmpd="sng" algn="ctr">
-                      <a:solidFill>
-                        <a:srgbClr val="DBE1EC"/>
-                      </a:solidFill>
-                      <a:prstDash val="solid"/>
-                      <a:round/>
-                      <a:headEnd type="none" w="med" len="med"/>
-                      <a:tailEnd type="none" w="med" len="med"/>
-                    </a:lnR>
-                    <a:lnT w="12700" cap="flat" cmpd="sng" algn="ctr">
-                      <a:solidFill>
-                        <a:srgbClr val="DBE1EC"/>
-                      </a:solidFill>
-                      <a:prstDash val="solid"/>
-                      <a:round/>
-                      <a:headEnd type="none" w="med" len="med"/>
-                      <a:tailEnd type="none" w="med" len="med"/>
-                    </a:lnT>
-                    <a:lnB w="12700" cap="flat" cmpd="sng" algn="ctr">
-                      <a:solidFill>
-                        <a:srgbClr val="DBE1EC"/>
-                      </a:solidFill>
-                      <a:prstDash val="solid"/>
-                      <a:round/>
-                      <a:headEnd type="none" w="med" len="med"/>
-                      <a:tailEnd type="none" w="med" len="med"/>
-                    </a:lnB>
-                  </a:tcPr>
-                </a:tc>
-                <a:tc>
-                  <a:txBody>
-                    <a:bodyPr/>
-                    <a:lstStyle/>
-                    <a:p>
-                      <a:pPr indent="0" marL="0">
-                        <a:buNone/>
-                      </a:pPr>
-                      <a:r>
-                        <a:rPr lang="en-US" sz="1150" dirty="0">
-                          <a:solidFill>
-                            <a:srgbClr val="141A26"/>
-                          </a:solidFill>
-                          <a:latin typeface="Calibri" pitchFamily="34" charset="0"/>
-                          <a:ea typeface="Calibri" pitchFamily="34" charset="-122"/>
-                          <a:cs typeface="Calibri" pitchFamily="34" charset="-120"/>
-                        </a:rPr>
-                        <a:t>Regulator VIN / GND</a:t>
-                      </a:r>
-                      <a:endParaRPr lang="en-US" sz="1150" dirty="0">
-                        <a:latin typeface="Calibri" charset="0"/>
-                        <a:ea typeface="Calibri" charset="0"/>
-                        <a:cs typeface="Calibri" charset="0"/>
-                      </a:endParaRPr>
-                    </a:p>
-                  </a:txBody>
-                  <a:tcPr marL="91440" marR="91440" marT="45720" marB="45720" anchor="ctr">
-                    <a:lnL w="12700" cap="flat" cmpd="sng" algn="ctr">
-                      <a:solidFill>
-                        <a:srgbClr val="DBE1EC"/>
-                      </a:solidFill>
-                      <a:prstDash val="solid"/>
-                      <a:round/>
-                      <a:headEnd type="none" w="med" len="med"/>
-                      <a:tailEnd type="none" w="med" len="med"/>
-                    </a:lnL>
-                    <a:lnR w="12700" cap="flat" cmpd="sng" algn="ctr">
-                      <a:solidFill>
-                        <a:srgbClr val="DBE1EC"/>
-                      </a:solidFill>
-                      <a:prstDash val="solid"/>
-                      <a:round/>
-                      <a:headEnd type="none" w="med" len="med"/>
-                      <a:tailEnd type="none" w="med" len="med"/>
-                    </a:lnR>
-                    <a:lnT w="12700" cap="flat" cmpd="sng" algn="ctr">
-                      <a:solidFill>
-                        <a:srgbClr val="DBE1EC"/>
-                      </a:solidFill>
-                      <a:prstDash val="solid"/>
-                      <a:round/>
-                      <a:headEnd type="none" w="med" len="med"/>
-                      <a:tailEnd type="none" w="med" len="med"/>
-                    </a:lnT>
-                    <a:lnB w="12700" cap="flat" cmpd="sng" algn="ctr">
-                      <a:solidFill>
-                        <a:srgbClr val="DBE1EC"/>
-                      </a:solidFill>
-                      <a:prstDash val="solid"/>
-                      <a:round/>
-                      <a:headEnd type="none" w="med" len="med"/>
-                      <a:tailEnd type="none" w="med" len="med"/>
-                    </a:lnB>
-                  </a:tcPr>
-                </a:tc>
-                <a:tc>
-                  <a:txBody>
-                    <a:bodyPr/>
-                    <a:lstStyle/>
-                    <a:p>
-                      <a:pPr indent="0" marL="0">
-                        <a:buNone/>
-                      </a:pPr>
-                      <a:r>
-                        <a:rPr lang="en-US" sz="1150" dirty="0">
-                          <a:solidFill>
-                            <a:srgbClr val="141A26"/>
-                          </a:solidFill>
-                          <a:latin typeface="Calibri" pitchFamily="34" charset="0"/>
-                          <a:ea typeface="Calibri" pitchFamily="34" charset="-122"/>
-                          <a:cs typeface="Calibri" pitchFamily="34" charset="-120"/>
-                        </a:rPr>
-                        <a:t>TPS63020 3.3 V</a:t>
-                      </a:r>
-                      <a:endParaRPr lang="en-US" sz="1150" dirty="0">
-                        <a:latin typeface="Calibri" charset="0"/>
-                        <a:ea typeface="Calibri" charset="0"/>
-                        <a:cs typeface="Calibri" charset="0"/>
-                      </a:endParaRPr>
-                    </a:p>
-                  </a:txBody>
-                  <a:tcPr marL="91440" marR="91440" marT="45720" marB="45720" anchor="ctr">
-                    <a:lnL w="12700" cap="flat" cmpd="sng" algn="ctr">
-                      <a:solidFill>
-                        <a:srgbClr val="DBE1EC"/>
-                      </a:solidFill>
-                      <a:prstDash val="solid"/>
-                      <a:round/>
-                      <a:headEnd type="none" w="med" len="med"/>
-                      <a:tailEnd type="none" w="med" len="med"/>
-                    </a:lnL>
-                    <a:lnR w="12700" cap="flat" cmpd="sng" algn="ctr">
-                      <a:solidFill>
-                        <a:srgbClr val="DBE1EC"/>
-                      </a:solidFill>
-                      <a:prstDash val="solid"/>
-                      <a:round/>
-                      <a:headEnd type="none" w="med" len="med"/>
-                      <a:tailEnd type="none" w="med" len="med"/>
-                    </a:lnR>
-                    <a:lnT w="12700" cap="flat" cmpd="sng" algn="ctr">
-                      <a:solidFill>
-                        <a:srgbClr val="DBE1EC"/>
-                      </a:solidFill>
-                      <a:prstDash val="solid"/>
-                      <a:round/>
-                      <a:headEnd type="none" w="med" len="med"/>
-                      <a:tailEnd type="none" w="med" len="med"/>
-                    </a:lnT>
-                    <a:lnB w="12700" cap="flat" cmpd="sng" algn="ctr">
-                      <a:solidFill>
-                        <a:srgbClr val="DBE1EC"/>
-                      </a:solidFill>
-                      <a:prstDash val="solid"/>
-                      <a:round/>
-                      <a:headEnd type="none" w="med" len="med"/>
-                      <a:tailEnd type="none" w="med" len="med"/>
-                    </a:lnB>
-                  </a:tcPr>
-                </a:tc>
-              </a:tr>
-              <a:tr h="384048">
-                <a:tc>
-                  <a:txBody>
-                    <a:bodyPr/>
-                    <a:lstStyle/>
-                    <a:p>
-                      <a:pPr indent="0" marL="0">
-                        <a:buNone/>
-                      </a:pPr>
-                      <a:r>
-                        <a:rPr lang="en-US" sz="1150" dirty="0">
-                          <a:solidFill>
-                            <a:srgbClr val="141A26"/>
-                          </a:solidFill>
-                          <a:latin typeface="Calibri" pitchFamily="34" charset="0"/>
-                          <a:ea typeface="Calibri" pitchFamily="34" charset="-122"/>
-                          <a:cs typeface="Calibri" pitchFamily="34" charset="-120"/>
-                        </a:rPr>
-                        <a:t>Regulator VOUT</a:t>
-                      </a:r>
-                      <a:endParaRPr lang="en-US" sz="1150" dirty="0">
-                        <a:latin typeface="Calibri" charset="0"/>
-                        <a:ea typeface="Calibri" charset="0"/>
-                        <a:cs typeface="Calibri" charset="0"/>
-                      </a:endParaRPr>
-                    </a:p>
-                  </a:txBody>
-                  <a:tcPr marL="91440" marR="91440" marT="45720" marB="45720" anchor="ctr">
-                    <a:lnL w="12700" cap="flat" cmpd="sng" algn="ctr">
-                      <a:solidFill>
-                        <a:srgbClr val="DBE1EC"/>
-                      </a:solidFill>
-                      <a:prstDash val="solid"/>
-                      <a:round/>
-                      <a:headEnd type="none" w="med" len="med"/>
-                      <a:tailEnd type="none" w="med" len="med"/>
-                    </a:lnL>
-                    <a:lnR w="12700" cap="flat" cmpd="sng" algn="ctr">
-                      <a:solidFill>
-                        <a:srgbClr val="DBE1EC"/>
-                      </a:solidFill>
-                      <a:prstDash val="solid"/>
-                      <a:round/>
-                      <a:headEnd type="none" w="med" len="med"/>
-                      <a:tailEnd type="none" w="med" len="med"/>
-                    </a:lnR>
-                    <a:lnT w="12700" cap="flat" cmpd="sng" algn="ctr">
-                      <a:solidFill>
-                        <a:srgbClr val="DBE1EC"/>
-                      </a:solidFill>
-                      <a:prstDash val="solid"/>
-                      <a:round/>
-                      <a:headEnd type="none" w="med" len="med"/>
-                      <a:tailEnd type="none" w="med" len="med"/>
-                    </a:lnT>
-                    <a:lnB w="12700" cap="flat" cmpd="sng" algn="ctr">
-                      <a:solidFill>
-                        <a:srgbClr val="DBE1EC"/>
-                      </a:solidFill>
-                      <a:prstDash val="solid"/>
-                      <a:round/>
-                      <a:headEnd type="none" w="med" len="med"/>
-                      <a:tailEnd type="none" w="med" len="med"/>
-                    </a:lnB>
-                  </a:tcPr>
-                </a:tc>
-                <a:tc>
-                  <a:txBody>
-                    <a:bodyPr/>
-                    <a:lstStyle/>
-                    <a:p>
-                      <a:pPr indent="0" marL="0">
-                        <a:buNone/>
-                      </a:pPr>
-                      <a:r>
-                        <a:rPr lang="en-US" sz="1150" dirty="0">
-                          <a:solidFill>
-                            <a:srgbClr val="141A26"/>
-                          </a:solidFill>
-                          <a:latin typeface="Calibri" pitchFamily="34" charset="0"/>
-                          <a:ea typeface="Calibri" pitchFamily="34" charset="-122"/>
-                          <a:cs typeface="Calibri" pitchFamily="34" charset="-120"/>
-                        </a:rPr>
-                        <a:t>3V3</a:t>
-                      </a:r>
-                      <a:endParaRPr lang="en-US" sz="1150" dirty="0">
-                        <a:latin typeface="Calibri" charset="0"/>
-                        <a:ea typeface="Calibri" charset="0"/>
-                        <a:cs typeface="Calibri" charset="0"/>
-                      </a:endParaRPr>
-                    </a:p>
-                  </a:txBody>
-                  <a:tcPr marL="91440" marR="91440" marT="45720" marB="45720" anchor="ctr">
-                    <a:lnL w="12700" cap="flat" cmpd="sng" algn="ctr">
-                      <a:solidFill>
-                        <a:srgbClr val="DBE1EC"/>
-                      </a:solidFill>
-                      <a:prstDash val="solid"/>
-                      <a:round/>
-                      <a:headEnd type="none" w="med" len="med"/>
-                      <a:tailEnd type="none" w="med" len="med"/>
-                    </a:lnL>
-                    <a:lnR w="12700" cap="flat" cmpd="sng" algn="ctr">
-                      <a:solidFill>
-                        <a:srgbClr val="DBE1EC"/>
-                      </a:solidFill>
-                      <a:prstDash val="solid"/>
-                      <a:round/>
-                      <a:headEnd type="none" w="med" len="med"/>
-                      <a:tailEnd type="none" w="med" len="med"/>
-                    </a:lnR>
-                    <a:lnT w="12700" cap="flat" cmpd="sng" algn="ctr">
-                      <a:solidFill>
-                        <a:srgbClr val="DBE1EC"/>
-                      </a:solidFill>
-                      <a:prstDash val="solid"/>
-                      <a:round/>
-                      <a:headEnd type="none" w="med" len="med"/>
-                      <a:tailEnd type="none" w="med" len="med"/>
-                    </a:lnT>
-                    <a:lnB w="12700" cap="flat" cmpd="sng" algn="ctr">
-                      <a:solidFill>
-                        <a:srgbClr val="DBE1EC"/>
-                      </a:solidFill>
-                      <a:prstDash val="solid"/>
-                      <a:round/>
-                      <a:headEnd type="none" w="med" len="med"/>
-                      <a:tailEnd type="none" w="med" len="med"/>
-                    </a:lnB>
-                  </a:tcPr>
-                </a:tc>
-                <a:tc>
-                  <a:txBody>
-                    <a:bodyPr/>
-                    <a:lstStyle/>
-                    <a:p>
-                      <a:pPr indent="0" marL="0">
-                        <a:buNone/>
-                      </a:pPr>
-                      <a:r>
-                        <a:rPr lang="en-US" sz="1150" dirty="0">
-                          <a:solidFill>
-                            <a:srgbClr val="141A26"/>
-                          </a:solidFill>
-                          <a:latin typeface="Calibri" pitchFamily="34" charset="0"/>
-                          <a:ea typeface="Calibri" pitchFamily="34" charset="-122"/>
-                          <a:cs typeface="Calibri" pitchFamily="34" charset="-120"/>
-                        </a:rPr>
-                        <a:t>steady 3.3 V</a:t>
-                      </a:r>
-                      <a:endParaRPr lang="en-US" sz="1150" dirty="0">
-                        <a:latin typeface="Calibri" charset="0"/>
-                        <a:ea typeface="Calibri" charset="0"/>
-                        <a:cs typeface="Calibri" charset="0"/>
-                      </a:endParaRPr>
-                    </a:p>
-                  </a:txBody>
-                  <a:tcPr marL="91440" marR="91440" marT="45720" marB="45720" anchor="ctr">
-                    <a:lnL w="12700" cap="flat" cmpd="sng" algn="ctr">
-                      <a:solidFill>
-                        <a:srgbClr val="DBE1EC"/>
-                      </a:solidFill>
-                      <a:prstDash val="solid"/>
-                      <a:round/>
-                      <a:headEnd type="none" w="med" len="med"/>
-                      <a:tailEnd type="none" w="med" len="med"/>
-                    </a:lnL>
-                    <a:lnR w="12700" cap="flat" cmpd="sng" algn="ctr">
-                      <a:solidFill>
-                        <a:srgbClr val="DBE1EC"/>
-                      </a:solidFill>
-                      <a:prstDash val="solid"/>
-                      <a:round/>
-                      <a:headEnd type="none" w="med" len="med"/>
-                      <a:tailEnd type="none" w="med" len="med"/>
-                    </a:lnR>
-                    <a:lnT w="12700" cap="flat" cmpd="sng" algn="ctr">
-                      <a:solidFill>
-                        <a:srgbClr val="DBE1EC"/>
-                      </a:solidFill>
-                      <a:prstDash val="solid"/>
-                      <a:round/>
-                      <a:headEnd type="none" w="med" len="med"/>
-                      <a:tailEnd type="none" w="med" len="med"/>
-                    </a:lnT>
-                    <a:lnB w="12700" cap="flat" cmpd="sng" algn="ctr">
-                      <a:solidFill>
-                        <a:srgbClr val="DBE1EC"/>
-                      </a:solidFill>
-                      <a:prstDash val="solid"/>
-                      <a:round/>
-                      <a:headEnd type="none" w="med" len="med"/>
-                      <a:tailEnd type="none" w="med" len="med"/>
-                    </a:lnB>
-                  </a:tcPr>
-                </a:tc>
-              </a:tr>
-              <a:tr h="384048">
-                <a:tc>
-                  <a:txBody>
-                    <a:bodyPr/>
-                    <a:lstStyle/>
-                    <a:p>
-                      <a:pPr indent="0" marL="0">
-                        <a:buNone/>
-                      </a:pPr>
-                      <a:r>
-                        <a:rPr lang="en-US" sz="1150" dirty="0">
-                          <a:solidFill>
-                            <a:srgbClr val="141A26"/>
-                          </a:solidFill>
-                          <a:latin typeface="Calibri" pitchFamily="34" charset="0"/>
-                          <a:ea typeface="Calibri" pitchFamily="34" charset="-122"/>
-                          <a:cs typeface="Calibri" pitchFamily="34" charset="-120"/>
-                        </a:rPr>
-                        <a:t>Battery divider (2 × 100 kΩ)</a:t>
-                      </a:r>
-                      <a:endParaRPr lang="en-US" sz="1150" dirty="0">
-                        <a:latin typeface="Calibri" charset="0"/>
-                        <a:ea typeface="Calibri" charset="0"/>
-                        <a:cs typeface="Calibri" charset="0"/>
-                      </a:endParaRPr>
-                    </a:p>
-                  </a:txBody>
-                  <a:tcPr marL="91440" marR="91440" marT="45720" marB="45720" anchor="ctr">
-                    <a:lnL w="12700" cap="flat" cmpd="sng" algn="ctr">
-                      <a:solidFill>
-                        <a:srgbClr val="DBE1EC"/>
-                      </a:solidFill>
-                      <a:prstDash val="solid"/>
-                      <a:round/>
-                      <a:headEnd type="none" w="med" len="med"/>
-                      <a:tailEnd type="none" w="med" len="med"/>
-                    </a:lnL>
-                    <a:lnR w="12700" cap="flat" cmpd="sng" algn="ctr">
-                      <a:solidFill>
-                        <a:srgbClr val="DBE1EC"/>
-                      </a:solidFill>
-                      <a:prstDash val="solid"/>
-                      <a:round/>
-                      <a:headEnd type="none" w="med" len="med"/>
-                      <a:tailEnd type="none" w="med" len="med"/>
-                    </a:lnR>
-                    <a:lnT w="12700" cap="flat" cmpd="sng" algn="ctr">
-                      <a:solidFill>
-                        <a:srgbClr val="DBE1EC"/>
-                      </a:solidFill>
-                      <a:prstDash val="solid"/>
-                      <a:round/>
-                      <a:headEnd type="none" w="med" len="med"/>
-                      <a:tailEnd type="none" w="med" len="med"/>
-                    </a:lnT>
-                    <a:lnB w="12700" cap="flat" cmpd="sng" algn="ctr">
-                      <a:solidFill>
-                        <a:srgbClr val="DBE1EC"/>
-                      </a:solidFill>
-                      <a:prstDash val="solid"/>
-                      <a:round/>
-                      <a:headEnd type="none" w="med" len="med"/>
-                      <a:tailEnd type="none" w="med" len="med"/>
-                    </a:lnB>
-                  </a:tcPr>
-                </a:tc>
-                <a:tc>
-                  <a:txBody>
-                    <a:bodyPr/>
-                    <a:lstStyle/>
-                    <a:p>
-                      <a:pPr indent="0" marL="0">
-                        <a:buNone/>
-                      </a:pPr>
-                      <a:r>
-                        <a:rPr lang="en-US" sz="1150" dirty="0">
-                          <a:solidFill>
-                            <a:srgbClr val="141A26"/>
-                          </a:solidFill>
-                          <a:latin typeface="Calibri" pitchFamily="34" charset="0"/>
-                          <a:ea typeface="Calibri" pitchFamily="34" charset="-122"/>
-                          <a:cs typeface="Calibri" pitchFamily="34" charset="-120"/>
-                        </a:rPr>
-                        <a:t>GPIO 34</a:t>
-                      </a:r>
-                      <a:endParaRPr lang="en-US" sz="1150" dirty="0">
-                        <a:latin typeface="Calibri" charset="0"/>
-                        <a:ea typeface="Calibri" charset="0"/>
-                        <a:cs typeface="Calibri" charset="0"/>
-                      </a:endParaRPr>
-                    </a:p>
-                  </a:txBody>
-                  <a:tcPr marL="91440" marR="91440" marT="45720" marB="45720" anchor="ctr">
-                    <a:lnL w="12700" cap="flat" cmpd="sng" algn="ctr">
-                      <a:solidFill>
-                        <a:srgbClr val="DBE1EC"/>
-                      </a:solidFill>
-                      <a:prstDash val="solid"/>
-                      <a:round/>
-                      <a:headEnd type="none" w="med" len="med"/>
-                      <a:tailEnd type="none" w="med" len="med"/>
-                    </a:lnL>
-                    <a:lnR w="12700" cap="flat" cmpd="sng" algn="ctr">
-                      <a:solidFill>
-                        <a:srgbClr val="DBE1EC"/>
-                      </a:solidFill>
-                      <a:prstDash val="solid"/>
-                      <a:round/>
-                      <a:headEnd type="none" w="med" len="med"/>
-                      <a:tailEnd type="none" w="med" len="med"/>
-                    </a:lnR>
-                    <a:lnT w="12700" cap="flat" cmpd="sng" algn="ctr">
-                      <a:solidFill>
-                        <a:srgbClr val="DBE1EC"/>
-                      </a:solidFill>
-                      <a:prstDash val="solid"/>
-                      <a:round/>
-                      <a:headEnd type="none" w="med" len="med"/>
-                      <a:tailEnd type="none" w="med" len="med"/>
-                    </a:lnT>
-                    <a:lnB w="12700" cap="flat" cmpd="sng" algn="ctr">
-                      <a:solidFill>
-                        <a:srgbClr val="DBE1EC"/>
-                      </a:solidFill>
-                      <a:prstDash val="solid"/>
-                      <a:round/>
-                      <a:headEnd type="none" w="med" len="med"/>
-                      <a:tailEnd type="none" w="med" len="med"/>
-                    </a:lnB>
-                  </a:tcPr>
-                </a:tc>
-                <a:tc>
-                  <a:txBody>
-                    <a:bodyPr/>
-                    <a:lstStyle/>
-                    <a:p>
-                      <a:pPr indent="0" marL="0">
-                        <a:buNone/>
-                      </a:pPr>
-                      <a:r>
-                        <a:rPr lang="en-US" sz="1150" dirty="0">
-                          <a:solidFill>
-                            <a:srgbClr val="141A26"/>
-                          </a:solidFill>
-                          <a:latin typeface="Calibri" pitchFamily="34" charset="0"/>
-                          <a:ea typeface="Calibri" pitchFamily="34" charset="-122"/>
-                          <a:cs typeface="Calibri" pitchFamily="34" charset="-120"/>
-                        </a:rPr>
-                        <a:t>battery %</a:t>
+                        <a:t>3 m cable to charger</a:t>
                       </a:r>
                       <a:endParaRPr lang="en-US" sz="1150" dirty="0">
                         <a:latin typeface="Calibri" charset="0"/>
@@ -11793,7 +10933,7 @@
       </p:graphicFrame>
       <p:pic>
         <p:nvPicPr>
-          <p:cNvPr id="7" name="Image 0" descr="/home/user/teetomivV2/science-fair/night-signal/slides/assets/3d_exploded.jpg">    </p:cNvPr>
+          <p:cNvPr id="7" name="Image 0" descr="/home/user/teetomivV2/science-fair/night-signal/slides/assets/wiring_v1.png">    </p:cNvPr>
           <p:cNvPicPr>
             <a:picLocks noChangeAspect="1"/>
           </p:cNvPicPr>
@@ -11807,6 +10947,30 @@
         </p:blipFill>
         <p:spPr>
           <a:xfrm>
+            <a:off x="1920240" y="4343400"/>
+            <a:ext cx="3566160" cy="2062358"/>
+          </a:xfrm>
+          <a:prstGeom prst="rect">
+            <a:avLst/>
+          </a:prstGeom>
+        </p:spPr>
+      </p:pic>
+      <p:pic>
+        <p:nvPicPr>
+          <p:cNvPr id="8" name="Image 1" descr="/home/user/teetomivV2/science-fair/night-signal/slides/assets/3d_exploded.jpg">    </p:cNvPr>
+          <p:cNvPicPr>
+            <a:picLocks noChangeAspect="1"/>
+          </p:cNvPicPr>
+          <p:nvPr/>
+        </p:nvPicPr>
+        <p:blipFill>
+          <a:blip r:embed="rId2"/>
+          <a:stretch>
+            <a:fillRect/>
+          </a:stretch>
+        </p:blipFill>
+        <p:spPr>
+          <a:xfrm>
             <a:off x="7040880" y="1463040"/>
             <a:ext cx="4480560" cy="3032779"/>
           </a:xfrm>
@@ -11817,7 +10981,7 @@
       </p:pic>
       <p:sp>
         <p:nvSpPr>
-          <p:cNvPr id="8" name="Text 4"/>
+          <p:cNvPr id="9" name="Text 4"/>
           <p:cNvSpPr txBox="1"/>
           <p:nvPr/>
         </p:nvSpPr>
@@ -11848,7 +11012,7 @@
                 <a:ea typeface="Calibri" pitchFamily="34" charset="-122"/>
                 <a:cs typeface="Calibri" pitchFamily="34" charset="-120"/>
               </a:rPr>
-              <a:t>Stack inside the 25 mm-tall case</a:t>
+              <a:t>v2: stack inside the 25 mm-tall case</a:t>
             </a:r>
             <a:endParaRPr lang="en-US" sz="1100" dirty="0"/>
           </a:p>
@@ -11856,7 +11020,7 @@
       </p:sp>
       <p:sp>
         <p:nvSpPr>
-          <p:cNvPr id="9" name="Text 5"/>
+          <p:cNvPr id="10" name="Text 5"/>
           <p:cNvSpPr txBox="1"/>
           <p:nvPr/>
         </p:nvSpPr>
@@ -11887,7 +11051,7 @@
                 <a:ea typeface="Calibri" pitchFamily="34" charset="-122"/>
                 <a:cs typeface="Calibri" pitchFamily="34" charset="-120"/>
               </a:rPr>
-              <a:t>Layer heights: battery 6 mm + ESP32 with pins ≈ 13 mm + GY-521 ≈ 3 mm ≈ 22 mm, inside the box’s 25 mm. Battery and TP4056 sit side by side on the bottom (35 + 17 = 52 mm of the 66 mm length).</a:t>
+              <a:t>Planned v2: a 70 × 45 × 29 mm box with its own battery. Layer heights: battery 6 mm + ESP32 with pins ≈ 13 mm + GY-521 ≈ 3 mm ≈ 22 mm, inside the box’s 25 mm. v1 uses each sensor’s own pins, so nothing needs splicing.</a:t>
             </a:r>
             <a:endParaRPr lang="en-US" sz="1200" dirty="0"/>
           </a:p>
@@ -15427,7 +14591,7 @@
                 <a:ea typeface="Calibri" pitchFamily="34" charset="-122"/>
                 <a:cs typeface="Calibri" pitchFamily="34" charset="-120"/>
               </a:rPr>
-              <a:t>Assembled — case on a velcro strap, cable to the finger clip</a:t>
+              <a:t>3D design (v2) — sealed case on a velcro strap</a:t>
             </a:r>
             <a:endParaRPr lang="en-US" sz="1100" dirty="0"/>
           </a:p>
@@ -15490,7 +14654,7 @@
                 <a:ea typeface="Calibri" pitchFamily="34" charset="-122"/>
                 <a:cs typeface="Calibri" pitchFamily="34" charset="-120"/>
               </a:rPr>
-              <a:t>Exploded — every part at its real size</a:t>
+              <a:t>Exploded — every v2 part at its real size</a:t>
             </a:r>
             <a:endParaRPr lang="en-US" sz="1100" dirty="0"/>
           </a:p>
@@ -15529,7 +14693,7 @@
                 <a:ea typeface="Calibri" pitchFamily="34" charset="-122"/>
                 <a:cs typeface="Calibri" pitchFamily="34" charset="-120"/>
               </a:rPr>
-              <a:t>70 × 45 × 29 mm</a:t>
+              <a:t>Prototype v1</a:t>
             </a:r>
             <a:endParaRPr lang="en-US" sz="2000" dirty="0"/>
           </a:p>
@@ -15568,7 +14732,7 @@
                 <a:ea typeface="Calibri" pitchFamily="34" charset="-122"/>
                 <a:cs typeface="Calibri" pitchFamily="34" charset="-120"/>
               </a:rPr>
-              <a:t>sensor case</a:t>
+              <a:t>armband + plug-in wires</a:t>
             </a:r>
             <a:endParaRPr lang="en-US" sz="1200" dirty="0"/>
           </a:p>
@@ -15607,7 +14771,7 @@
                 <a:ea typeface="Calibri" pitchFamily="34" charset="-122"/>
                 <a:cs typeface="Calibri" pitchFamily="34" charset="-120"/>
               </a:rPr>
-              <a:t>25 mm</a:t>
+              <a:t>All night</a:t>
             </a:r>
             <a:endParaRPr lang="en-US" sz="2000" dirty="0"/>
           </a:p>
@@ -15646,7 +14810,7 @@
                 <a:ea typeface="Calibri" pitchFamily="34" charset="-122"/>
                 <a:cs typeface="Calibri" pitchFamily="34" charset="-120"/>
               </a:rPr>
-              <a:t>velcro strap</a:t>
+              <a:t>USB power</a:t>
             </a:r>
             <a:endParaRPr lang="en-US" sz="1200" dirty="0"/>
           </a:p>
@@ -16194,7 +15358,7 @@
                 <a:ea typeface="Calibri" pitchFamily="34" charset="-122"/>
                 <a:cs typeface="Calibri" pitchFamily="34" charset="-120"/>
               </a:rPr>
-              <a:t>ESP32 in the case</a:t>
+              <a:t>ESP32 on the arm</a:t>
             </a:r>
             <a:endParaRPr lang="en-US" sz="1600" dirty="0"/>
           </a:p>
@@ -17537,7 +16701,7 @@
                 <a:ea typeface="Calibri" pitchFamily="34" charset="-122"/>
                 <a:cs typeface="Calibri" pitchFamily="34" charset="-120"/>
               </a:rPr>
-              <a:t>Battery runtime test  </a:t>
+              <a:t>Full-night power test  </a:t>
             </a:r>
             <a:pPr indent="0" marL="0">
               <a:buNone/>
@@ -17551,7 +16715,7 @@
                 <a:ea typeface="Calibri" pitchFamily="34" charset="-122"/>
                 <a:cs typeface="Calibri" pitchFamily="34" charset="-120"/>
               </a:rPr>
-              <a:t>full charge → stream until it stops, 3 times</a:t>
+              <a:t>USB power → 8 h of data with no gaps</a:t>
             </a:r>
             <a:endParaRPr lang="en-US" sz="1500" dirty="0"/>
           </a:p>
@@ -17665,7 +16829,7 @@
                 <a:ea typeface="Calibri" pitchFamily="34" charset="-122"/>
                 <a:cs typeface="Calibri" pitchFamily="34" charset="-120"/>
               </a:rPr>
-              <a:t>≥ 5 nights; case on upper arm, clip on index finger</a:t>
+              <a:t>≥ 5 nights; armband on forearm, clip on index finger</a:t>
             </a:r>
             <a:endParaRPr lang="en-US" sz="1500" dirty="0"/>
           </a:p>

</xml_diff>

<commit_message>
Apple-style charts to match the deck
- analysis/chart_style.py: one shared style (no chart box, light y-grid,
  grey axis text, left-aligned title + subtitle, labels on the lines,
  SF Pro / Helvetica Neue / Inter fallbacks, optional NS_FONT_DIR)
- analyze, validate, position, heart and asthma charts use it and are
  sized for the slides so their text stays readable when projected
- Regenerated slide assets, app screenshots, app and deck

Co-Authored-By: Claude Opus 5.5 <noreply@anthropic.com>
Claude-Session: https://claude.ai/code/session_01CxrUMy4UZKTNYh6kiz9919
</commit_message>
<xml_diff>
--- a/science-fair/night-signal/Night_Signal_Presentation.pptx
+++ b/science-fair/night-signal/Night_Signal_Presentation.pptx
@@ -3247,56 +3247,17 @@
         </p:blipFill>
         <p:spPr>
           <a:xfrm>
-            <a:off x="685800" y="1920240"/>
-            <a:ext cx="5303520" cy="3314700"/>
+            <a:off x="685800" y="1874520"/>
+            <a:ext cx="5120640" cy="3755136"/>
           </a:xfrm>
           <a:prstGeom prst="rect">
             <a:avLst/>
           </a:prstGeom>
         </p:spPr>
       </p:pic>
-      <p:sp>
-        <p:nvSpPr>
-          <p:cNvPr id="7" name="Text 4"/>
-          <p:cNvSpPr txBox="1"/>
-          <p:nvPr/>
-        </p:nvSpPr>
-        <p:spPr>
-          <a:xfrm>
-            <a:off x="685800" y="5308092"/>
-            <a:ext cx="5303520" cy="274320"/>
-          </a:xfrm>
-          <a:prstGeom prst="rect">
-            <a:avLst/>
-          </a:prstGeom>
-          <a:noFill/>
-          <a:ln/>
-        </p:spPr>
-        <p:txBody>
-          <a:bodyPr wrap="square" lIns="0" tIns="0" rIns="0" bIns="0" rtlCol="0" anchor="t"/>
-          <a:lstStyle/>
-          <a:p>
-            <a:pPr algn="ctr" indent="0" marL="0">
-              <a:buNone/>
-            </a:pPr>
-            <a:r>
-              <a:rPr lang="en-US" sz="1200" dirty="0">
-                <a:solidFill>
-                  <a:srgbClr val="6E6E73"/>
-                </a:solidFill>
-                <a:latin typeface="Helvetica Neue" pitchFamily="34" charset="0"/>
-                <a:ea typeface="Helvetica Neue" pitchFamily="34" charset="-122"/>
-                <a:cs typeface="Helvetica Neue" pitchFamily="34" charset="-120"/>
-              </a:rPr>
-              <a:t>Apnea events per hour by position</a:t>
-            </a:r>
-            <a:endParaRPr lang="en-US" sz="1200" dirty="0"/>
-          </a:p>
-        </p:txBody>
-      </p:sp>
       <p:graphicFrame>
         <p:nvGraphicFramePr>
-          <p:cNvPr id="8" name="Chart 0" descr=""/>
+          <p:cNvPr id="7" name="Chart 0" descr=""/>
           <p:cNvGraphicFramePr/>
           <p:nvPr/>
         </p:nvGraphicFramePr>
@@ -4770,7 +4731,7 @@
         <p:spPr>
           <a:xfrm>
             <a:off x="685800" y="1920240"/>
-            <a:ext cx="5312664" cy="2302154"/>
+            <a:ext cx="5312664" cy="2799918"/>
           </a:xfrm>
           <a:prstGeom prst="rect">
             <a:avLst/>
@@ -4794,7 +4755,7 @@
         <p:spPr>
           <a:xfrm>
             <a:off x="6190488" y="1920240"/>
-            <a:ext cx="5312664" cy="2302154"/>
+            <a:ext cx="5312664" cy="2799918"/>
           </a:xfrm>
           <a:prstGeom prst="rect">
             <a:avLst/>
@@ -4809,7 +4770,7 @@
         </p:nvSpPr>
         <p:spPr>
           <a:xfrm>
-            <a:off x="685800" y="4405274"/>
+            <a:off x="685800" y="4903038"/>
             <a:ext cx="5312664" cy="914400"/>
           </a:xfrm>
           <a:prstGeom prst="rect">
@@ -4862,7 +4823,7 @@
         </p:nvSpPr>
         <p:spPr>
           <a:xfrm>
-            <a:off x="6190488" y="4405274"/>
+            <a:off x="6190488" y="4903038"/>
             <a:ext cx="5312664" cy="914400"/>
           </a:xfrm>
           <a:prstGeom prst="rect">
@@ -17951,56 +17912,17 @@
         </p:blipFill>
         <p:spPr>
           <a:xfrm>
-            <a:off x="685800" y="1920240"/>
-            <a:ext cx="6355080" cy="2912745"/>
+            <a:off x="685800" y="1965960"/>
+            <a:ext cx="6355080" cy="3261159"/>
           </a:xfrm>
           <a:prstGeom prst="rect">
             <a:avLst/>
           </a:prstGeom>
         </p:spPr>
       </p:pic>
-      <p:sp>
-        <p:nvSpPr>
-          <p:cNvPr id="7" name="Text 4"/>
-          <p:cNvSpPr txBox="1"/>
-          <p:nvPr/>
-        </p:nvSpPr>
-        <p:spPr>
-          <a:xfrm>
-            <a:off x="685800" y="4942713"/>
-            <a:ext cx="6355080" cy="274320"/>
-          </a:xfrm>
-          <a:prstGeom prst="rect">
-            <a:avLst/>
-          </a:prstGeom>
-          <a:noFill/>
-          <a:ln/>
-        </p:spPr>
-        <p:txBody>
-          <a:bodyPr wrap="square" lIns="0" tIns="0" rIns="0" bIns="0" rtlCol="0" anchor="t"/>
-          <a:lstStyle/>
-          <a:p>
-            <a:pPr algn="ctr" indent="0" marL="0">
-              <a:buNone/>
-            </a:pPr>
-            <a:r>
-              <a:rPr lang="en-US" sz="1200" dirty="0">
-                <a:solidFill>
-                  <a:srgbClr val="6E6E73"/>
-                </a:solidFill>
-                <a:latin typeface="Helvetica Neue" pitchFamily="34" charset="0"/>
-                <a:ea typeface="Helvetica Neue" pitchFamily="34" charset="-122"/>
-                <a:cs typeface="Helvetica Neue" pitchFamily="34" charset="-120"/>
-              </a:rPr>
-              <a:t>One night: each red band is an apnea event found automatically</a:t>
-            </a:r>
-            <a:endParaRPr lang="en-US" sz="1200" dirty="0"/>
-          </a:p>
-        </p:txBody>
-      </p:sp>
       <p:pic>
         <p:nvPicPr>
-          <p:cNvPr id="8" name="Image 1" descr="/home/user/teetomivV2/science-fair/night-signal/slides/assets/validation.png">    </p:cNvPr>
+          <p:cNvPr id="7" name="Image 1" descr="/home/user/teetomivV2/science-fair/night-signal/slides/assets/validation.png">    </p:cNvPr>
           <p:cNvPicPr>
             <a:picLocks noChangeAspect="1"/>
           </p:cNvPicPr>
@@ -18014,8 +17936,8 @@
         </p:blipFill>
         <p:spPr>
           <a:xfrm>
-            <a:off x="7269480" y="1920240"/>
-            <a:ext cx="4233672" cy="2587244"/>
+            <a:off x="7269480" y="1965960"/>
+            <a:ext cx="4233672" cy="3065762"/>
           </a:xfrm>
           <a:prstGeom prst="rect">
             <a:avLst/>
@@ -18024,13 +17946,13 @@
       </p:pic>
       <p:sp>
         <p:nvSpPr>
-          <p:cNvPr id="9" name="Text 5"/>
-          <p:cNvSpPr txBox="1"/>
-          <p:nvPr/>
-        </p:nvSpPr>
-        <p:spPr>
-          <a:xfrm>
-            <a:off x="7269480" y="4617212"/>
+          <p:cNvPr id="8" name="Text 4"/>
+          <p:cNvSpPr txBox="1"/>
+          <p:nvPr/>
+        </p:nvSpPr>
+        <p:spPr>
+          <a:xfrm>
+            <a:off x="7269480" y="5168882"/>
             <a:ext cx="4233672" cy="274320"/>
           </a:xfrm>
           <a:prstGeom prst="rect">
@@ -18055,7 +17977,7 @@
                 <a:ea typeface="Helvetica Neue" pitchFamily="34" charset="-122"/>
                 <a:cs typeface="Helvetica Neue" pitchFamily="34" charset="-120"/>
               </a:rPr>
-              <a:t>Bland–Altman: 95% of readings within −1.5 to +1.7 %</a:t>
+              <a:t>95% of readings within −1.5 to +1.7 % of the reference</a:t>
             </a:r>
             <a:endParaRPr lang="en-US" sz="1200" dirty="0"/>
           </a:p>

</xml_diff>

<commit_message>
Public QR codes that open in Safari (GitHub Pages)
- QR codes and slide links now point to GitHub Pages copies of the app,
  the 3D model and the buy/build/connect page instead of private links
- slides/make_qr.py regenerates the codes (verified they decode)
- build-kit.html added so the build guide is reachable from a phone
- app links.json uses only public links; README and START HERE explain
  the one-time Settings > Pages switch; .nojekyll so files are served as-is

Co-Authored-By: Claude Opus 5.5 <noreply@anthropic.com>
Claude-Session: https://claude.ai/code/session_01CxrUMy4UZKTNYh6kiz9919
</commit_message>
<xml_diff>
--- a/science-fair/night-signal/Night_Signal_Presentation.pptx
+++ b/science-fair/night-signal/Night_Signal_Presentation.pptx
@@ -5362,7 +5362,7 @@
       <p:pic>
         <p:nvPicPr>
           <p:cNvPr id="15" name="Image 0" descr="/home/user/teetomivV2/science-fair/night-signal/slides/assets/qr_app.png">
-            <a:hlinkClick r:id="rId2" tooltip="https://claude.ai/artifact/KCkbwVKfmBhQoC9cxCn7qZ"/>
+            <a:hlinkClick r:id="rId2" tooltip="https://gabrielamamanestudent-wq.github.io/teetomivV2/science-fair/night-signal/app/"/>
           </p:cNvPr>
           <p:cNvPicPr>
             <a:picLocks noChangeAspect="1"/>
@@ -5410,7 +5410,7 @@
       <p:pic>
         <p:nvPicPr>
           <p:cNvPr id="17" name="Image 1" descr="/home/user/teetomivV2/science-fair/night-signal/slides/assets/qr_3d.png">
-            <a:hlinkClick r:id="rId4" tooltip="https://claude.ai/artifact/7wqAASJ8qWxBBKBuVHAqLt"/>
+            <a:hlinkClick r:id="rId4" tooltip="https://gabrielamamanestudent-wq.github.io/teetomivV2/science-fair/night-signal/app/3d.html"/>
           </p:cNvPr>
           <p:cNvPicPr>
             <a:picLocks noChangeAspect="1"/>
@@ -11045,7 +11045,7 @@
                 <a:latin typeface="Helvetica Neue" pitchFamily="34" charset="0"/>
                 <a:ea typeface="Helvetica Neue" pitchFamily="34" charset="-122"/>
                 <a:cs typeface="Helvetica Neue" pitchFamily="34" charset="-120"/>
-                <a:hlinkClick r:id="rId3" invalidUrl="" action="" tgtFrame="" tooltip="https://github.com/gabrielamamanestudent-wq/teetomivV2/blob/claude/science-fair-medical-project-7k0wk4/science-fair/night-signal/BUILD_GUIDE.md" history="1" highlightClick="0" endSnd="0">
+                <a:hlinkClick r:id="rId3" invalidUrl="" action="" tgtFrame="" tooltip="https://gabrielamamanestudent-wq.github.io/teetomivV2/science-fair/night-signal/build-kit.html" history="1" highlightClick="0" endSnd="0">
                   <a:extLst>
                     <a:ext uri="{A12FA001-AC4F-418D-AE19-62706E023703}">
                       <ahyp:hlinkClr xmlns:ahyp="http://schemas.microsoft.com/office/drawing/2018/hyperlinkcolor" val="tx"/>
@@ -13535,7 +13535,7 @@
       <p:pic>
         <p:nvPicPr>
           <p:cNvPr id="17" name="Image 2" descr="/home/user/teetomivV2/science-fair/night-signal/slides/assets/qr_3d.png">
-            <a:hlinkClick r:id="rId4" tooltip="https://claude.ai/artifact/7wqAASJ8qWxBBKBuVHAqLt"/>
+            <a:hlinkClick r:id="rId4" tooltip="https://gabrielamamanestudent-wq.github.io/teetomivV2/science-fair/night-signal/app/3d.html"/>
           </p:cNvPr>
           <p:cNvPicPr>
             <a:picLocks noChangeAspect="1"/>
@@ -13590,7 +13590,7 @@
                 <a:latin typeface="Helvetica Neue" pitchFamily="34" charset="0"/>
                 <a:ea typeface="Helvetica Neue" pitchFamily="34" charset="-122"/>
                 <a:cs typeface="Helvetica Neue" pitchFamily="34" charset="-120"/>
-                <a:hlinkClick r:id="rId5" invalidUrl="" action="" tgtFrame="" tooltip="https://claude.ai/artifact/7wqAASJ8qWxBBKBuVHAqLt" history="1" highlightClick="0" endSnd="0">
+                <a:hlinkClick r:id="rId5" invalidUrl="" action="" tgtFrame="" tooltip="https://gabrielamamanestudent-wq.github.io/teetomivV2/science-fair/night-signal/app/3d.html" history="1" highlightClick="0" endSnd="0">
                   <a:extLst>
                     <a:ext uri="{A12FA001-AC4F-418D-AE19-62706E023703}">
                       <ahyp:hlinkClr xmlns:ahyp="http://schemas.microsoft.com/office/drawing/2018/hyperlinkcolor" val="tx"/>
@@ -16226,7 +16226,7 @@
       <p:pic>
         <p:nvPicPr>
           <p:cNvPr id="19" name="Image 2" descr="/home/user/teetomivV2/science-fair/night-signal/slides/assets/qr_app.png">
-            <a:hlinkClick r:id="rId4" tooltip="https://claude.ai/artifact/KCkbwVKfmBhQoC9cxCn7qZ"/>
+            <a:hlinkClick r:id="rId4" tooltip="https://gabrielamamanestudent-wq.github.io/teetomivV2/science-fair/night-signal/app/"/>
           </p:cNvPr>
           <p:cNvPicPr>
             <a:picLocks noChangeAspect="1"/>
@@ -16281,7 +16281,7 @@
                 <a:latin typeface="Helvetica Neue" pitchFamily="34" charset="0"/>
                 <a:ea typeface="Helvetica Neue" pitchFamily="34" charset="-122"/>
                 <a:cs typeface="Helvetica Neue" pitchFamily="34" charset="-120"/>
-                <a:hlinkClick r:id="rId5" invalidUrl="" action="" tgtFrame="" tooltip="https://claude.ai/artifact/KCkbwVKfmBhQoC9cxCn7qZ" history="1" highlightClick="0" endSnd="0">
+                <a:hlinkClick r:id="rId5" invalidUrl="" action="" tgtFrame="" tooltip="https://gabrielamamanestudent-wq.github.io/teetomivV2/science-fair/night-signal/app/" history="1" highlightClick="0" endSnd="0">
                   <a:extLst>
                     <a:ext uri="{A12FA001-AC4F-418D-AE19-62706E023703}">
                       <ahyp:hlinkClr xmlns:ahyp="http://schemas.microsoft.com/office/drawing/2018/hyperlinkcolor" val="tx"/>

</xml_diff>

<commit_message>
Record Ms. Ireland's Oct 9 agreement to the revised scope
Ms. Ireland agreed to refocus on measurement accuracy and desaturation
detection and asked for a revised proposal. Update status wording across
the app, slides, proposal, ethics package, guides and review; add her
supervisor details from her email signature, the Technoscience
pre-questionnaire link and steps, and a draft cover email (not sent).
Fix the review PDF checklist formatting.

Co-Authored-By: Claude Opus 5.5 <noreply@anthropic.com>
Claude-Session: https://claude.ai/code/session_01CxrUMy4UZKTNYh6kiz9919
</commit_message>
<xml_diff>
--- a/science-fair/night-signal/Night_Signal_Presentation.pptx
+++ b/science-fair/night-signal/Night_Signal_Presentation.pptx
@@ -872,7 +872,7 @@
           <a:p>
             <a:r>
               <a:rPr lang="en-US" dirty="0"/>
-              <a:t>[0:35] To be clear about where the project stands: the design, firmware, analysis software, app and 3D model are done, and the software has been tested only on simulated data. Still pending are my teacher's approval of the revised scope, ethics approval and consent, building the prototype, and all of the real measurements.</a:t>
+              <a:t>[0:35] To be clear about where the project stands: the design, firmware, analysis software, app and 3D model are done, and the software has been tested only on simulated data. My teacher agreed to this revised scope on October ninth. Still pending are her review of the revised proposal, ethics approval and consent, building the prototype, and all of the real measurements.</a:t>
             </a:r>
             <a:endParaRPr lang="en-US" dirty="0"/>
           </a:p>
@@ -1840,7 +1840,7 @@
           <a:p>
             <a:r>
               <a:rPr lang="en-US" dirty="0"/>
-              <a:t>[0:50] This is my planned protocol. Nothing will be tested on anyone, including me, until my teacher approves the revised scope, the ethics committee approves, and consent is signed. The main test is accuracy: seated at rest, I wear my device on one finger and the reference oximeter on the other hand, and I record both oxygen and heart rate every two minutes for thirty minutes, over several sessions. Every reading must pass signal-quality checks. If approved, overnight recordings will measure signal quality and desaturation events, but those events cannot be verified because the reference oximeter does not record overnight. An optional breath-hold test, only if approved, would check whether short, awake dips are flagged; it does not test sleep apnea.</a:t>
+              <a:t>[0:50] This is my planned protocol. Nothing will be tested on anyone, including me, until my teacher accepts this revised proposal, the ethics committee approves, and consent is signed. The main test is accuracy: seated at rest, I wear my device on one finger and the reference oximeter on the other hand, and I record both oxygen and heart rate every two minutes for thirty minutes, over several sessions. Every reading must pass signal-quality checks. If approved, overnight recordings will measure signal quality and desaturation events, but those events cannot be verified because the reference oximeter does not record overnight. An optional breath-hold test, only if approved, would check whether short, awake dips are flagged; it does not test sleep apnea.</a:t>
             </a:r>
             <a:endParaRPr lang="en-US" dirty="0"/>
           </a:p>
@@ -5461,7 +5461,7 @@
                 <a:ea typeface="Helvetica Neue" pitchFamily="34" charset="-122"/>
                 <a:cs typeface="Helvetica Neue" pitchFamily="34" charset="-120"/>
               </a:rPr>
-              <a:t>Original proposal submitted (Sep 25); revised proposal and ethics package drafted</a:t>
+              <a:t>Scope revised with Ms. Ireland (Oct 9); revised proposal and ethics package drafted</a:t>
             </a:r>
             <a:endParaRPr lang="en-US" sz="1350" dirty="0"/>
           </a:p>
@@ -5559,7 +5559,7 @@
                 <a:ea typeface="Helvetica Neue" pitchFamily="34" charset="-122"/>
                 <a:cs typeface="Helvetica Neue" pitchFamily="34" charset="-120"/>
               </a:rPr>
-              <a:t>Ms. Ireland’s approval of the revised scope</a:t>
+              <a:t>Ms. Ireland’s review of the revised proposal</a:t>
             </a:r>
             <a:endParaRPr lang="en-US" sz="1350" dirty="0"/>
           </a:p>
@@ -9170,7 +9170,7 @@
                 <a:ea typeface="Helvetica Neue" pitchFamily="34" charset="-122"/>
                 <a:cs typeface="Helvetica Neue" pitchFamily="34" charset="-120"/>
               </a:rPr>
-              <a:t>Ms. Ireland approves the revised scope, the ethics committee approves, and informed consent is signed (participant and parent/guardian). No data is collected from anyone, including me, before all three.</a:t>
+              <a:t>Ms. Ireland accepts the revised proposal, the ethics committee approves, and informed consent is signed (participant and parent/guardian). No data is collected from anyone, including me, before all three.</a:t>
             </a:r>
             <a:endParaRPr lang="en-US" sz="1200" dirty="0"/>
           </a:p>

</xml_diff>